<commit_message>
Put Chinese names before scenario codes and technical abbreviations
</commit_message>
<xml_diff>
--- a/重點檔案/01_成果簡報.pptx
+++ b/重點檔案/01_成果簡報.pptx
@@ -2,42 +2,42 @@
 <file path=ppt/presentation.xml><?xml version="1.0" encoding="utf-8"?>
 <p:presentation xmlns:p="http://schemas.openxmlformats.org/presentationml/2006/main" embedTrueTypeFonts="1" saveSubsetFonts="0">
   <p:sldMasterIdLst>
-    <p:sldMasterId xmlns:r="http://schemas.openxmlformats.org/officeDocument/2006/relationships" id="2147483648" r:id="R18579d5630a74d69"/>
+    <p:sldMasterId xmlns:r="http://schemas.openxmlformats.org/officeDocument/2006/relationships" id="2147483648" r:id="R81922336bfae47f2"/>
   </p:sldMasterIdLst>
   <p:notesMasterIdLst>
-    <p:notesMasterId xmlns:r="http://schemas.openxmlformats.org/officeDocument/2006/relationships" r:id="Rf475f33c754447c2"/>
+    <p:notesMasterId xmlns:r="http://schemas.openxmlformats.org/officeDocument/2006/relationships" r:id="Rbbeb863bf31d4ffb"/>
   </p:notesMasterIdLst>
   <p:sldIdLst>
-    <p:sldId xmlns:r="http://schemas.openxmlformats.org/officeDocument/2006/relationships" id="256" r:id="Rc7f94b4e688d4f7c"/>
-    <p:sldId xmlns:r="http://schemas.openxmlformats.org/officeDocument/2006/relationships" id="257" r:id="R219732119e634ab6"/>
-    <p:sldId xmlns:r="http://schemas.openxmlformats.org/officeDocument/2006/relationships" id="258" r:id="R1af259136fd6480b"/>
-    <p:sldId xmlns:r="http://schemas.openxmlformats.org/officeDocument/2006/relationships" id="259" r:id="R453aed756d4b42a4"/>
-    <p:sldId xmlns:r="http://schemas.openxmlformats.org/officeDocument/2006/relationships" id="260" r:id="Ra1cb325cf01748b7"/>
-    <p:sldId xmlns:r="http://schemas.openxmlformats.org/officeDocument/2006/relationships" id="261" r:id="Rbcb00b8689c54e23"/>
-    <p:sldId xmlns:r="http://schemas.openxmlformats.org/officeDocument/2006/relationships" id="262" r:id="R0ba58f01f54043c4"/>
-    <p:sldId xmlns:r="http://schemas.openxmlformats.org/officeDocument/2006/relationships" id="263" r:id="Rd86cdc9744274e11"/>
-    <p:sldId xmlns:r="http://schemas.openxmlformats.org/officeDocument/2006/relationships" id="264" r:id="R1651043e0b74485d"/>
-    <p:sldId xmlns:r="http://schemas.openxmlformats.org/officeDocument/2006/relationships" id="265" r:id="Ra1be592f4ff04f2f"/>
-    <p:sldId xmlns:r="http://schemas.openxmlformats.org/officeDocument/2006/relationships" id="266" r:id="R80310bc39b4d4afa"/>
-    <p:sldId xmlns:r="http://schemas.openxmlformats.org/officeDocument/2006/relationships" id="267" r:id="R974da358a60d4aa2"/>
-    <p:sldId xmlns:r="http://schemas.openxmlformats.org/officeDocument/2006/relationships" id="268" r:id="R0875ab855c594c37"/>
-    <p:sldId xmlns:r="http://schemas.openxmlformats.org/officeDocument/2006/relationships" id="269" r:id="Rf6f539424202482c"/>
-    <p:sldId xmlns:r="http://schemas.openxmlformats.org/officeDocument/2006/relationships" id="270" r:id="Rd9c234f7c8ad4e07"/>
+    <p:sldId xmlns:r="http://schemas.openxmlformats.org/officeDocument/2006/relationships" id="256" r:id="R39b30d7673554fb0"/>
+    <p:sldId xmlns:r="http://schemas.openxmlformats.org/officeDocument/2006/relationships" id="257" r:id="R65d449fd8110474b"/>
+    <p:sldId xmlns:r="http://schemas.openxmlformats.org/officeDocument/2006/relationships" id="258" r:id="R2c24e6d2d03b4f72"/>
+    <p:sldId xmlns:r="http://schemas.openxmlformats.org/officeDocument/2006/relationships" id="259" r:id="R9a5b4ab625e84dca"/>
+    <p:sldId xmlns:r="http://schemas.openxmlformats.org/officeDocument/2006/relationships" id="260" r:id="R2d845fd5588c45c1"/>
+    <p:sldId xmlns:r="http://schemas.openxmlformats.org/officeDocument/2006/relationships" id="261" r:id="R294c191c0ffc41f4"/>
+    <p:sldId xmlns:r="http://schemas.openxmlformats.org/officeDocument/2006/relationships" id="262" r:id="Ra98335886c6f437a"/>
+    <p:sldId xmlns:r="http://schemas.openxmlformats.org/officeDocument/2006/relationships" id="263" r:id="R628c12c193b04e84"/>
+    <p:sldId xmlns:r="http://schemas.openxmlformats.org/officeDocument/2006/relationships" id="264" r:id="R56ba6732e25f4f39"/>
+    <p:sldId xmlns:r="http://schemas.openxmlformats.org/officeDocument/2006/relationships" id="265" r:id="Rcf45832590e14010"/>
+    <p:sldId xmlns:r="http://schemas.openxmlformats.org/officeDocument/2006/relationships" id="266" r:id="Rbc29604d5c194e9d"/>
+    <p:sldId xmlns:r="http://schemas.openxmlformats.org/officeDocument/2006/relationships" id="267" r:id="R90ab647fb0e84a09"/>
+    <p:sldId xmlns:r="http://schemas.openxmlformats.org/officeDocument/2006/relationships" id="268" r:id="Rc807a673ba0c4915"/>
+    <p:sldId xmlns:r="http://schemas.openxmlformats.org/officeDocument/2006/relationships" id="269" r:id="Ra22468954b6d4b74"/>
+    <p:sldId xmlns:r="http://schemas.openxmlformats.org/officeDocument/2006/relationships" id="270" r:id="Rd20ef3684ee747c5"/>
   </p:sldIdLst>
   <p:sldSz cx="18288000" cy="10287000"/>
   <p:notesSz cx="6858000" cy="9144000"/>
   <p:embeddedFontLst>
     <p:embeddedFont>
       <p:font typeface="Garet Bold"/>
-      <p:regular xmlns:r="http://schemas.openxmlformats.org/officeDocument/2006/relationships" r:id="R533b04373fe9473e"/>
+      <p:regular xmlns:r="http://schemas.openxmlformats.org/officeDocument/2006/relationships" r:id="Reb313f523b4b4faf"/>
     </p:embeddedFont>
     <p:embeddedFont>
       <p:font typeface="Garet"/>
-      <p:regular xmlns:r="http://schemas.openxmlformats.org/officeDocument/2006/relationships" r:id="R39b39ebb40e44600"/>
+      <p:regular xmlns:r="http://schemas.openxmlformats.org/officeDocument/2006/relationships" r:id="R2015ec024c674691"/>
     </p:embeddedFont>
     <p:embeddedFont>
       <p:font typeface="Poppins"/>
-      <p:regular xmlns:r="http://schemas.openxmlformats.org/officeDocument/2006/relationships" r:id="R40a9e10f629a4f3c"/>
+      <p:regular xmlns:r="http://schemas.openxmlformats.org/officeDocument/2006/relationships" r:id="Rc6bbcb77d0b245aa"/>
     </p:embeddedFont>
   </p:embeddedFontLst>
   <p:defaultTextStyle>
@@ -679,7 +679,7 @@
           <a:lstStyle xmlns:a="http://schemas.openxmlformats.org/drawingml/2006/main"/>
           <a:p xmlns:a="http://schemas.openxmlformats.org/drawingml/2006/main">
             <a:r>
-              <a:t>S1、各30次。P4 8公尺平均外包110.8箱，12m84.7箱，現有實驗不是支援/外包的獨立消融。P4 8公尺阻塞0.951% [0.783,1.118]；12m0.711% [0.565,0.856]。品質檢查單人40秒能力90/h，低於清洗期望115.2/h，單加第二台清洗P1仍阻塞3.944%。</a:t>
+              <a:t>短波尖峰情境（S1）、各30次。聯合改善（P4） 8公尺平均外包110.8箱，12m84.7箱，現有實驗不是支援/外包的獨立消融。聯合改善（P4） 8公尺阻塞0.951% [0.783,1.118]；12m0.711% [0.565,0.856]。品質檢查單人40秒能力90/h，低於清洗期望115.2/h，單加第二台清洗增設第二台清洗機（P1）仍阻塞3.944%。</a:t>
             </a:r>
           </a:p>
           <a:p xmlns:a="http://schemas.openxmlformats.org/drawingml/2006/main">
@@ -919,7 +919,7 @@
           <a:lstStyle xmlns:a="http://schemas.openxmlformats.org/drawingml/2006/main"/>
           <a:p xmlns:a="http://schemas.openxmlformats.org/drawingml/2006/main">
             <a:r>
-              <a:t>成本含箱攤提、剩餘帳面價值沖銷、清洗耗材、電力、外包與檢查前等待損失。365日年化以6日觀察推估，另列250日敏感度；不是實際年度帳務。12公尺五年8%NPV為-323,376元。若必須改善SLA，P4比P1少投資且營運成本較低，但與維持P0相比，直接財務效益不足以支持回收。</a:t>
+              <a:t>成本含箱攤提、剩餘帳面價值沖銷、清洗耗材、電力、外包與檢查前等待損失。365日年化以6日觀察推估，另列250日敏感度；不是實際年度帳務。12公尺五年8%NPV為-323,376元。若必須改善SLA，聯合改善（P4）比增設第二台清洗機（P1）少投資且營運成本較低，但與維持維持現況（P0）相比，直接財務效益不足以支持回收。</a:t>
             </a:r>
           </a:p>
           <a:p xmlns:a="http://schemas.openxmlformats.org/drawingml/2006/main">
@@ -1159,7 +1159,7 @@
           <a:lstStyle xmlns:a="http://schemas.openxmlformats.org/drawingml/2006/main"/>
           <a:p xmlns:a="http://schemas.openxmlformats.org/drawingml/2006/main">
             <a:r>
-              <a:t>所有方案使用同一模型的原生實驗比較。P4的效果不可全部歸因於人員支援，因為它也包含外包。三波各20分鐘，六日觀察需求量約為平日1.43倍；不是整週3.5倍。</a:t>
+              <a:t>所有方案使用同一模型的原生實驗比較。聯合改善（P4）含緩衝、人員支援與觸發式外包，效果不能全部歸因於人員。短波尖峰情境（S1）每天三波、每波20分鐘；不是整週需求都增加3.5倍。</a:t>
             </a:r>
           </a:p>
           <a:p xmlns:a="http://schemas.openxmlformats.org/drawingml/2006/main">
@@ -1559,7 +1559,7 @@
           <a:lstStyle xmlns:a="http://schemas.openxmlformats.org/drawingml/2006/main"/>
           <a:p xmlns:a="http://schemas.openxmlformats.org/drawingml/2006/main">
             <a:r>
-              <a:t>S1/P0無外包，按每次能耗/退貨量計算再取平均，0.184875145度電/件。1−E×0.495/0.35=73.853%。同口徑若剛好42%，E約0.410101度電/件；差異來自給定係數、能耗與基準。P4 12公尺的完整減碳信賴區間[73.966,74.023]%，下界亦大於42%；包含平均84.7箱外包及相應排放，不能只套電力公式。0.35與0.495為課程係數，未涵蓋完整箱製造與逆物流LCA。</a:t>
+              <a:t>短波尖峰情境（S1）/維持現況（P0）無外包，按每次能耗/退貨量計算再取平均，0.184875145度電/件。1−E×0.495/0.35=73.853%。同口徑若剛好42%，E約0.410101度電/件；差異來自給定係數、能耗與基準。聯合改善（P4） 12公尺的完整減碳信賴區間[73.966,74.023]%，下界亦大於42%；包含平均84.7箱外包及相應排放，不能只套電力公式。0.35與0.495為課程係數，未涵蓋完整箱製造與逆物流LCA。</a:t>
             </a:r>
           </a:p>
           <a:p xmlns:a="http://schemas.openxmlformats.org/drawingml/2006/main">
@@ -1639,7 +1639,7 @@
           <a:lstStyle xmlns:a="http://schemas.openxmlformats.org/drawingml/2006/main"/>
           <a:p xmlns:a="http://schemas.openxmlformats.org/drawingml/2006/main">
             <a:r>
-              <a:t>V3依批次前固定計畫，使用30次平均在製量時間剖面的迴歸，並完整保留個別重複的絕對漂移。S0 pooled漂移−0.20755%，S1 改善前為9.84335%，P4 12公尺為1.86592%。V5包含12項主要作業與財務績效指標；原始30次的精度不足仍是正式發現。</a:t>
+              <a:t>V3依批次前固定計畫，使用30次平均在製量時間剖面的迴歸，並完整保留個別重複的絕對漂移。平日基準情境（S0） pooled漂移−0.20755%，短波尖峰情境（S1） 改善前為9.84335%，聯合改善（P4） 12公尺為1.86592%。V5包含12項主要作業與財務績效指標；原始30次的精度不足仍是正式發現。</a:t>
             </a:r>
           </a:p>
           <a:p xmlns:a="http://schemas.openxmlformats.org/drawingml/2006/main">
@@ -1776,7 +1776,7 @@
           <p:cNvPr id="2" name="Title 1">
             <a:extLst xmlns:a="http://schemas.openxmlformats.org/drawingml/2006/main">
               <a:ext uri="{FF2B5EF4-FFF2-40B4-BE49-F238E27FC236}">
-                <a16:creationId xmlns:a16="http://schemas.microsoft.com/office/drawing/2014/main" id="{60AAF07D-6364-4DBB-849C-D3D6E7FB2AEE}"/>
+                <a16:creationId xmlns:a16="http://schemas.microsoft.com/office/drawing/2014/main" id="{75611A03-6432-4CF4-A33D-3C8C01767B57}"/>
               </a:ext>
             </a:extLst>
           </p:cNvPr>
@@ -1809,7 +1809,7 @@
           <p:cNvPr id="3" name="Subtitle 2">
             <a:extLst xmlns:a="http://schemas.openxmlformats.org/drawingml/2006/main">
               <a:ext uri="{FF2B5EF4-FFF2-40B4-BE49-F238E27FC236}">
-                <a16:creationId xmlns:a16="http://schemas.microsoft.com/office/drawing/2014/main" id="{BB96BAB8-8DF6-4363-B7EB-6357AC0755AE}"/>
+                <a16:creationId xmlns:a16="http://schemas.microsoft.com/office/drawing/2014/main" id="{E2320E25-4023-4028-934B-4090F3B433CB}"/>
               </a:ext>
             </a:extLst>
           </p:cNvPr>
@@ -1933,7 +1933,7 @@
           <p:cNvPr id="4" name="Date Placeholder 3">
             <a:extLst xmlns:a="http://schemas.openxmlformats.org/drawingml/2006/main">
               <a:ext uri="{FF2B5EF4-FFF2-40B4-BE49-F238E27FC236}">
-                <a16:creationId xmlns:a16="http://schemas.microsoft.com/office/drawing/2014/main" id="{ED1DFAB8-B381-4365-8BA9-AADDB5BCAC69}"/>
+                <a16:creationId xmlns:a16="http://schemas.microsoft.com/office/drawing/2014/main" id="{920FCB2A-051C-4AAF-A364-579AAC4A5F89}"/>
               </a:ext>
             </a:extLst>
           </p:cNvPr>
@@ -1961,7 +1961,7 @@
           <p:cNvPr id="5" name="Footer Placeholder 4">
             <a:extLst xmlns:a="http://schemas.openxmlformats.org/drawingml/2006/main">
               <a:ext uri="{FF2B5EF4-FFF2-40B4-BE49-F238E27FC236}">
-                <a16:creationId xmlns:a16="http://schemas.microsoft.com/office/drawing/2014/main" id="{EDCFE6B8-D071-42C0-B3DA-51E3AB0D2F0B}"/>
+                <a16:creationId xmlns:a16="http://schemas.microsoft.com/office/drawing/2014/main" id="{05E7525D-9480-4064-90EF-34016703EE36}"/>
               </a:ext>
             </a:extLst>
           </p:cNvPr>
@@ -1986,7 +1986,7 @@
           <p:cNvPr id="6" name="Slide Number Placeholder 5">
             <a:extLst xmlns:a="http://schemas.openxmlformats.org/drawingml/2006/main">
               <a:ext uri="{FF2B5EF4-FFF2-40B4-BE49-F238E27FC236}">
-                <a16:creationId xmlns:a16="http://schemas.microsoft.com/office/drawing/2014/main" id="{7AEE314B-925E-46C3-BFFE-5D17713F49C6}"/>
+                <a16:creationId xmlns:a16="http://schemas.microsoft.com/office/drawing/2014/main" id="{71550E44-7BBA-4740-B054-0668BF9005E6}"/>
               </a:ext>
             </a:extLst>
           </p:cNvPr>
@@ -2031,7 +2031,7 @@
           <p:cNvPr id="2" name="Title 1">
             <a:extLst xmlns:a="http://schemas.openxmlformats.org/drawingml/2006/main">
               <a:ext uri="{FF2B5EF4-FFF2-40B4-BE49-F238E27FC236}">
-                <a16:creationId xmlns:a16="http://schemas.microsoft.com/office/drawing/2014/main" id="{32AEE945-C4F4-429A-BB77-8E9F444CCCC7}"/>
+                <a16:creationId xmlns:a16="http://schemas.microsoft.com/office/drawing/2014/main" id="{47F13565-6321-4A6C-A12B-DABBBBD65882}"/>
               </a:ext>
             </a:extLst>
           </p:cNvPr>
@@ -2059,7 +2059,7 @@
           <p:cNvPr id="3" name="Vertical Text Placeholder 2">
             <a:extLst xmlns:a="http://schemas.openxmlformats.org/drawingml/2006/main">
               <a:ext uri="{FF2B5EF4-FFF2-40B4-BE49-F238E27FC236}">
-                <a16:creationId xmlns:a16="http://schemas.microsoft.com/office/drawing/2014/main" id="{8B9FB5EF-2779-449A-92A6-C26F06A61F54}"/>
+                <a16:creationId xmlns:a16="http://schemas.microsoft.com/office/drawing/2014/main" id="{E40B18B2-998D-4938-88F3-78980833ADE0}"/>
               </a:ext>
             </a:extLst>
           </p:cNvPr>
@@ -2122,7 +2122,7 @@
           <p:cNvPr id="4" name="Date Placeholder 3">
             <a:extLst xmlns:a="http://schemas.openxmlformats.org/drawingml/2006/main">
               <a:ext uri="{FF2B5EF4-FFF2-40B4-BE49-F238E27FC236}">
-                <a16:creationId xmlns:a16="http://schemas.microsoft.com/office/drawing/2014/main" id="{0D26E671-CDE6-4284-B2AD-4C4A45A0BF58}"/>
+                <a16:creationId xmlns:a16="http://schemas.microsoft.com/office/drawing/2014/main" id="{C311B3BE-DBE5-4775-B968-C1708A06831F}"/>
               </a:ext>
             </a:extLst>
           </p:cNvPr>
@@ -2150,7 +2150,7 @@
           <p:cNvPr id="5" name="Footer Placeholder 4">
             <a:extLst xmlns:a="http://schemas.openxmlformats.org/drawingml/2006/main">
               <a:ext uri="{FF2B5EF4-FFF2-40B4-BE49-F238E27FC236}">
-                <a16:creationId xmlns:a16="http://schemas.microsoft.com/office/drawing/2014/main" id="{F9FA5C33-375F-406F-B194-93D4A5125279}"/>
+                <a16:creationId xmlns:a16="http://schemas.microsoft.com/office/drawing/2014/main" id="{7416F8C2-9EA5-4F3E-B7A2-1FCC58062CD0}"/>
               </a:ext>
             </a:extLst>
           </p:cNvPr>
@@ -2175,7 +2175,7 @@
           <p:cNvPr id="6" name="Slide Number Placeholder 5">
             <a:extLst xmlns:a="http://schemas.openxmlformats.org/drawingml/2006/main">
               <a:ext uri="{FF2B5EF4-FFF2-40B4-BE49-F238E27FC236}">
-                <a16:creationId xmlns:a16="http://schemas.microsoft.com/office/drawing/2014/main" id="{D729844A-CB12-436B-ABF2-945E28186938}"/>
+                <a16:creationId xmlns:a16="http://schemas.microsoft.com/office/drawing/2014/main" id="{7DDD1C29-A33F-4682-9E40-11FE8A070AC0}"/>
               </a:ext>
             </a:extLst>
           </p:cNvPr>
@@ -2220,7 +2220,7 @@
           <p:cNvPr id="2" name="Vertical Title 1">
             <a:extLst xmlns:a="http://schemas.openxmlformats.org/drawingml/2006/main">
               <a:ext uri="{FF2B5EF4-FFF2-40B4-BE49-F238E27FC236}">
-                <a16:creationId xmlns:a16="http://schemas.microsoft.com/office/drawing/2014/main" id="{5DED8826-D2D4-4561-85CD-8DB8E16E9444}"/>
+                <a16:creationId xmlns:a16="http://schemas.microsoft.com/office/drawing/2014/main" id="{AA443A5A-84E5-4692-815D-514F943EE25B}"/>
               </a:ext>
             </a:extLst>
           </p:cNvPr>
@@ -2253,7 +2253,7 @@
           <p:cNvPr id="3" name="Vertical Text Placeholder 2">
             <a:extLst xmlns:a="http://schemas.openxmlformats.org/drawingml/2006/main">
               <a:ext uri="{FF2B5EF4-FFF2-40B4-BE49-F238E27FC236}">
-                <a16:creationId xmlns:a16="http://schemas.microsoft.com/office/drawing/2014/main" id="{A097CD4E-49FC-47DD-8AFD-84FD08565A3C}"/>
+                <a16:creationId xmlns:a16="http://schemas.microsoft.com/office/drawing/2014/main" id="{F696EA01-DAA3-492B-BD20-01C42ACA9256}"/>
               </a:ext>
             </a:extLst>
           </p:cNvPr>
@@ -2321,7 +2321,7 @@
           <p:cNvPr id="4" name="Date Placeholder 3">
             <a:extLst xmlns:a="http://schemas.openxmlformats.org/drawingml/2006/main">
               <a:ext uri="{FF2B5EF4-FFF2-40B4-BE49-F238E27FC236}">
-                <a16:creationId xmlns:a16="http://schemas.microsoft.com/office/drawing/2014/main" id="{707040ED-AD0F-4299-8F57-2F45AF0AC390}"/>
+                <a16:creationId xmlns:a16="http://schemas.microsoft.com/office/drawing/2014/main" id="{339AEBBC-34CD-44C7-9FD3-E6E5B74509B5}"/>
               </a:ext>
             </a:extLst>
           </p:cNvPr>
@@ -2349,7 +2349,7 @@
           <p:cNvPr id="5" name="Footer Placeholder 4">
             <a:extLst xmlns:a="http://schemas.openxmlformats.org/drawingml/2006/main">
               <a:ext uri="{FF2B5EF4-FFF2-40B4-BE49-F238E27FC236}">
-                <a16:creationId xmlns:a16="http://schemas.microsoft.com/office/drawing/2014/main" id="{3BBBB6DE-D8BD-4029-B1C9-AA6128C1D938}"/>
+                <a16:creationId xmlns:a16="http://schemas.microsoft.com/office/drawing/2014/main" id="{FA124AE0-9AB9-4CFC-86FA-F426A031C33A}"/>
               </a:ext>
             </a:extLst>
           </p:cNvPr>
@@ -2374,7 +2374,7 @@
           <p:cNvPr id="6" name="Slide Number Placeholder 5">
             <a:extLst xmlns:a="http://schemas.openxmlformats.org/drawingml/2006/main">
               <a:ext uri="{FF2B5EF4-FFF2-40B4-BE49-F238E27FC236}">
-                <a16:creationId xmlns:a16="http://schemas.microsoft.com/office/drawing/2014/main" id="{9834859B-E781-41B0-8498-7B1306E3784D}"/>
+                <a16:creationId xmlns:a16="http://schemas.microsoft.com/office/drawing/2014/main" id="{E1F4B61A-5B2A-4DC0-A0B3-592B1B599F57}"/>
               </a:ext>
             </a:extLst>
           </p:cNvPr>
@@ -2419,7 +2419,7 @@
           <p:cNvPr id="2" name="Title 1">
             <a:extLst xmlns:a="http://schemas.openxmlformats.org/drawingml/2006/main">
               <a:ext uri="{FF2B5EF4-FFF2-40B4-BE49-F238E27FC236}">
-                <a16:creationId xmlns:a16="http://schemas.microsoft.com/office/drawing/2014/main" id="{D828A8B1-B652-43B3-AA1D-A0621EB9F5F4}"/>
+                <a16:creationId xmlns:a16="http://schemas.microsoft.com/office/drawing/2014/main" id="{081FDFEA-1D76-4898-BAB4-12AC97B36692}"/>
               </a:ext>
             </a:extLst>
           </p:cNvPr>
@@ -2447,7 +2447,7 @@
           <p:cNvPr id="3" name="Content Placeholder 2">
             <a:extLst xmlns:a="http://schemas.openxmlformats.org/drawingml/2006/main">
               <a:ext uri="{FF2B5EF4-FFF2-40B4-BE49-F238E27FC236}">
-                <a16:creationId xmlns:a16="http://schemas.microsoft.com/office/drawing/2014/main" id="{9356AFC3-E8D0-4603-AD83-3FE3EFE7639E}"/>
+                <a16:creationId xmlns:a16="http://schemas.microsoft.com/office/drawing/2014/main" id="{F4AC1F04-3542-473D-88D8-6E439CDADBE9}"/>
               </a:ext>
             </a:extLst>
           </p:cNvPr>
@@ -2510,7 +2510,7 @@
           <p:cNvPr id="4" name="Date Placeholder 3">
             <a:extLst xmlns:a="http://schemas.openxmlformats.org/drawingml/2006/main">
               <a:ext uri="{FF2B5EF4-FFF2-40B4-BE49-F238E27FC236}">
-                <a16:creationId xmlns:a16="http://schemas.microsoft.com/office/drawing/2014/main" id="{4DB1F090-2363-4E5B-8CC8-1988C718928F}"/>
+                <a16:creationId xmlns:a16="http://schemas.microsoft.com/office/drawing/2014/main" id="{B8422028-17D8-4B9C-BB4A-CECA86C04FFA}"/>
               </a:ext>
             </a:extLst>
           </p:cNvPr>
@@ -2538,7 +2538,7 @@
           <p:cNvPr id="5" name="Footer Placeholder 4">
             <a:extLst xmlns:a="http://schemas.openxmlformats.org/drawingml/2006/main">
               <a:ext uri="{FF2B5EF4-FFF2-40B4-BE49-F238E27FC236}">
-                <a16:creationId xmlns:a16="http://schemas.microsoft.com/office/drawing/2014/main" id="{A618B71B-A2BB-41C6-828C-CD44E0424B9B}"/>
+                <a16:creationId xmlns:a16="http://schemas.microsoft.com/office/drawing/2014/main" id="{162C013A-ADD2-42B6-B32F-5EF2A6B53194}"/>
               </a:ext>
             </a:extLst>
           </p:cNvPr>
@@ -2563,7 +2563,7 @@
           <p:cNvPr id="6" name="Slide Number Placeholder 5">
             <a:extLst xmlns:a="http://schemas.openxmlformats.org/drawingml/2006/main">
               <a:ext uri="{FF2B5EF4-FFF2-40B4-BE49-F238E27FC236}">
-                <a16:creationId xmlns:a16="http://schemas.microsoft.com/office/drawing/2014/main" id="{4D229217-2BE8-4969-83DF-91BDA058BA0B}"/>
+                <a16:creationId xmlns:a16="http://schemas.microsoft.com/office/drawing/2014/main" id="{E2B04C45-F606-48C3-A1EA-56D626C62EED}"/>
               </a:ext>
             </a:extLst>
           </p:cNvPr>
@@ -2608,7 +2608,7 @@
           <p:cNvPr id="2" name="Title 1">
             <a:extLst xmlns:a="http://schemas.openxmlformats.org/drawingml/2006/main">
               <a:ext uri="{FF2B5EF4-FFF2-40B4-BE49-F238E27FC236}">
-                <a16:creationId xmlns:a16="http://schemas.microsoft.com/office/drawing/2014/main" id="{B301247E-6265-46EB-B042-D7DF871124FB}"/>
+                <a16:creationId xmlns:a16="http://schemas.microsoft.com/office/drawing/2014/main" id="{C5B09E22-298E-49E6-B662-2A985773939D}"/>
               </a:ext>
             </a:extLst>
           </p:cNvPr>
@@ -2646,7 +2646,7 @@
           <p:cNvPr id="3" name="Text Placeholder 2">
             <a:extLst xmlns:a="http://schemas.openxmlformats.org/drawingml/2006/main">
               <a:ext uri="{FF2B5EF4-FFF2-40B4-BE49-F238E27FC236}">
-                <a16:creationId xmlns:a16="http://schemas.microsoft.com/office/drawing/2014/main" id="{82B9AEF6-9C03-40C5-A2EE-4197EEB4FCAB}"/>
+                <a16:creationId xmlns:a16="http://schemas.microsoft.com/office/drawing/2014/main" id="{BDD508BF-1086-464A-9133-408A4849E229}"/>
               </a:ext>
             </a:extLst>
           </p:cNvPr>
@@ -2772,7 +2772,7 @@
           <p:cNvPr id="4" name="Date Placeholder 3">
             <a:extLst xmlns:a="http://schemas.openxmlformats.org/drawingml/2006/main">
               <a:ext uri="{FF2B5EF4-FFF2-40B4-BE49-F238E27FC236}">
-                <a16:creationId xmlns:a16="http://schemas.microsoft.com/office/drawing/2014/main" id="{00D16052-FC48-4A04-8568-57416ECBC64A}"/>
+                <a16:creationId xmlns:a16="http://schemas.microsoft.com/office/drawing/2014/main" id="{9DF35C86-CBED-462D-BDCE-B900B54746FB}"/>
               </a:ext>
             </a:extLst>
           </p:cNvPr>
@@ -2800,7 +2800,7 @@
           <p:cNvPr id="5" name="Footer Placeholder 4">
             <a:extLst xmlns:a="http://schemas.openxmlformats.org/drawingml/2006/main">
               <a:ext uri="{FF2B5EF4-FFF2-40B4-BE49-F238E27FC236}">
-                <a16:creationId xmlns:a16="http://schemas.microsoft.com/office/drawing/2014/main" id="{D9435F90-D516-4918-8DA1-456727A4C60C}"/>
+                <a16:creationId xmlns:a16="http://schemas.microsoft.com/office/drawing/2014/main" id="{8534D2D2-F0B8-4444-A445-5D935331D93B}"/>
               </a:ext>
             </a:extLst>
           </p:cNvPr>
@@ -2825,7 +2825,7 @@
           <p:cNvPr id="6" name="Slide Number Placeholder 5">
             <a:extLst xmlns:a="http://schemas.openxmlformats.org/drawingml/2006/main">
               <a:ext uri="{FF2B5EF4-FFF2-40B4-BE49-F238E27FC236}">
-                <a16:creationId xmlns:a16="http://schemas.microsoft.com/office/drawing/2014/main" id="{4C6E7816-B282-450F-AD26-2C74920E189F}"/>
+                <a16:creationId xmlns:a16="http://schemas.microsoft.com/office/drawing/2014/main" id="{E97AF52B-1CDE-4EFB-9505-798E5E0E2FDF}"/>
               </a:ext>
             </a:extLst>
           </p:cNvPr>
@@ -2870,7 +2870,7 @@
           <p:cNvPr id="2" name="Title 1">
             <a:extLst xmlns:a="http://schemas.openxmlformats.org/drawingml/2006/main">
               <a:ext uri="{FF2B5EF4-FFF2-40B4-BE49-F238E27FC236}">
-                <a16:creationId xmlns:a16="http://schemas.microsoft.com/office/drawing/2014/main" id="{AE626077-D5E5-410C-8707-A82256304791}"/>
+                <a16:creationId xmlns:a16="http://schemas.microsoft.com/office/drawing/2014/main" id="{54F35E30-4A82-4002-8AE9-C310537CEC56}"/>
               </a:ext>
             </a:extLst>
           </p:cNvPr>
@@ -2898,7 +2898,7 @@
           <p:cNvPr id="3" name="Content Placeholder 2">
             <a:extLst xmlns:a="http://schemas.openxmlformats.org/drawingml/2006/main">
               <a:ext uri="{FF2B5EF4-FFF2-40B4-BE49-F238E27FC236}">
-                <a16:creationId xmlns:a16="http://schemas.microsoft.com/office/drawing/2014/main" id="{E9A06E95-659D-4C50-A044-5617BBCEA644}"/>
+                <a16:creationId xmlns:a16="http://schemas.microsoft.com/office/drawing/2014/main" id="{1E877585-40E9-4D94-B2FE-1127F2B812DB}"/>
               </a:ext>
             </a:extLst>
           </p:cNvPr>
@@ -3003,7 +3003,7 @@
           <p:cNvPr id="4" name="Content Placeholder 3">
             <a:extLst xmlns:a="http://schemas.openxmlformats.org/drawingml/2006/main">
               <a:ext uri="{FF2B5EF4-FFF2-40B4-BE49-F238E27FC236}">
-                <a16:creationId xmlns:a16="http://schemas.microsoft.com/office/drawing/2014/main" id="{171639AA-00D3-49DA-BB35-D47DF77BBF9A}"/>
+                <a16:creationId xmlns:a16="http://schemas.microsoft.com/office/drawing/2014/main" id="{645EF75E-9F3B-4178-80B0-6E972C3A6B40}"/>
               </a:ext>
             </a:extLst>
           </p:cNvPr>
@@ -3108,7 +3108,7 @@
           <p:cNvPr id="5" name="Date Placeholder 4">
             <a:extLst xmlns:a="http://schemas.openxmlformats.org/drawingml/2006/main">
               <a:ext uri="{FF2B5EF4-FFF2-40B4-BE49-F238E27FC236}">
-                <a16:creationId xmlns:a16="http://schemas.microsoft.com/office/drawing/2014/main" id="{F8DFB4E3-D13A-44F5-997C-31AE3785E0ED}"/>
+                <a16:creationId xmlns:a16="http://schemas.microsoft.com/office/drawing/2014/main" id="{EC9898E4-C359-4CBB-A478-E67106D4C1AE}"/>
               </a:ext>
             </a:extLst>
           </p:cNvPr>
@@ -3136,7 +3136,7 @@
           <p:cNvPr id="6" name="Footer Placeholder 5">
             <a:extLst xmlns:a="http://schemas.openxmlformats.org/drawingml/2006/main">
               <a:ext uri="{FF2B5EF4-FFF2-40B4-BE49-F238E27FC236}">
-                <a16:creationId xmlns:a16="http://schemas.microsoft.com/office/drawing/2014/main" id="{54A70DE5-AF91-4859-981B-98C7641BE966}"/>
+                <a16:creationId xmlns:a16="http://schemas.microsoft.com/office/drawing/2014/main" id="{CF0E325F-2FFC-492E-92ED-4E70130CFFD1}"/>
               </a:ext>
             </a:extLst>
           </p:cNvPr>
@@ -3161,7 +3161,7 @@
           <p:cNvPr id="7" name="Slide Number Placeholder 6">
             <a:extLst xmlns:a="http://schemas.openxmlformats.org/drawingml/2006/main">
               <a:ext uri="{FF2B5EF4-FFF2-40B4-BE49-F238E27FC236}">
-                <a16:creationId xmlns:a16="http://schemas.microsoft.com/office/drawing/2014/main" id="{F1EA5517-7091-4147-A924-8D7722E2B203}"/>
+                <a16:creationId xmlns:a16="http://schemas.microsoft.com/office/drawing/2014/main" id="{7377E1FE-094B-458C-AD19-103F049E5758}"/>
               </a:ext>
             </a:extLst>
           </p:cNvPr>
@@ -3206,7 +3206,7 @@
           <p:cNvPr id="2" name="Title 1">
             <a:extLst xmlns:a="http://schemas.openxmlformats.org/drawingml/2006/main">
               <a:ext uri="{FF2B5EF4-FFF2-40B4-BE49-F238E27FC236}">
-                <a16:creationId xmlns:a16="http://schemas.microsoft.com/office/drawing/2014/main" id="{C1E42FEF-8782-407E-A41E-DE7F66A67025}"/>
+                <a16:creationId xmlns:a16="http://schemas.microsoft.com/office/drawing/2014/main" id="{774EB2D8-F5AC-4C0D-A3DB-EB4A4D66826E}"/>
               </a:ext>
             </a:extLst>
           </p:cNvPr>
@@ -3239,7 +3239,7 @@
           <p:cNvPr id="3" name="Text Placeholder 2">
             <a:extLst xmlns:a="http://schemas.openxmlformats.org/drawingml/2006/main">
               <a:ext uri="{FF2B5EF4-FFF2-40B4-BE49-F238E27FC236}">
-                <a16:creationId xmlns:a16="http://schemas.microsoft.com/office/drawing/2014/main" id="{F59AA7F3-E402-44AC-A604-D63C4E1AF92B}"/>
+                <a16:creationId xmlns:a16="http://schemas.microsoft.com/office/drawing/2014/main" id="{FA7634D2-C4B2-4742-A5D2-B9856DFFF4B4}"/>
               </a:ext>
             </a:extLst>
           </p:cNvPr>
@@ -3311,7 +3311,7 @@
           <p:cNvPr id="4" name="Content Placeholder 3">
             <a:extLst xmlns:a="http://schemas.openxmlformats.org/drawingml/2006/main">
               <a:ext uri="{FF2B5EF4-FFF2-40B4-BE49-F238E27FC236}">
-                <a16:creationId xmlns:a16="http://schemas.microsoft.com/office/drawing/2014/main" id="{EDEFD273-B834-42E3-894E-5AB626C693F5}"/>
+                <a16:creationId xmlns:a16="http://schemas.microsoft.com/office/drawing/2014/main" id="{0AE24FA5-EE45-4082-89C0-BE628BDC05EB}"/>
               </a:ext>
             </a:extLst>
           </p:cNvPr>
@@ -3416,7 +3416,7 @@
           <p:cNvPr id="5" name="Text Placeholder 4">
             <a:extLst xmlns:a="http://schemas.openxmlformats.org/drawingml/2006/main">
               <a:ext uri="{FF2B5EF4-FFF2-40B4-BE49-F238E27FC236}">
-                <a16:creationId xmlns:a16="http://schemas.microsoft.com/office/drawing/2014/main" id="{E64744B3-EDE8-4677-9194-01ABA99F207A}"/>
+                <a16:creationId xmlns:a16="http://schemas.microsoft.com/office/drawing/2014/main" id="{C188824F-3C9A-46EC-B442-DA32174BF835}"/>
               </a:ext>
             </a:extLst>
           </p:cNvPr>
@@ -3488,7 +3488,7 @@
           <p:cNvPr id="6" name="Content Placeholder 5">
             <a:extLst xmlns:a="http://schemas.openxmlformats.org/drawingml/2006/main">
               <a:ext uri="{FF2B5EF4-FFF2-40B4-BE49-F238E27FC236}">
-                <a16:creationId xmlns:a16="http://schemas.microsoft.com/office/drawing/2014/main" id="{77A14389-6008-44CC-ADFA-77E7C8B950C6}"/>
+                <a16:creationId xmlns:a16="http://schemas.microsoft.com/office/drawing/2014/main" id="{D12DEC92-54F2-4379-9E1E-AAB3EE7E2604}"/>
               </a:ext>
             </a:extLst>
           </p:cNvPr>
@@ -3593,7 +3593,7 @@
           <p:cNvPr id="7" name="Date Placeholder 6">
             <a:extLst xmlns:a="http://schemas.openxmlformats.org/drawingml/2006/main">
               <a:ext uri="{FF2B5EF4-FFF2-40B4-BE49-F238E27FC236}">
-                <a16:creationId xmlns:a16="http://schemas.microsoft.com/office/drawing/2014/main" id="{1BFCDD00-E976-4CA3-BFE2-C6D534FF030E}"/>
+                <a16:creationId xmlns:a16="http://schemas.microsoft.com/office/drawing/2014/main" id="{25784E6C-47DA-4925-AF79-1AB9C2EC0456}"/>
               </a:ext>
             </a:extLst>
           </p:cNvPr>
@@ -3621,7 +3621,7 @@
           <p:cNvPr id="8" name="Footer Placeholder 7">
             <a:extLst xmlns:a="http://schemas.openxmlformats.org/drawingml/2006/main">
               <a:ext uri="{FF2B5EF4-FFF2-40B4-BE49-F238E27FC236}">
-                <a16:creationId xmlns:a16="http://schemas.microsoft.com/office/drawing/2014/main" id="{E6B1B905-033A-498A-AB50-19C7B99A2CBD}"/>
+                <a16:creationId xmlns:a16="http://schemas.microsoft.com/office/drawing/2014/main" id="{34FD361F-CBD9-492C-9874-DACC61873261}"/>
               </a:ext>
             </a:extLst>
           </p:cNvPr>
@@ -3646,7 +3646,7 @@
           <p:cNvPr id="9" name="Slide Number Placeholder 8">
             <a:extLst xmlns:a="http://schemas.openxmlformats.org/drawingml/2006/main">
               <a:ext uri="{FF2B5EF4-FFF2-40B4-BE49-F238E27FC236}">
-                <a16:creationId xmlns:a16="http://schemas.microsoft.com/office/drawing/2014/main" id="{1918A968-4724-42BB-B78A-EAA98F669780}"/>
+                <a16:creationId xmlns:a16="http://schemas.microsoft.com/office/drawing/2014/main" id="{CD8D8422-71EA-4318-B2B5-E41A6D5D8F7B}"/>
               </a:ext>
             </a:extLst>
           </p:cNvPr>
@@ -3691,7 +3691,7 @@
           <p:cNvPr id="2" name="Title 1">
             <a:extLst xmlns:a="http://schemas.openxmlformats.org/drawingml/2006/main">
               <a:ext uri="{FF2B5EF4-FFF2-40B4-BE49-F238E27FC236}">
-                <a16:creationId xmlns:a16="http://schemas.microsoft.com/office/drawing/2014/main" id="{4E382995-18B2-4930-A43E-E48DBDF6461F}"/>
+                <a16:creationId xmlns:a16="http://schemas.microsoft.com/office/drawing/2014/main" id="{D8CC1A17-E5F3-4F53-BEA1-18A43D73C364}"/>
               </a:ext>
             </a:extLst>
           </p:cNvPr>
@@ -3719,7 +3719,7 @@
           <p:cNvPr id="3" name="Date Placeholder 2">
             <a:extLst xmlns:a="http://schemas.openxmlformats.org/drawingml/2006/main">
               <a:ext uri="{FF2B5EF4-FFF2-40B4-BE49-F238E27FC236}">
-                <a16:creationId xmlns:a16="http://schemas.microsoft.com/office/drawing/2014/main" id="{CED2F28E-2D96-44BE-AF71-892C45C91BC8}"/>
+                <a16:creationId xmlns:a16="http://schemas.microsoft.com/office/drawing/2014/main" id="{47C4C53B-2B1D-45F2-86C5-7A00624FBCDA}"/>
               </a:ext>
             </a:extLst>
           </p:cNvPr>
@@ -3747,7 +3747,7 @@
           <p:cNvPr id="4" name="Footer Placeholder 3">
             <a:extLst xmlns:a="http://schemas.openxmlformats.org/drawingml/2006/main">
               <a:ext uri="{FF2B5EF4-FFF2-40B4-BE49-F238E27FC236}">
-                <a16:creationId xmlns:a16="http://schemas.microsoft.com/office/drawing/2014/main" id="{47A273F3-350F-4CA7-9802-A4B0AC1342F3}"/>
+                <a16:creationId xmlns:a16="http://schemas.microsoft.com/office/drawing/2014/main" id="{C866B801-A57C-4E46-BA2A-C44900AF1A92}"/>
               </a:ext>
             </a:extLst>
           </p:cNvPr>
@@ -3772,7 +3772,7 @@
           <p:cNvPr id="5" name="Slide Number Placeholder 4">
             <a:extLst xmlns:a="http://schemas.openxmlformats.org/drawingml/2006/main">
               <a:ext uri="{FF2B5EF4-FFF2-40B4-BE49-F238E27FC236}">
-                <a16:creationId xmlns:a16="http://schemas.microsoft.com/office/drawing/2014/main" id="{FFF307C5-96D7-4D26-8815-F0F8FDD0C425}"/>
+                <a16:creationId xmlns:a16="http://schemas.microsoft.com/office/drawing/2014/main" id="{5A0670E0-0F2D-4F59-A9F0-82CFBBEAF1A6}"/>
               </a:ext>
             </a:extLst>
           </p:cNvPr>
@@ -3817,7 +3817,7 @@
           <p:cNvPr id="2" name="Date Placeholder 1">
             <a:extLst xmlns:a="http://schemas.openxmlformats.org/drawingml/2006/main">
               <a:ext uri="{FF2B5EF4-FFF2-40B4-BE49-F238E27FC236}">
-                <a16:creationId xmlns:a16="http://schemas.microsoft.com/office/drawing/2014/main" id="{B499E12C-9480-4A90-8A35-FD88ED29E9D9}"/>
+                <a16:creationId xmlns:a16="http://schemas.microsoft.com/office/drawing/2014/main" id="{1B72F6A2-DC5E-4870-8D5A-A5ACF666A072}"/>
               </a:ext>
             </a:extLst>
           </p:cNvPr>
@@ -3845,7 +3845,7 @@
           <p:cNvPr id="3" name="Footer Placeholder 2">
             <a:extLst xmlns:a="http://schemas.openxmlformats.org/drawingml/2006/main">
               <a:ext uri="{FF2B5EF4-FFF2-40B4-BE49-F238E27FC236}">
-                <a16:creationId xmlns:a16="http://schemas.microsoft.com/office/drawing/2014/main" id="{641E59A9-02D9-49C5-A850-BF5DE06459E7}"/>
+                <a16:creationId xmlns:a16="http://schemas.microsoft.com/office/drawing/2014/main" id="{41389574-CD78-4995-8DA5-1A16CDCED958}"/>
               </a:ext>
             </a:extLst>
           </p:cNvPr>
@@ -3870,7 +3870,7 @@
           <p:cNvPr id="4" name="Slide Number Placeholder 3">
             <a:extLst xmlns:a="http://schemas.openxmlformats.org/drawingml/2006/main">
               <a:ext uri="{FF2B5EF4-FFF2-40B4-BE49-F238E27FC236}">
-                <a16:creationId xmlns:a16="http://schemas.microsoft.com/office/drawing/2014/main" id="{B76A17DF-7A42-460F-ACB4-60813DA8E5BA}"/>
+                <a16:creationId xmlns:a16="http://schemas.microsoft.com/office/drawing/2014/main" id="{47EB52AF-E945-40CA-BC97-1C1AED0BFBE3}"/>
               </a:ext>
             </a:extLst>
           </p:cNvPr>
@@ -3915,7 +3915,7 @@
           <p:cNvPr id="2" name="Title 1">
             <a:extLst xmlns:a="http://schemas.openxmlformats.org/drawingml/2006/main">
               <a:ext uri="{FF2B5EF4-FFF2-40B4-BE49-F238E27FC236}">
-                <a16:creationId xmlns:a16="http://schemas.microsoft.com/office/drawing/2014/main" id="{3C0DFFD5-5685-43C7-A397-4B82920847E5}"/>
+                <a16:creationId xmlns:a16="http://schemas.microsoft.com/office/drawing/2014/main" id="{82FCEADD-D66E-423D-9B91-4174C6E9F363}"/>
               </a:ext>
             </a:extLst>
           </p:cNvPr>
@@ -3953,7 +3953,7 @@
           <p:cNvPr id="3" name="Content Placeholder 2">
             <a:extLst xmlns:a="http://schemas.openxmlformats.org/drawingml/2006/main">
               <a:ext uri="{FF2B5EF4-FFF2-40B4-BE49-F238E27FC236}">
-                <a16:creationId xmlns:a16="http://schemas.microsoft.com/office/drawing/2014/main" id="{B0896747-69B8-490F-AE06-568E978B8601}"/>
+                <a16:creationId xmlns:a16="http://schemas.microsoft.com/office/drawing/2014/main" id="{38493421-6C60-454B-B75B-3675109556A7}"/>
               </a:ext>
             </a:extLst>
           </p:cNvPr>
@@ -4058,7 +4058,7 @@
           <p:cNvPr id="4" name="Text Placeholder 3">
             <a:extLst xmlns:a="http://schemas.openxmlformats.org/drawingml/2006/main">
               <a:ext uri="{FF2B5EF4-FFF2-40B4-BE49-F238E27FC236}">
-                <a16:creationId xmlns:a16="http://schemas.microsoft.com/office/drawing/2014/main" id="{4E35F372-2BFC-4007-9C66-DC142A3784F7}"/>
+                <a16:creationId xmlns:a16="http://schemas.microsoft.com/office/drawing/2014/main" id="{0621BF76-3C79-4EB9-8549-7758CF59B179}"/>
               </a:ext>
             </a:extLst>
           </p:cNvPr>
@@ -4130,7 +4130,7 @@
           <p:cNvPr id="5" name="Date Placeholder 4">
             <a:extLst xmlns:a="http://schemas.openxmlformats.org/drawingml/2006/main">
               <a:ext uri="{FF2B5EF4-FFF2-40B4-BE49-F238E27FC236}">
-                <a16:creationId xmlns:a16="http://schemas.microsoft.com/office/drawing/2014/main" id="{05B080BD-7DD9-43A7-81C0-D8FF6DAFE8A9}"/>
+                <a16:creationId xmlns:a16="http://schemas.microsoft.com/office/drawing/2014/main" id="{9729EEB0-FB44-4209-ADBC-A7E868AD4535}"/>
               </a:ext>
             </a:extLst>
           </p:cNvPr>
@@ -4158,7 +4158,7 @@
           <p:cNvPr id="6" name="Footer Placeholder 5">
             <a:extLst xmlns:a="http://schemas.openxmlformats.org/drawingml/2006/main">
               <a:ext uri="{FF2B5EF4-FFF2-40B4-BE49-F238E27FC236}">
-                <a16:creationId xmlns:a16="http://schemas.microsoft.com/office/drawing/2014/main" id="{09052CD8-E69C-462E-9426-43E5906E917D}"/>
+                <a16:creationId xmlns:a16="http://schemas.microsoft.com/office/drawing/2014/main" id="{362D16D3-5020-43FA-ABAA-74DC1011A525}"/>
               </a:ext>
             </a:extLst>
           </p:cNvPr>
@@ -4183,7 +4183,7 @@
           <p:cNvPr id="7" name="Slide Number Placeholder 6">
             <a:extLst xmlns:a="http://schemas.openxmlformats.org/drawingml/2006/main">
               <a:ext uri="{FF2B5EF4-FFF2-40B4-BE49-F238E27FC236}">
-                <a16:creationId xmlns:a16="http://schemas.microsoft.com/office/drawing/2014/main" id="{6DAC0015-F48F-4708-8960-7D36EC74514C}"/>
+                <a16:creationId xmlns:a16="http://schemas.microsoft.com/office/drawing/2014/main" id="{074CC201-E333-4AC8-B32F-71C89A17C7B3}"/>
               </a:ext>
             </a:extLst>
           </p:cNvPr>
@@ -4228,7 +4228,7 @@
           <p:cNvPr id="2" name="Title 1">
             <a:extLst xmlns:a="http://schemas.openxmlformats.org/drawingml/2006/main">
               <a:ext uri="{FF2B5EF4-FFF2-40B4-BE49-F238E27FC236}">
-                <a16:creationId xmlns:a16="http://schemas.microsoft.com/office/drawing/2014/main" id="{7B5CF778-DE2E-40E4-8FCE-4BA5554DC450}"/>
+                <a16:creationId xmlns:a16="http://schemas.microsoft.com/office/drawing/2014/main" id="{E568D38A-7864-46FF-848C-476B65806278}"/>
               </a:ext>
             </a:extLst>
           </p:cNvPr>
@@ -4266,7 +4266,7 @@
           <p:cNvPr id="3" name="Picture Placeholder 2">
             <a:extLst xmlns:a="http://schemas.openxmlformats.org/drawingml/2006/main">
               <a:ext uri="{FF2B5EF4-FFF2-40B4-BE49-F238E27FC236}">
-                <a16:creationId xmlns:a16="http://schemas.microsoft.com/office/drawing/2014/main" id="{3716F194-B4CD-40FA-B689-53AC6A6C358D}"/>
+                <a16:creationId xmlns:a16="http://schemas.microsoft.com/office/drawing/2014/main" id="{C1A0EA41-341C-4CC6-BCF9-92324802193B}"/>
               </a:ext>
             </a:extLst>
           </p:cNvPr>
@@ -4333,7 +4333,7 @@
           <p:cNvPr id="4" name="Text Placeholder 3">
             <a:extLst xmlns:a="http://schemas.openxmlformats.org/drawingml/2006/main">
               <a:ext uri="{FF2B5EF4-FFF2-40B4-BE49-F238E27FC236}">
-                <a16:creationId xmlns:a16="http://schemas.microsoft.com/office/drawing/2014/main" id="{BD425812-31AD-4815-A3F0-1205F69DEE1B}"/>
+                <a16:creationId xmlns:a16="http://schemas.microsoft.com/office/drawing/2014/main" id="{677424CC-BF97-42BB-A30B-C26A11D36C2D}"/>
               </a:ext>
             </a:extLst>
           </p:cNvPr>
@@ -4405,7 +4405,7 @@
           <p:cNvPr id="5" name="Date Placeholder 4">
             <a:extLst xmlns:a="http://schemas.openxmlformats.org/drawingml/2006/main">
               <a:ext uri="{FF2B5EF4-FFF2-40B4-BE49-F238E27FC236}">
-                <a16:creationId xmlns:a16="http://schemas.microsoft.com/office/drawing/2014/main" id="{58D318DA-A50C-4E60-9249-13C0848DB623}"/>
+                <a16:creationId xmlns:a16="http://schemas.microsoft.com/office/drawing/2014/main" id="{AD61D148-47A8-4CA1-9C30-1924B3BFA78B}"/>
               </a:ext>
             </a:extLst>
           </p:cNvPr>
@@ -4433,7 +4433,7 @@
           <p:cNvPr id="6" name="Footer Placeholder 5">
             <a:extLst xmlns:a="http://schemas.openxmlformats.org/drawingml/2006/main">
               <a:ext uri="{FF2B5EF4-FFF2-40B4-BE49-F238E27FC236}">
-                <a16:creationId xmlns:a16="http://schemas.microsoft.com/office/drawing/2014/main" id="{F3D2EB50-363D-467D-9ACB-F168CD038366}"/>
+                <a16:creationId xmlns:a16="http://schemas.microsoft.com/office/drawing/2014/main" id="{ADC443DF-E923-45EB-9755-84F35DF9122C}"/>
               </a:ext>
             </a:extLst>
           </p:cNvPr>
@@ -4458,7 +4458,7 @@
           <p:cNvPr id="7" name="Slide Number Placeholder 6">
             <a:extLst xmlns:a="http://schemas.openxmlformats.org/drawingml/2006/main">
               <a:ext uri="{FF2B5EF4-FFF2-40B4-BE49-F238E27FC236}">
-                <a16:creationId xmlns:a16="http://schemas.microsoft.com/office/drawing/2014/main" id="{73BE029D-B684-4013-8721-2043B0CE28B9}"/>
+                <a16:creationId xmlns:a16="http://schemas.microsoft.com/office/drawing/2014/main" id="{E6C9115D-B885-4405-8385-FFDAA6B0EC97}"/>
               </a:ext>
             </a:extLst>
           </p:cNvPr>
@@ -4508,7 +4508,7 @@
           <p:cNvPr id="2" name="Title Placeholder 1">
             <a:extLst xmlns:a="http://schemas.openxmlformats.org/drawingml/2006/main">
               <a:ext uri="{FF2B5EF4-FFF2-40B4-BE49-F238E27FC236}">
-                <a16:creationId xmlns:a16="http://schemas.microsoft.com/office/drawing/2014/main" id="{E0EEEC88-DBAE-449B-9002-4B4C91875C30}"/>
+                <a16:creationId xmlns:a16="http://schemas.microsoft.com/office/drawing/2014/main" id="{CCC52AA2-CC93-4590-AFFF-97D99B6E16D7}"/>
               </a:ext>
             </a:extLst>
           </p:cNvPr>
@@ -4546,7 +4546,7 @@
           <p:cNvPr id="3" name="Text Placeholder 2">
             <a:extLst xmlns:a="http://schemas.openxmlformats.org/drawingml/2006/main">
               <a:ext uri="{FF2B5EF4-FFF2-40B4-BE49-F238E27FC236}">
-                <a16:creationId xmlns:a16="http://schemas.microsoft.com/office/drawing/2014/main" id="{A8F47AD5-4482-4BD2-A519-DC1075F317E5}"/>
+                <a16:creationId xmlns:a16="http://schemas.microsoft.com/office/drawing/2014/main" id="{7BD14768-B128-4B7C-A25C-64A805443697}"/>
               </a:ext>
             </a:extLst>
           </p:cNvPr>
@@ -4619,7 +4619,7 @@
           <p:cNvPr id="4" name="Date Placeholder 3">
             <a:extLst xmlns:a="http://schemas.openxmlformats.org/drawingml/2006/main">
               <a:ext uri="{FF2B5EF4-FFF2-40B4-BE49-F238E27FC236}">
-                <a16:creationId xmlns:a16="http://schemas.microsoft.com/office/drawing/2014/main" id="{50C5D670-763E-4153-8469-01D9A4D6E91A}"/>
+                <a16:creationId xmlns:a16="http://schemas.microsoft.com/office/drawing/2014/main" id="{FED28B17-D846-489C-8282-1D2FF8AFA289}"/>
               </a:ext>
             </a:extLst>
           </p:cNvPr>
@@ -4666,7 +4666,7 @@
           <p:cNvPr id="5" name="Footer Placeholder 4">
             <a:extLst xmlns:a="http://schemas.openxmlformats.org/drawingml/2006/main">
               <a:ext uri="{FF2B5EF4-FFF2-40B4-BE49-F238E27FC236}">
-                <a16:creationId xmlns:a16="http://schemas.microsoft.com/office/drawing/2014/main" id="{B04C9047-3EE5-49A4-A542-D07CCC356427}"/>
+                <a16:creationId xmlns:a16="http://schemas.microsoft.com/office/drawing/2014/main" id="{D809E257-664E-42B0-81FA-56248D5905B4}"/>
               </a:ext>
             </a:extLst>
           </p:cNvPr>
@@ -4710,7 +4710,7 @@
           <p:cNvPr id="6" name="Slide Number Placeholder 5">
             <a:extLst xmlns:a="http://schemas.openxmlformats.org/drawingml/2006/main">
               <a:ext uri="{FF2B5EF4-FFF2-40B4-BE49-F238E27FC236}">
-                <a16:creationId xmlns:a16="http://schemas.microsoft.com/office/drawing/2014/main" id="{AA21E6D0-0FC2-4B20-ABD5-07AD60CEFCAD}"/>
+                <a16:creationId xmlns:a16="http://schemas.microsoft.com/office/drawing/2014/main" id="{8952303B-2948-4EB5-9A99-8E46DAE69043}"/>
               </a:ext>
             </a:extLst>
           </p:cNvPr>
@@ -4756,17 +4756,17 @@
   </p:cSld>
   <p:clrMap bg1="lt1" tx1="dk1" bg2="lt2" tx2="dk2" accent1="accent1" accent2="accent2" accent3="accent3" accent4="accent4" accent5="accent5" accent6="accent6" hlink="hlink" folHlink="folHlink"/>
   <p:sldLayoutIdLst>
-    <p:sldLayoutId xmlns:r="http://schemas.openxmlformats.org/officeDocument/2006/relationships" id="2147483649" r:id="R0f228906f2274515"/>
-    <p:sldLayoutId xmlns:r="http://schemas.openxmlformats.org/officeDocument/2006/relationships" id="2147483650" r:id="R81d44deb74d94a16"/>
-    <p:sldLayoutId xmlns:r="http://schemas.openxmlformats.org/officeDocument/2006/relationships" id="2147483651" r:id="R693338acdb9d432c"/>
-    <p:sldLayoutId xmlns:r="http://schemas.openxmlformats.org/officeDocument/2006/relationships" id="2147483652" r:id="R011bd35c68f444e8"/>
-    <p:sldLayoutId xmlns:r="http://schemas.openxmlformats.org/officeDocument/2006/relationships" id="2147483653" r:id="R17defdd7eed1420b"/>
-    <p:sldLayoutId xmlns:r="http://schemas.openxmlformats.org/officeDocument/2006/relationships" id="2147483654" r:id="R7328ba6ebebb49a1"/>
-    <p:sldLayoutId xmlns:r="http://schemas.openxmlformats.org/officeDocument/2006/relationships" id="2147483655" r:id="Re5463081fb97497d"/>
-    <p:sldLayoutId xmlns:r="http://schemas.openxmlformats.org/officeDocument/2006/relationships" id="2147483656" r:id="Rebe586ffc6914a4e"/>
-    <p:sldLayoutId xmlns:r="http://schemas.openxmlformats.org/officeDocument/2006/relationships" id="2147483657" r:id="Rc7018df7736c4e7c"/>
-    <p:sldLayoutId xmlns:r="http://schemas.openxmlformats.org/officeDocument/2006/relationships" id="2147483658" r:id="R76395670f4af437f"/>
-    <p:sldLayoutId xmlns:r="http://schemas.openxmlformats.org/officeDocument/2006/relationships" id="2147483659" r:id="R9d4259d793824e1d"/>
+    <p:sldLayoutId xmlns:r="http://schemas.openxmlformats.org/officeDocument/2006/relationships" id="2147483649" r:id="Rf160aadebd8b48c9"/>
+    <p:sldLayoutId xmlns:r="http://schemas.openxmlformats.org/officeDocument/2006/relationships" id="2147483650" r:id="R5306861126404cc4"/>
+    <p:sldLayoutId xmlns:r="http://schemas.openxmlformats.org/officeDocument/2006/relationships" id="2147483651" r:id="R4ddcdede915846dd"/>
+    <p:sldLayoutId xmlns:r="http://schemas.openxmlformats.org/officeDocument/2006/relationships" id="2147483652" r:id="Re06c5e2f4e504e5a"/>
+    <p:sldLayoutId xmlns:r="http://schemas.openxmlformats.org/officeDocument/2006/relationships" id="2147483653" r:id="R86184ba5b04f4d76"/>
+    <p:sldLayoutId xmlns:r="http://schemas.openxmlformats.org/officeDocument/2006/relationships" id="2147483654" r:id="R0f778510db694e91"/>
+    <p:sldLayoutId xmlns:r="http://schemas.openxmlformats.org/officeDocument/2006/relationships" id="2147483655" r:id="R6e3136ccfd424d95"/>
+    <p:sldLayoutId xmlns:r="http://schemas.openxmlformats.org/officeDocument/2006/relationships" id="2147483656" r:id="R76c5bc4d3cc64a91"/>
+    <p:sldLayoutId xmlns:r="http://schemas.openxmlformats.org/officeDocument/2006/relationships" id="2147483657" r:id="R7954eaaa1f124c7e"/>
+    <p:sldLayoutId xmlns:r="http://schemas.openxmlformats.org/officeDocument/2006/relationships" id="2147483658" r:id="R7075f032f0c148eb"/>
+    <p:sldLayoutId xmlns:r="http://schemas.openxmlformats.org/officeDocument/2006/relationships" id="2147483659" r:id="R5c62bf705a0c49f4"/>
   </p:sldLayoutIdLst>
   <p:txStyles>
     <p:titleStyle>
@@ -5779,7 +5779,7 @@
           <c:idx val="0"/>
           <c:order val="0"/>
           <c:tx>
-            <c:v>僅加緩衝（方案P2）</c:v>
+            <c:v>僅加緩衝（P2）</c:v>
           </c:tx>
           <c:spPr>
             <a:ln xmlns:a="http://schemas.openxmlformats.org/drawingml/2006/main" w="38100">
@@ -5851,7 +5851,7 @@
           <c:idx val="1"/>
           <c:order val="1"/>
           <c:tx>
-            <c:v>聯合改善（方案P4）</c:v>
+            <c:v>聯合改善（P4）</c:v>
           </c:tx>
           <c:spPr>
             <a:ln xmlns:a="http://schemas.openxmlformats.org/drawingml/2006/main" w="38100">
@@ -6127,7 +6127,7 @@
           <p:cNvPr id="2" name="Freeform 2">
             <a:extLst xmlns:a="http://schemas.openxmlformats.org/drawingml/2006/main">
               <a:ext uri="{FF2B5EF4-FFF2-40B4-BE49-F238E27FC236}">
-                <a16:creationId xmlns:a16="http://schemas.microsoft.com/office/drawing/2014/main" id="{04ECE57F-F9E8-4609-BF51-B64E9900388A}"/>
+                <a16:creationId xmlns:a16="http://schemas.microsoft.com/office/drawing/2014/main" id="{1038CC73-0A7C-4D39-A11B-C4B9B3DF90BC}"/>
               </a:ext>
             </a:extLst>
           </p:cNvPr>
@@ -6165,7 +6165,7 @@
             </a:pathLst>
           </a:custGeom>
           <a:blipFill xmlns:a="http://schemas.openxmlformats.org/drawingml/2006/main">
-            <a:blip xmlns:r="http://schemas.openxmlformats.org/officeDocument/2006/relationships" r:embed="Rfe27aea067ea4bb4"/>
+            <a:blip xmlns:r="http://schemas.openxmlformats.org/officeDocument/2006/relationships" r:embed="R115375dfa9c24c5b"/>
             <a:stretch>
               <a:fillRect l="-4156" t="0" r="-2479" b="-18484"/>
             </a:stretch>
@@ -6177,7 +6177,7 @@
           <p:cNvPr id="3" name="Freeform 3">
             <a:extLst xmlns:a="http://schemas.openxmlformats.org/drawingml/2006/main">
               <a:ext uri="{FF2B5EF4-FFF2-40B4-BE49-F238E27FC236}">
-                <a16:creationId xmlns:a16="http://schemas.microsoft.com/office/drawing/2014/main" id="{B39B4459-E7EA-4F33-A8F2-869E04439373}"/>
+                <a16:creationId xmlns:a16="http://schemas.microsoft.com/office/drawing/2014/main" id="{2168D3BD-4BF3-48CF-B32A-07E50B754A7B}"/>
               </a:ext>
             </a:extLst>
           </p:cNvPr>
@@ -6225,7 +6225,7 @@
           <p:cNvPr id="5" name="Freeform 5">
             <a:extLst xmlns:a="http://schemas.openxmlformats.org/drawingml/2006/main">
               <a:ext uri="{FF2B5EF4-FFF2-40B4-BE49-F238E27FC236}">
-                <a16:creationId xmlns:a16="http://schemas.microsoft.com/office/drawing/2014/main" id="{DA5EFA2C-08F3-4BBA-9FD3-8F005BAE154F}"/>
+                <a16:creationId xmlns:a16="http://schemas.microsoft.com/office/drawing/2014/main" id="{A344B12F-E7E3-4F4F-B39A-D5994A5ED75E}"/>
               </a:ext>
             </a:extLst>
           </p:cNvPr>
@@ -6299,7 +6299,7 @@
           <p:cNvPr id="6" name="TextBox 6">
             <a:extLst xmlns:a="http://schemas.openxmlformats.org/drawingml/2006/main">
               <a:ext uri="{FF2B5EF4-FFF2-40B4-BE49-F238E27FC236}">
-                <a16:creationId xmlns:a16="http://schemas.microsoft.com/office/drawing/2014/main" id="{315A9547-CF70-48D6-8A7A-8096E5FB885E}"/>
+                <a16:creationId xmlns:a16="http://schemas.microsoft.com/office/drawing/2014/main" id="{6E645BBB-B5EC-4C1B-97DD-15170F49529C}"/>
               </a:ext>
             </a:extLst>
           </p:cNvPr>
@@ -6335,7 +6335,7 @@
           <p:cNvPr id="7" name="Freeform 7">
             <a:extLst xmlns:a="http://schemas.openxmlformats.org/drawingml/2006/main">
               <a:ext uri="{FF2B5EF4-FFF2-40B4-BE49-F238E27FC236}">
-                <a16:creationId xmlns:a16="http://schemas.microsoft.com/office/drawing/2014/main" id="{E2A5536F-652A-4566-A8D5-B6C0467EE405}"/>
+                <a16:creationId xmlns:a16="http://schemas.microsoft.com/office/drawing/2014/main" id="{4DC7E806-81E0-452D-A3FC-33E1C6DC8D0F}"/>
               </a:ext>
             </a:extLst>
           </p:cNvPr>
@@ -6373,10 +6373,10 @@
             </a:pathLst>
           </a:custGeom>
           <a:blipFill xmlns:a="http://schemas.openxmlformats.org/drawingml/2006/main">
-            <a:blip xmlns:r="http://schemas.openxmlformats.org/officeDocument/2006/relationships" r:embed="Reb83d089010a41fd">
+            <a:blip xmlns:r="http://schemas.openxmlformats.org/officeDocument/2006/relationships" r:embed="Re21162ad9ccb413a">
               <a:extLst>
                 <a:ext uri="{96DAC541-7B7A-43D3-8B79-37D633B846F1}">
-                  <asvg:svgBlip xmlns:asvg="http://schemas.microsoft.com/office/drawing/2016/SVG/main" r:embed="Rb4a8cc89b8ee4c74"/>
+                  <asvg:svgBlip xmlns:asvg="http://schemas.microsoft.com/office/drawing/2016/SVG/main" r:embed="R45457e3aed4247ff"/>
                 </a:ext>
               </a:extLst>
             </a:blip>
@@ -6391,7 +6391,7 @@
           <p:cNvPr id="8" name="Freeform 8">
             <a:extLst xmlns:a="http://schemas.openxmlformats.org/drawingml/2006/main">
               <a:ext uri="{FF2B5EF4-FFF2-40B4-BE49-F238E27FC236}">
-                <a16:creationId xmlns:a16="http://schemas.microsoft.com/office/drawing/2014/main" id="{8C7665B2-0DAF-45F0-B19B-76F4CC18C532}"/>
+                <a16:creationId xmlns:a16="http://schemas.microsoft.com/office/drawing/2014/main" id="{AFFC8262-5E01-4B46-99EF-E37EBF333C2F}"/>
               </a:ext>
             </a:extLst>
           </p:cNvPr>
@@ -6429,10 +6429,10 @@
             </a:pathLst>
           </a:custGeom>
           <a:blipFill xmlns:a="http://schemas.openxmlformats.org/drawingml/2006/main">
-            <a:blip xmlns:r="http://schemas.openxmlformats.org/officeDocument/2006/relationships" r:embed="Reb83d089010a41fd">
+            <a:blip xmlns:r="http://schemas.openxmlformats.org/officeDocument/2006/relationships" r:embed="Re21162ad9ccb413a">
               <a:extLst>
                 <a:ext uri="{96DAC541-7B7A-43D3-8B79-37D633B846F1}">
-                  <asvg:svgBlip xmlns:asvg="http://schemas.microsoft.com/office/drawing/2016/SVG/main" r:embed="Rb4a8cc89b8ee4c74"/>
+                  <asvg:svgBlip xmlns:asvg="http://schemas.microsoft.com/office/drawing/2016/SVG/main" r:embed="R45457e3aed4247ff"/>
                 </a:ext>
               </a:extLst>
             </a:blip>
@@ -6447,7 +6447,7 @@
           <p:cNvPr id="9" name="TextBox 9">
             <a:extLst xmlns:a="http://schemas.openxmlformats.org/drawingml/2006/main">
               <a:ext uri="{FF2B5EF4-FFF2-40B4-BE49-F238E27FC236}">
-                <a16:creationId xmlns:a16="http://schemas.microsoft.com/office/drawing/2014/main" id="{6B38FD18-B439-4399-9653-8F246FABCE67}"/>
+                <a16:creationId xmlns:a16="http://schemas.microsoft.com/office/drawing/2014/main" id="{6614D20D-8AC5-47B6-86A3-23527964CE4C}"/>
               </a:ext>
             </a:extLst>
           </p:cNvPr>
@@ -6499,7 +6499,7 @@
           <p:cNvPr id="10" name="TextBox 10">
             <a:extLst xmlns:a="http://schemas.openxmlformats.org/drawingml/2006/main">
               <a:ext uri="{FF2B5EF4-FFF2-40B4-BE49-F238E27FC236}">
-                <a16:creationId xmlns:a16="http://schemas.microsoft.com/office/drawing/2014/main" id="{96E36E80-AFCF-4D09-9E99-10E0B073AE0C}"/>
+                <a16:creationId xmlns:a16="http://schemas.microsoft.com/office/drawing/2014/main" id="{B3D2A060-B787-4CA7-A523-CFFD97E7E6A1}"/>
               </a:ext>
             </a:extLst>
           </p:cNvPr>
@@ -6551,7 +6551,7 @@
           <p:cNvPr id="11" name="TextBox 11">
             <a:extLst xmlns:a="http://schemas.openxmlformats.org/drawingml/2006/main">
               <a:ext uri="{FF2B5EF4-FFF2-40B4-BE49-F238E27FC236}">
-                <a16:creationId xmlns:a16="http://schemas.microsoft.com/office/drawing/2014/main" id="{5957D054-BBBC-4459-B7DA-0F580BD82969}"/>
+                <a16:creationId xmlns:a16="http://schemas.microsoft.com/office/drawing/2014/main" id="{27482CA7-4299-4538-97B4-E70D6719F40C}"/>
               </a:ext>
             </a:extLst>
           </p:cNvPr>
@@ -6712,7 +6712,7 @@
           <p:cNvPr id="12" name="TextBox 12">
             <a:extLst xmlns:a="http://schemas.openxmlformats.org/drawingml/2006/main">
               <a:ext uri="{FF2B5EF4-FFF2-40B4-BE49-F238E27FC236}">
-                <a16:creationId xmlns:a16="http://schemas.microsoft.com/office/drawing/2014/main" id="{5309C0A9-6EDC-48CD-B1CA-568C588F06F0}"/>
+                <a16:creationId xmlns:a16="http://schemas.microsoft.com/office/drawing/2014/main" id="{0E74FFB3-FD8F-4981-AEC4-1390D0D974E1}"/>
               </a:ext>
             </a:extLst>
           </p:cNvPr>
@@ -6764,7 +6764,7 @@
           <p:cNvPr id="13" name="Freeform 13">
             <a:extLst xmlns:a="http://schemas.openxmlformats.org/drawingml/2006/main">
               <a:ext uri="{FF2B5EF4-FFF2-40B4-BE49-F238E27FC236}">
-                <a16:creationId xmlns:a16="http://schemas.microsoft.com/office/drawing/2014/main" id="{07390AD5-AEC2-4258-8680-573659FE1D52}"/>
+                <a16:creationId xmlns:a16="http://schemas.microsoft.com/office/drawing/2014/main" id="{49C603D9-8C8F-4D07-BB0E-F6D7B12DF4C8}"/>
               </a:ext>
             </a:extLst>
           </p:cNvPr>
@@ -6812,7 +6812,7 @@
           <p:cNvPr id="14" name="TextBox 14">
             <a:extLst xmlns:a="http://schemas.openxmlformats.org/drawingml/2006/main">
               <a:ext uri="{FF2B5EF4-FFF2-40B4-BE49-F238E27FC236}">
-                <a16:creationId xmlns:a16="http://schemas.microsoft.com/office/drawing/2014/main" id="{245F346B-A86C-4BCC-9627-55F2FEE12B2F}"/>
+                <a16:creationId xmlns:a16="http://schemas.microsoft.com/office/drawing/2014/main" id="{EF25FDE3-C9AB-4CEF-86E6-5AB29F850565}"/>
               </a:ext>
             </a:extLst>
           </p:cNvPr>
@@ -6866,7 +6866,7 @@
           <p:cNvPr id="15" name="">
             <a:extLst xmlns:a="http://schemas.openxmlformats.org/drawingml/2006/main">
               <a:ext uri="{FF2B5EF4-FFF2-40B4-BE49-F238E27FC236}">
-                <a16:creationId xmlns:a16="http://schemas.microsoft.com/office/drawing/2014/main" id="{68CFB383-7CFD-4BE8-8C0E-D7EE1AC0D162}"/>
+                <a16:creationId xmlns:a16="http://schemas.microsoft.com/office/drawing/2014/main" id="{7C1AEF01-7794-423D-A2AF-7FA94A156BD8}"/>
               </a:ext>
             </a:extLst>
           </p:cNvPr>
@@ -6876,7 +6876,7 @@
           <p:nvPr/>
         </p:nvPicPr>
         <p:blipFill>
-          <a:blip xmlns:r="http://schemas.openxmlformats.org/officeDocument/2006/relationships" xmlns:a="http://schemas.openxmlformats.org/drawingml/2006/main" r:embed="Raed7de2da3b44ad6"/>
+          <a:blip xmlns:r="http://schemas.openxmlformats.org/officeDocument/2006/relationships" xmlns:a="http://schemas.openxmlformats.org/drawingml/2006/main" r:embed="R11cce451b26244a4"/>
           <a:srcRect xmlns:a="http://schemas.openxmlformats.org/drawingml/2006/main" l="0" t="15880" r="23187" b="0"/>
           <a:stretch xmlns:a="http://schemas.openxmlformats.org/drawingml/2006/main"/>
         </p:blipFill>
@@ -6895,7 +6895,7 @@
           <p:cNvPr id="16" name="">
             <a:extLst xmlns:a="http://schemas.openxmlformats.org/drawingml/2006/main">
               <a:ext uri="{FF2B5EF4-FFF2-40B4-BE49-F238E27FC236}">
-                <a16:creationId xmlns:a16="http://schemas.microsoft.com/office/drawing/2014/main" id="{B6213251-659D-4AA5-ABE4-C7799EDA74CC}"/>
+                <a16:creationId xmlns:a16="http://schemas.microsoft.com/office/drawing/2014/main" id="{93A1FF6C-57A7-4C9D-955B-049F41AAFDE1}"/>
               </a:ext>
             </a:extLst>
           </p:cNvPr>
@@ -6905,7 +6905,7 @@
           <p:nvPr/>
         </p:nvPicPr>
         <p:blipFill>
-          <a:blip xmlns:r="http://schemas.openxmlformats.org/officeDocument/2006/relationships" xmlns:a="http://schemas.openxmlformats.org/drawingml/2006/main" r:embed="Raf79b6a7549a4316"/>
+          <a:blip xmlns:r="http://schemas.openxmlformats.org/officeDocument/2006/relationships" xmlns:a="http://schemas.openxmlformats.org/drawingml/2006/main" r:embed="R377477db3ba54649"/>
           <a:srcRect xmlns:a="http://schemas.openxmlformats.org/drawingml/2006/main" l="13490" t="35208" r="0" b="0"/>
           <a:stretch xmlns:a="http://schemas.openxmlformats.org/drawingml/2006/main"/>
         </p:blipFill>
@@ -6924,7 +6924,7 @@
           <p:cNvPr id="17" name="內容_1_循環箱逆向物流">
             <a:extLst xmlns:a="http://schemas.openxmlformats.org/drawingml/2006/main">
               <a:ext uri="{FF2B5EF4-FFF2-40B4-BE49-F238E27FC236}">
-                <a16:creationId xmlns:a16="http://schemas.microsoft.com/office/drawing/2014/main" id="{950FA09E-01CB-4583-A363-16D9BEC4770A}"/>
+                <a16:creationId xmlns:a16="http://schemas.microsoft.com/office/drawing/2014/main" id="{68F044DE-58D7-4C6E-912F-2FC89F57A5E1}"/>
               </a:ext>
             </a:extLst>
           </p:cNvPr>
@@ -7082,7 +7082,7 @@
           <p:cNvPr id="18" name="內容_1_倉庫模擬與改善方案實測">
             <a:extLst xmlns:a="http://schemas.openxmlformats.org/drawingml/2006/main">
               <a:ext uri="{FF2B5EF4-FFF2-40B4-BE49-F238E27FC236}">
-                <a16:creationId xmlns:a16="http://schemas.microsoft.com/office/drawing/2014/main" id="{B41667CE-8B2B-418C-82E9-F68AE6912160}"/>
+                <a16:creationId xmlns:a16="http://schemas.microsoft.com/office/drawing/2014/main" id="{D6EF1B7D-E1F7-4CCE-A74A-3949979A705F}"/>
               </a:ext>
             </a:extLst>
           </p:cNvPr>
@@ -7240,7 +7240,7 @@
           <p:cNvPr id="19" name="內容_1_雙層輸送網・五人作業・500">
             <a:extLst xmlns:a="http://schemas.openxmlformats.org/drawingml/2006/main">
               <a:ext uri="{FF2B5EF4-FFF2-40B4-BE49-F238E27FC236}">
-                <a16:creationId xmlns:a16="http://schemas.microsoft.com/office/drawing/2014/main" id="{4555EA4B-BDFB-4D53-9635-361EAFE79F1D}"/>
+                <a16:creationId xmlns:a16="http://schemas.microsoft.com/office/drawing/2014/main" id="{BADAF019-13DC-4E2C-A64F-898AA3785332}"/>
               </a:ext>
             </a:extLst>
           </p:cNvPr>
@@ -7398,7 +7398,7 @@
           <p:cNvPr id="20" name="內容_1_2026.10.29　循環物">
             <a:extLst xmlns:a="http://schemas.openxmlformats.org/drawingml/2006/main">
               <a:ext uri="{FF2B5EF4-FFF2-40B4-BE49-F238E27FC236}">
-                <a16:creationId xmlns:a16="http://schemas.microsoft.com/office/drawing/2014/main" id="{31E16F55-2E6A-45F0-B7D9-A37B41926CA6}"/>
+                <a16:creationId xmlns:a16="http://schemas.microsoft.com/office/drawing/2014/main" id="{845962A8-B760-41F5-B02E-C4738EF9BCC5}"/>
               </a:ext>
             </a:extLst>
           </p:cNvPr>
@@ -7554,7 +7554,7 @@
     </p:spTree>
     <p:extLst>
       <p:ext uri="{BB962C8B-B14F-4D97-AF65-F5344CB8AC3E}">
-        <p14:creationId xmlns:p14="http://schemas.microsoft.com/office/powerpoint/2010/main" val="1648993173"/>
+        <p14:creationId xmlns:p14="http://schemas.microsoft.com/office/powerpoint/2010/main" val="367939481"/>
       </p:ext>
     </p:extLst>
   </p:cSld>
@@ -7578,7 +7578,7 @@
           <p:cNvPr id="2" name="Freeform 2">
             <a:extLst xmlns:a="http://schemas.openxmlformats.org/drawingml/2006/main">
               <a:ext uri="{FF2B5EF4-FFF2-40B4-BE49-F238E27FC236}">
-                <a16:creationId xmlns:a16="http://schemas.microsoft.com/office/drawing/2014/main" id="{B31B2887-690B-4167-A3FD-5B5335A940B7}"/>
+                <a16:creationId xmlns:a16="http://schemas.microsoft.com/office/drawing/2014/main" id="{866781D3-707A-48D8-B08E-0CFC5C086C9F}"/>
               </a:ext>
             </a:extLst>
           </p:cNvPr>
@@ -7616,7 +7616,7 @@
             </a:pathLst>
           </a:custGeom>
           <a:blipFill xmlns:a="http://schemas.openxmlformats.org/drawingml/2006/main">
-            <a:blip xmlns:r="http://schemas.openxmlformats.org/officeDocument/2006/relationships" r:embed="Rb7c416bf8c564aa0"/>
+            <a:blip xmlns:r="http://schemas.openxmlformats.org/officeDocument/2006/relationships" r:embed="R359b0fb1d56f4ae8"/>
             <a:stretch>
               <a:fillRect l="-35258" t="-5555" r="-24931" b="-72434"/>
             </a:stretch>
@@ -7628,7 +7628,7 @@
           <p:cNvPr id="4" name="Freeform 4">
             <a:extLst xmlns:a="http://schemas.openxmlformats.org/drawingml/2006/main">
               <a:ext uri="{FF2B5EF4-FFF2-40B4-BE49-F238E27FC236}">
-                <a16:creationId xmlns:a16="http://schemas.microsoft.com/office/drawing/2014/main" id="{4F94845E-43C2-4D36-B952-7B225F0D1295}"/>
+                <a16:creationId xmlns:a16="http://schemas.microsoft.com/office/drawing/2014/main" id="{8CEEA448-28E3-4F4B-BC4D-7C7329D2B7A1}"/>
               </a:ext>
             </a:extLst>
           </p:cNvPr>
@@ -7702,7 +7702,7 @@
           <p:cNvPr id="5" name="TextBox 5">
             <a:extLst xmlns:a="http://schemas.openxmlformats.org/drawingml/2006/main">
               <a:ext uri="{FF2B5EF4-FFF2-40B4-BE49-F238E27FC236}">
-                <a16:creationId xmlns:a16="http://schemas.microsoft.com/office/drawing/2014/main" id="{4E81984A-83BE-4497-A24F-E5EF3AC11411}"/>
+                <a16:creationId xmlns:a16="http://schemas.microsoft.com/office/drawing/2014/main" id="{72E976D6-A34F-404D-A091-7E04AC49AC4D}"/>
               </a:ext>
             </a:extLst>
           </p:cNvPr>
@@ -7738,7 +7738,7 @@
           <p:cNvPr id="6" name="Freeform 6">
             <a:extLst xmlns:a="http://schemas.openxmlformats.org/drawingml/2006/main">
               <a:ext uri="{FF2B5EF4-FFF2-40B4-BE49-F238E27FC236}">
-                <a16:creationId xmlns:a16="http://schemas.microsoft.com/office/drawing/2014/main" id="{492A44A8-C7ED-4383-9375-336194A6F73E}"/>
+                <a16:creationId xmlns:a16="http://schemas.microsoft.com/office/drawing/2014/main" id="{64E820B2-C23A-4D14-8775-7C1A3211035F}"/>
               </a:ext>
             </a:extLst>
           </p:cNvPr>
@@ -7776,7 +7776,7 @@
             </a:pathLst>
           </a:custGeom>
           <a:blipFill xmlns:a="http://schemas.openxmlformats.org/drawingml/2006/main">
-            <a:blip xmlns:r="http://schemas.openxmlformats.org/officeDocument/2006/relationships" r:embed="Rb1c8c3ab76ed40a9"/>
+            <a:blip xmlns:r="http://schemas.openxmlformats.org/officeDocument/2006/relationships" r:embed="Rad4278638f994fac"/>
             <a:stretch>
               <a:fillRect l="0" t="0" r="0" b="0"/>
             </a:stretch>
@@ -7788,7 +7788,7 @@
           <p:cNvPr id="7" name="Freeform 7">
             <a:extLst xmlns:a="http://schemas.openxmlformats.org/drawingml/2006/main">
               <a:ext uri="{FF2B5EF4-FFF2-40B4-BE49-F238E27FC236}">
-                <a16:creationId xmlns:a16="http://schemas.microsoft.com/office/drawing/2014/main" id="{218B341F-BCF2-4BB5-A3A9-14B513D94334}"/>
+                <a16:creationId xmlns:a16="http://schemas.microsoft.com/office/drawing/2014/main" id="{B277E06E-0F3D-43D7-949D-2E06A6CCE5C4}"/>
               </a:ext>
             </a:extLst>
           </p:cNvPr>
@@ -7826,10 +7826,10 @@
             </a:pathLst>
           </a:custGeom>
           <a:blipFill xmlns:a="http://schemas.openxmlformats.org/drawingml/2006/main">
-            <a:blip xmlns:r="http://schemas.openxmlformats.org/officeDocument/2006/relationships" r:embed="Rf27ff6fc921a41ba">
+            <a:blip xmlns:r="http://schemas.openxmlformats.org/officeDocument/2006/relationships" r:embed="R558b3305dc4f445f">
               <a:extLst>
                 <a:ext uri="{96DAC541-7B7A-43D3-8B79-37D633B846F1}">
-                  <asvg:svgBlip xmlns:asvg="http://schemas.microsoft.com/office/drawing/2016/SVG/main" r:embed="R942c72dd1bd34581"/>
+                  <asvg:svgBlip xmlns:asvg="http://schemas.microsoft.com/office/drawing/2016/SVG/main" r:embed="R1cba6b6b071d4ae0"/>
                 </a:ext>
               </a:extLst>
             </a:blip>
@@ -7844,7 +7844,7 @@
           <p:cNvPr id="8" name="Freeform 8">
             <a:extLst xmlns:a="http://schemas.openxmlformats.org/drawingml/2006/main">
               <a:ext uri="{FF2B5EF4-FFF2-40B4-BE49-F238E27FC236}">
-                <a16:creationId xmlns:a16="http://schemas.microsoft.com/office/drawing/2014/main" id="{F60EC4D8-87C6-4BA5-8893-884E2069DE21}"/>
+                <a16:creationId xmlns:a16="http://schemas.microsoft.com/office/drawing/2014/main" id="{C3BA6FD7-8358-41AF-9CB7-368B3771CB0C}"/>
               </a:ext>
             </a:extLst>
           </p:cNvPr>
@@ -7882,10 +7882,10 @@
             </a:pathLst>
           </a:custGeom>
           <a:blipFill xmlns:a="http://schemas.openxmlformats.org/drawingml/2006/main">
-            <a:blip xmlns:r="http://schemas.openxmlformats.org/officeDocument/2006/relationships" r:embed="Rf27ff6fc921a41ba">
+            <a:blip xmlns:r="http://schemas.openxmlformats.org/officeDocument/2006/relationships" r:embed="R558b3305dc4f445f">
               <a:extLst>
                 <a:ext uri="{96DAC541-7B7A-43D3-8B79-37D633B846F1}">
-                  <asvg:svgBlip xmlns:asvg="http://schemas.microsoft.com/office/drawing/2016/SVG/main" r:embed="R942c72dd1bd34581"/>
+                  <asvg:svgBlip xmlns:asvg="http://schemas.microsoft.com/office/drawing/2016/SVG/main" r:embed="R1cba6b6b071d4ae0"/>
                 </a:ext>
               </a:extLst>
             </a:blip>
@@ -7900,7 +7900,7 @@
           <p:cNvPr id="9" name="Freeform 9">
             <a:extLst xmlns:a="http://schemas.openxmlformats.org/drawingml/2006/main">
               <a:ext uri="{FF2B5EF4-FFF2-40B4-BE49-F238E27FC236}">
-                <a16:creationId xmlns:a16="http://schemas.microsoft.com/office/drawing/2014/main" id="{4A61E6FD-F7DE-44AC-A17C-4BDE0445A97D}"/>
+                <a16:creationId xmlns:a16="http://schemas.microsoft.com/office/drawing/2014/main" id="{1ED269A7-9DFE-41F4-9836-6EC682F974CB}"/>
               </a:ext>
             </a:extLst>
           </p:cNvPr>
@@ -7948,7 +7948,7 @@
           <p:cNvPr id="10" name="TextBox 10">
             <a:extLst xmlns:a="http://schemas.openxmlformats.org/drawingml/2006/main">
               <a:ext uri="{FF2B5EF4-FFF2-40B4-BE49-F238E27FC236}">
-                <a16:creationId xmlns:a16="http://schemas.microsoft.com/office/drawing/2014/main" id="{99FC7D0B-5C9B-4317-BB53-112E71EBE1FA}"/>
+                <a16:creationId xmlns:a16="http://schemas.microsoft.com/office/drawing/2014/main" id="{1A72E459-1E5D-46CB-8AA4-8928B825432C}"/>
               </a:ext>
             </a:extLst>
           </p:cNvPr>
@@ -8000,7 +8000,7 @@
           <p:cNvPr id="11" name="TextBox 11">
             <a:extLst xmlns:a="http://schemas.openxmlformats.org/drawingml/2006/main">
               <a:ext uri="{FF2B5EF4-FFF2-40B4-BE49-F238E27FC236}">
-                <a16:creationId xmlns:a16="http://schemas.microsoft.com/office/drawing/2014/main" id="{CD5AB63D-EA2E-4DA5-93C2-342369E00E00}"/>
+                <a16:creationId xmlns:a16="http://schemas.microsoft.com/office/drawing/2014/main" id="{BAF262D9-C084-4734-831B-39C50FCA404A}"/>
               </a:ext>
             </a:extLst>
           </p:cNvPr>
@@ -8052,7 +8052,7 @@
           <p:cNvPr id="12" name="TextBox 12">
             <a:extLst xmlns:a="http://schemas.openxmlformats.org/drawingml/2006/main">
               <a:ext uri="{FF2B5EF4-FFF2-40B4-BE49-F238E27FC236}">
-                <a16:creationId xmlns:a16="http://schemas.microsoft.com/office/drawing/2014/main" id="{862065D4-7DC3-4D40-9A99-2D3B9C1C3271}"/>
+                <a16:creationId xmlns:a16="http://schemas.microsoft.com/office/drawing/2014/main" id="{AA36B807-E42B-4B01-A0F7-55E25FFA9664}"/>
               </a:ext>
             </a:extLst>
           </p:cNvPr>
@@ -8213,7 +8213,7 @@
           <p:cNvPr id="13" name="TextBox 13">
             <a:extLst xmlns:a="http://schemas.openxmlformats.org/drawingml/2006/main">
               <a:ext uri="{FF2B5EF4-FFF2-40B4-BE49-F238E27FC236}">
-                <a16:creationId xmlns:a16="http://schemas.microsoft.com/office/drawing/2014/main" id="{2905857B-A38A-4408-899A-E5EA9755C1BD}"/>
+                <a16:creationId xmlns:a16="http://schemas.microsoft.com/office/drawing/2014/main" id="{14482A6B-6066-4534-837A-002A9484FFE8}"/>
               </a:ext>
             </a:extLst>
           </p:cNvPr>
@@ -8264,7 +8264,7 @@
           <p:cNvPr id="14" name="TextBox 14">
             <a:extLst xmlns:a="http://schemas.openxmlformats.org/drawingml/2006/main">
               <a:ext uri="{FF2B5EF4-FFF2-40B4-BE49-F238E27FC236}">
-                <a16:creationId xmlns:a16="http://schemas.microsoft.com/office/drawing/2014/main" id="{B68949A4-ADD8-4225-8107-8001F93078B6}"/>
+                <a16:creationId xmlns:a16="http://schemas.microsoft.com/office/drawing/2014/main" id="{ED35B51D-55A2-413A-B439-899A35935D2A}"/>
               </a:ext>
             </a:extLst>
           </p:cNvPr>
@@ -8316,7 +8316,7 @@
           <p:cNvPr id="16" name="Freeform 16">
             <a:extLst xmlns:a="http://schemas.openxmlformats.org/drawingml/2006/main">
               <a:ext uri="{FF2B5EF4-FFF2-40B4-BE49-F238E27FC236}">
-                <a16:creationId xmlns:a16="http://schemas.microsoft.com/office/drawing/2014/main" id="{1E9192C2-9767-4458-9F7C-6C92466B593C}"/>
+                <a16:creationId xmlns:a16="http://schemas.microsoft.com/office/drawing/2014/main" id="{AD27B265-C94C-41BF-93CB-B851B2772DBC}"/>
               </a:ext>
             </a:extLst>
           </p:cNvPr>
@@ -8361,7 +8361,7 @@
           <p:cNvPr id="17" name="內容_10_關鍵發現">
             <a:extLst xmlns:a="http://schemas.openxmlformats.org/drawingml/2006/main">
               <a:ext uri="{FF2B5EF4-FFF2-40B4-BE49-F238E27FC236}">
-                <a16:creationId xmlns:a16="http://schemas.microsoft.com/office/drawing/2014/main" id="{589A8567-A3E7-40E2-9B71-429DE767EFC6}"/>
+                <a16:creationId xmlns:a16="http://schemas.microsoft.com/office/drawing/2014/main" id="{ED28A3B8-CC71-4BF8-90BE-AF1F4930FE47}"/>
               </a:ext>
             </a:extLst>
           </p:cNvPr>
@@ -8519,7 +8519,7 @@
           <p:cNvPr id="18" name="內容_10_只加8公尺不夠，聯合控制才有">
             <a:extLst xmlns:a="http://schemas.openxmlformats.org/drawingml/2006/main">
               <a:ext uri="{FF2B5EF4-FFF2-40B4-BE49-F238E27FC236}">
-                <a16:creationId xmlns:a16="http://schemas.microsoft.com/office/drawing/2014/main" id="{03837F55-8F86-4F91-A94D-0C1CA9C6AEE5}"/>
+                <a16:creationId xmlns:a16="http://schemas.microsoft.com/office/drawing/2014/main" id="{A1770B33-E149-4BEA-AF4B-7DA80D868ACD}"/>
               </a:ext>
             </a:extLst>
           </p:cNvPr>
@@ -8677,7 +8677,7 @@
           <p:cNvPr id="19" name="Chart">
             <a:extLst xmlns:a="http://schemas.openxmlformats.org/drawingml/2006/main">
               <a:ext uri="{FF2B5EF4-FFF2-40B4-BE49-F238E27FC236}">
-                <a16:creationId xmlns:a16="http://schemas.microsoft.com/office/drawing/2014/main" id="{FEEEE8CD-EF02-4900-910F-1AB0DEC65554}"/>
+                <a16:creationId xmlns:a16="http://schemas.microsoft.com/office/drawing/2014/main" id="{DF3ED47B-2A78-406C-B5B7-439175DBAAF7}"/>
               </a:ext>
             </a:extLst>
           </p:cNvPr>
@@ -8690,7 +8690,7 @@
         </p:xfrm>
         <a:graphic xmlns:a="http://schemas.openxmlformats.org/drawingml/2006/main">
           <a:graphicData uri="http://schemas.openxmlformats.org/drawingml/2006/chart">
-            <c:chart xmlns:r="http://schemas.openxmlformats.org/officeDocument/2006/relationships" xmlns:c="http://schemas.openxmlformats.org/drawingml/2006/chart" r:id="Rf5b93fd8da2e489c"/>
+            <c:chart xmlns:r="http://schemas.openxmlformats.org/officeDocument/2006/relationships" xmlns:c="http://schemas.openxmlformats.org/drawingml/2006/chart" r:id="R3b4652f0c67847fd"/>
           </a:graphicData>
         </a:graphic>
       </p:graphicFrame>
@@ -8699,7 +8699,7 @@
           <p:cNvPr id="20" name="Chart">
             <a:extLst xmlns:a="http://schemas.openxmlformats.org/drawingml/2006/main">
               <a:ext uri="{FF2B5EF4-FFF2-40B4-BE49-F238E27FC236}">
-                <a16:creationId xmlns:a16="http://schemas.microsoft.com/office/drawing/2014/main" id="{88408CE9-D891-4E47-BE43-5D9CCFA60A1D}"/>
+                <a16:creationId xmlns:a16="http://schemas.microsoft.com/office/drawing/2014/main" id="{2E6AC4FB-BC3D-45C1-BE76-7B7D5E379FDC}"/>
               </a:ext>
             </a:extLst>
           </p:cNvPr>
@@ -8712,16 +8712,16 @@
         </p:xfrm>
         <a:graphic xmlns:a="http://schemas.openxmlformats.org/drawingml/2006/main">
           <a:graphicData uri="http://schemas.openxmlformats.org/drawingml/2006/chart">
-            <c:chart xmlns:r="http://schemas.openxmlformats.org/officeDocument/2006/relationships" xmlns:c="http://schemas.openxmlformats.org/drawingml/2006/chart" r:id="R6cf185952f324630"/>
+            <c:chart xmlns:r="http://schemas.openxmlformats.org/officeDocument/2006/relationships" xmlns:c="http://schemas.openxmlformats.org/drawingml/2006/chart" r:id="R157ea65d73cb44ea"/>
           </a:graphicData>
         </a:graphic>
       </p:graphicFrame>
       <p:sp>
         <p:nvSpPr>
-          <p:cNvPr id="21" name="內容_10_僅加8公尺緩衝的阻塞仍7.6">
+          <p:cNvPr id="21" name="內容_10_短波尖峰情境（S1）；現況（">
             <a:extLst xmlns:a="http://schemas.openxmlformats.org/drawingml/2006/main">
               <a:ext uri="{FF2B5EF4-FFF2-40B4-BE49-F238E27FC236}">
-                <a16:creationId xmlns:a16="http://schemas.microsoft.com/office/drawing/2014/main" id="{B4513D19-B656-4A78-8757-4DF6DF0C6FD5}"/>
+                <a16:creationId xmlns:a16="http://schemas.microsoft.com/office/drawing/2014/main" id="{8AC9BDFF-5EF1-415F-9E57-DE99875CB58A}"/>
               </a:ext>
             </a:extLst>
           </p:cNvPr>
@@ -8869,7 +8869,7 @@
                 <a:ea typeface="Microsoft JhengHei"/>
                 <a:cs typeface="Microsoft JhengHei"/>
               </a:rPr>
-              <a:t>僅加8公尺緩衝的阻塞仍7.609%，未達1%。聯合方案含支援與外包，不能把效果都算成人力。</a:t>
+              <a:t>短波尖峰情境（S1）；現況（P0）、僅加緩衝（P2）、聯合改善（P4）。僅加8公尺仍未達標。</a:t>
             </a:r>
           </a:p>
         </p:txBody>
@@ -8877,7 +8877,7 @@
     </p:spTree>
     <p:extLst>
       <p:ext uri="{BB962C8B-B14F-4D97-AF65-F5344CB8AC3E}">
-        <p14:creationId xmlns:p14="http://schemas.microsoft.com/office/powerpoint/2010/main" val="732914813"/>
+        <p14:creationId xmlns:p14="http://schemas.microsoft.com/office/powerpoint/2010/main" val="2105048793"/>
       </p:ext>
     </p:extLst>
   </p:cSld>
@@ -8901,7 +8901,7 @@
           <p:cNvPr id="2" name="Freeform 2">
             <a:extLst xmlns:a="http://schemas.openxmlformats.org/drawingml/2006/main">
               <a:ext uri="{FF2B5EF4-FFF2-40B4-BE49-F238E27FC236}">
-                <a16:creationId xmlns:a16="http://schemas.microsoft.com/office/drawing/2014/main" id="{067CD3AA-CA13-44BE-AB96-78B49AECE230}"/>
+                <a16:creationId xmlns:a16="http://schemas.microsoft.com/office/drawing/2014/main" id="{634ADACA-BC0C-40A6-875B-0020F541D394}"/>
               </a:ext>
             </a:extLst>
           </p:cNvPr>
@@ -8939,7 +8939,7 @@
             </a:pathLst>
           </a:custGeom>
           <a:blipFill xmlns:a="http://schemas.openxmlformats.org/drawingml/2006/main">
-            <a:blip xmlns:r="http://schemas.openxmlformats.org/officeDocument/2006/relationships" r:embed="R9a4aa51d6db747e0"/>
+            <a:blip xmlns:r="http://schemas.openxmlformats.org/officeDocument/2006/relationships" r:embed="R51e4930a0ae54fc7"/>
             <a:stretch>
               <a:fillRect l="-35258" t="-5555" r="-24931" b="-72434"/>
             </a:stretch>
@@ -8951,7 +8951,7 @@
           <p:cNvPr id="4" name="Freeform 4">
             <a:extLst xmlns:a="http://schemas.openxmlformats.org/drawingml/2006/main">
               <a:ext uri="{FF2B5EF4-FFF2-40B4-BE49-F238E27FC236}">
-                <a16:creationId xmlns:a16="http://schemas.microsoft.com/office/drawing/2014/main" id="{2E4ABCDE-D84F-4D48-BF00-3F8EC27CB0C9}"/>
+                <a16:creationId xmlns:a16="http://schemas.microsoft.com/office/drawing/2014/main" id="{3C82EFFD-EE96-4EC8-AC57-A56C15F38641}"/>
               </a:ext>
             </a:extLst>
           </p:cNvPr>
@@ -9025,7 +9025,7 @@
           <p:cNvPr id="5" name="TextBox 5">
             <a:extLst xmlns:a="http://schemas.openxmlformats.org/drawingml/2006/main">
               <a:ext uri="{FF2B5EF4-FFF2-40B4-BE49-F238E27FC236}">
-                <a16:creationId xmlns:a16="http://schemas.microsoft.com/office/drawing/2014/main" id="{7C86BB20-4DA7-4A6E-AD36-B92C814C7D23}"/>
+                <a16:creationId xmlns:a16="http://schemas.microsoft.com/office/drawing/2014/main" id="{2AD50E75-50D0-4E3F-8584-545AD59C9697}"/>
               </a:ext>
             </a:extLst>
           </p:cNvPr>
@@ -9061,7 +9061,7 @@
           <p:cNvPr id="6" name="Freeform 6">
             <a:extLst xmlns:a="http://schemas.openxmlformats.org/drawingml/2006/main">
               <a:ext uri="{FF2B5EF4-FFF2-40B4-BE49-F238E27FC236}">
-                <a16:creationId xmlns:a16="http://schemas.microsoft.com/office/drawing/2014/main" id="{DDCFBCA0-EC09-43CA-A67C-38F34A6F923C}"/>
+                <a16:creationId xmlns:a16="http://schemas.microsoft.com/office/drawing/2014/main" id="{DDC7E139-F618-464A-B6AB-F9BCA02A561D}"/>
               </a:ext>
             </a:extLst>
           </p:cNvPr>
@@ -9099,7 +9099,7 @@
             </a:pathLst>
           </a:custGeom>
           <a:blipFill xmlns:a="http://schemas.openxmlformats.org/drawingml/2006/main">
-            <a:blip xmlns:r="http://schemas.openxmlformats.org/officeDocument/2006/relationships" r:embed="R92728691a5914c66"/>
+            <a:blip xmlns:r="http://schemas.openxmlformats.org/officeDocument/2006/relationships" r:embed="R752cb0d77f33468b"/>
             <a:stretch>
               <a:fillRect l="0" t="0" r="0" b="0"/>
             </a:stretch>
@@ -9111,7 +9111,7 @@
           <p:cNvPr id="7" name="Freeform 7">
             <a:extLst xmlns:a="http://schemas.openxmlformats.org/drawingml/2006/main">
               <a:ext uri="{FF2B5EF4-FFF2-40B4-BE49-F238E27FC236}">
-                <a16:creationId xmlns:a16="http://schemas.microsoft.com/office/drawing/2014/main" id="{376F8760-E336-408F-A747-098A2E522296}"/>
+                <a16:creationId xmlns:a16="http://schemas.microsoft.com/office/drawing/2014/main" id="{EF47C1AC-F5CC-4AF6-AF16-861D64B9308E}"/>
               </a:ext>
             </a:extLst>
           </p:cNvPr>
@@ -9149,10 +9149,10 @@
             </a:pathLst>
           </a:custGeom>
           <a:blipFill xmlns:a="http://schemas.openxmlformats.org/drawingml/2006/main">
-            <a:blip xmlns:r="http://schemas.openxmlformats.org/officeDocument/2006/relationships" r:embed="Re3384580e27d4b33">
+            <a:blip xmlns:r="http://schemas.openxmlformats.org/officeDocument/2006/relationships" r:embed="R8bdf5283835944bc">
               <a:extLst>
                 <a:ext uri="{96DAC541-7B7A-43D3-8B79-37D633B846F1}">
-                  <asvg:svgBlip xmlns:asvg="http://schemas.microsoft.com/office/drawing/2016/SVG/main" r:embed="R9ec6d6a4a57d498f"/>
+                  <asvg:svgBlip xmlns:asvg="http://schemas.microsoft.com/office/drawing/2016/SVG/main" r:embed="R10e4827af7f24897"/>
                 </a:ext>
               </a:extLst>
             </a:blip>
@@ -9167,7 +9167,7 @@
           <p:cNvPr id="8" name="Freeform 8">
             <a:extLst xmlns:a="http://schemas.openxmlformats.org/drawingml/2006/main">
               <a:ext uri="{FF2B5EF4-FFF2-40B4-BE49-F238E27FC236}">
-                <a16:creationId xmlns:a16="http://schemas.microsoft.com/office/drawing/2014/main" id="{B5E025A3-0F63-48D2-B57F-298AA14AC8EE}"/>
+                <a16:creationId xmlns:a16="http://schemas.microsoft.com/office/drawing/2014/main" id="{A41A37C4-2E6C-49BA-B20E-929EFB642C2D}"/>
               </a:ext>
             </a:extLst>
           </p:cNvPr>
@@ -9205,10 +9205,10 @@
             </a:pathLst>
           </a:custGeom>
           <a:blipFill xmlns:a="http://schemas.openxmlformats.org/drawingml/2006/main">
-            <a:blip xmlns:r="http://schemas.openxmlformats.org/officeDocument/2006/relationships" r:embed="Re3384580e27d4b33">
+            <a:blip xmlns:r="http://schemas.openxmlformats.org/officeDocument/2006/relationships" r:embed="R8bdf5283835944bc">
               <a:extLst>
                 <a:ext uri="{96DAC541-7B7A-43D3-8B79-37D633B846F1}">
-                  <asvg:svgBlip xmlns:asvg="http://schemas.microsoft.com/office/drawing/2016/SVG/main" r:embed="R9ec6d6a4a57d498f"/>
+                  <asvg:svgBlip xmlns:asvg="http://schemas.microsoft.com/office/drawing/2016/SVG/main" r:embed="R10e4827af7f24897"/>
                 </a:ext>
               </a:extLst>
             </a:blip>
@@ -9223,7 +9223,7 @@
           <p:cNvPr id="10" name="Freeform 10">
             <a:extLst xmlns:a="http://schemas.openxmlformats.org/drawingml/2006/main">
               <a:ext uri="{FF2B5EF4-FFF2-40B4-BE49-F238E27FC236}">
-                <a16:creationId xmlns:a16="http://schemas.microsoft.com/office/drawing/2014/main" id="{C3CF0EC4-C002-4F23-8B7B-6789C139EBB2}"/>
+                <a16:creationId xmlns:a16="http://schemas.microsoft.com/office/drawing/2014/main" id="{0268D963-39CB-4757-8AB4-66F988432C8C}"/>
               </a:ext>
             </a:extLst>
           </p:cNvPr>
@@ -9289,7 +9289,7 @@
           <p:cNvPr id="11" name="Freeform 11">
             <a:extLst xmlns:a="http://schemas.openxmlformats.org/drawingml/2006/main">
               <a:ext uri="{FF2B5EF4-FFF2-40B4-BE49-F238E27FC236}">
-                <a16:creationId xmlns:a16="http://schemas.microsoft.com/office/drawing/2014/main" id="{D566D8A1-C9B6-49A4-8862-EFA63A3B8A1E}"/>
+                <a16:creationId xmlns:a16="http://schemas.microsoft.com/office/drawing/2014/main" id="{16CE1BD5-0360-4567-8084-CA62596187FC}"/>
               </a:ext>
             </a:extLst>
           </p:cNvPr>
@@ -9355,7 +9355,7 @@
           <p:cNvPr id="12" name="Freeform 12">
             <a:extLst xmlns:a="http://schemas.openxmlformats.org/drawingml/2006/main">
               <a:ext uri="{FF2B5EF4-FFF2-40B4-BE49-F238E27FC236}">
-                <a16:creationId xmlns:a16="http://schemas.microsoft.com/office/drawing/2014/main" id="{5B90552F-8BEF-43A8-91C2-BE234163D233}"/>
+                <a16:creationId xmlns:a16="http://schemas.microsoft.com/office/drawing/2014/main" id="{CADE7767-BBCF-498B-99CF-C01444560C53}"/>
               </a:ext>
             </a:extLst>
           </p:cNvPr>
@@ -9421,7 +9421,7 @@
           <p:cNvPr id="14" name="Freeform 14">
             <a:extLst xmlns:a="http://schemas.openxmlformats.org/drawingml/2006/main">
               <a:ext uri="{FF2B5EF4-FFF2-40B4-BE49-F238E27FC236}">
-                <a16:creationId xmlns:a16="http://schemas.microsoft.com/office/drawing/2014/main" id="{5542C6C3-16DF-4060-96CD-65CCC62327F8}"/>
+                <a16:creationId xmlns:a16="http://schemas.microsoft.com/office/drawing/2014/main" id="{636A647E-C913-4432-B696-3AC51226A9D5}"/>
               </a:ext>
             </a:extLst>
           </p:cNvPr>
@@ -9487,7 +9487,7 @@
           <p:cNvPr id="15" name="Freeform 15">
             <a:extLst xmlns:a="http://schemas.openxmlformats.org/drawingml/2006/main">
               <a:ext uri="{FF2B5EF4-FFF2-40B4-BE49-F238E27FC236}">
-                <a16:creationId xmlns:a16="http://schemas.microsoft.com/office/drawing/2014/main" id="{5D63043E-B8A8-42A1-B12A-BAC4BDD02539}"/>
+                <a16:creationId xmlns:a16="http://schemas.microsoft.com/office/drawing/2014/main" id="{F110EB8E-04AA-4F7A-9AC1-F1AD2347D312}"/>
               </a:ext>
             </a:extLst>
           </p:cNvPr>
@@ -9553,7 +9553,7 @@
           <p:cNvPr id="16" name="Freeform 16">
             <a:extLst xmlns:a="http://schemas.openxmlformats.org/drawingml/2006/main">
               <a:ext uri="{FF2B5EF4-FFF2-40B4-BE49-F238E27FC236}">
-                <a16:creationId xmlns:a16="http://schemas.microsoft.com/office/drawing/2014/main" id="{78E50DD1-A963-4800-B359-8A4F860A6D06}"/>
+                <a16:creationId xmlns:a16="http://schemas.microsoft.com/office/drawing/2014/main" id="{84D4DF41-D759-49DF-8817-D67046F836B1}"/>
               </a:ext>
             </a:extLst>
           </p:cNvPr>
@@ -9619,7 +9619,7 @@
           <p:cNvPr id="18" name="Freeform 18">
             <a:extLst xmlns:a="http://schemas.openxmlformats.org/drawingml/2006/main">
               <a:ext uri="{FF2B5EF4-FFF2-40B4-BE49-F238E27FC236}">
-                <a16:creationId xmlns:a16="http://schemas.microsoft.com/office/drawing/2014/main" id="{436CE8BD-5549-437B-9290-10F1F5E60A99}"/>
+                <a16:creationId xmlns:a16="http://schemas.microsoft.com/office/drawing/2014/main" id="{5286E870-C520-4DF0-98E6-1BDD7CF1DFD5}"/>
               </a:ext>
             </a:extLst>
           </p:cNvPr>
@@ -9664,7 +9664,7 @@
           <p:cNvPr id="19" name="TextBox 19">
             <a:extLst xmlns:a="http://schemas.openxmlformats.org/drawingml/2006/main">
               <a:ext uri="{FF2B5EF4-FFF2-40B4-BE49-F238E27FC236}">
-                <a16:creationId xmlns:a16="http://schemas.microsoft.com/office/drawing/2014/main" id="{89124E28-569B-4D01-9DB3-F6586B77229C}"/>
+                <a16:creationId xmlns:a16="http://schemas.microsoft.com/office/drawing/2014/main" id="{0E7B3F4D-C138-4883-9355-E902083020A4}"/>
               </a:ext>
             </a:extLst>
           </p:cNvPr>
@@ -9704,7 +9704,7 @@
           <p:cNvPr id="20" name="TextBox 20">
             <a:extLst xmlns:a="http://schemas.openxmlformats.org/drawingml/2006/main">
               <a:ext uri="{FF2B5EF4-FFF2-40B4-BE49-F238E27FC236}">
-                <a16:creationId xmlns:a16="http://schemas.microsoft.com/office/drawing/2014/main" id="{B72E7D01-9180-43B9-B566-9D07FCD658D2}"/>
+                <a16:creationId xmlns:a16="http://schemas.microsoft.com/office/drawing/2014/main" id="{6DF1B052-27BD-405E-A365-429D298CF536}"/>
               </a:ext>
             </a:extLst>
           </p:cNvPr>
@@ -9865,7 +9865,7 @@
           <p:cNvPr id="21" name="TextBox 21">
             <a:extLst xmlns:a="http://schemas.openxmlformats.org/drawingml/2006/main">
               <a:ext uri="{FF2B5EF4-FFF2-40B4-BE49-F238E27FC236}">
-                <a16:creationId xmlns:a16="http://schemas.microsoft.com/office/drawing/2014/main" id="{1BB5ED1B-49DC-412E-B2D8-E1BCD2491C40}"/>
+                <a16:creationId xmlns:a16="http://schemas.microsoft.com/office/drawing/2014/main" id="{301E0083-C78B-40C2-A0C6-5F08DFAE2C4A}"/>
               </a:ext>
             </a:extLst>
           </p:cNvPr>
@@ -9919,7 +9919,7 @@
           <p:cNvPr id="22" name="TextBox 22">
             <a:extLst xmlns:a="http://schemas.openxmlformats.org/drawingml/2006/main">
               <a:ext uri="{FF2B5EF4-FFF2-40B4-BE49-F238E27FC236}">
-                <a16:creationId xmlns:a16="http://schemas.microsoft.com/office/drawing/2014/main" id="{75DC57AA-8871-4E0A-9F2D-E86CF86F6952}"/>
+                <a16:creationId xmlns:a16="http://schemas.microsoft.com/office/drawing/2014/main" id="{EFF7BFF4-1C02-4A14-85A0-7B628FC61C53}"/>
               </a:ext>
             </a:extLst>
           </p:cNvPr>
@@ -9971,7 +9971,7 @@
           <p:cNvPr id="23" name="TextBox 23">
             <a:extLst xmlns:a="http://schemas.openxmlformats.org/drawingml/2006/main">
               <a:ext uri="{FF2B5EF4-FFF2-40B4-BE49-F238E27FC236}">
-                <a16:creationId xmlns:a16="http://schemas.microsoft.com/office/drawing/2014/main" id="{D677529C-7AE4-4A83-8216-596E6577F367}"/>
+                <a16:creationId xmlns:a16="http://schemas.microsoft.com/office/drawing/2014/main" id="{847F8F48-D724-479C-9390-AD32BE96B148}"/>
               </a:ext>
             </a:extLst>
           </p:cNvPr>
@@ -10023,7 +10023,7 @@
           <p:cNvPr id="24" name="TextBox 24">
             <a:extLst xmlns:a="http://schemas.openxmlformats.org/drawingml/2006/main">
               <a:ext uri="{FF2B5EF4-FFF2-40B4-BE49-F238E27FC236}">
-                <a16:creationId xmlns:a16="http://schemas.microsoft.com/office/drawing/2014/main" id="{D3EBF3A5-5A1F-4A52-BD0F-42748C9FB5AA}"/>
+                <a16:creationId xmlns:a16="http://schemas.microsoft.com/office/drawing/2014/main" id="{AEE81234-F17E-4329-9253-E68B8C8C236C}"/>
               </a:ext>
             </a:extLst>
           </p:cNvPr>
@@ -10072,7 +10072,7 @@
           <p:cNvPr id="25" name="TextBox 25">
             <a:extLst xmlns:a="http://schemas.openxmlformats.org/drawingml/2006/main">
               <a:ext uri="{FF2B5EF4-FFF2-40B4-BE49-F238E27FC236}">
-                <a16:creationId xmlns:a16="http://schemas.microsoft.com/office/drawing/2014/main" id="{034DA127-49B7-42F1-AD04-42EC0DC1BCC9}"/>
+                <a16:creationId xmlns:a16="http://schemas.microsoft.com/office/drawing/2014/main" id="{3C0CB8E7-D299-4849-B7FD-75713D6D8A6E}"/>
               </a:ext>
             </a:extLst>
           </p:cNvPr>
@@ -10124,7 +10124,7 @@
           <p:cNvPr id="27" name="Freeform 27">
             <a:extLst xmlns:a="http://schemas.openxmlformats.org/drawingml/2006/main">
               <a:ext uri="{FF2B5EF4-FFF2-40B4-BE49-F238E27FC236}">
-                <a16:creationId xmlns:a16="http://schemas.microsoft.com/office/drawing/2014/main" id="{BD085A2E-CD16-4916-9710-D93011E5F933}"/>
+                <a16:creationId xmlns:a16="http://schemas.microsoft.com/office/drawing/2014/main" id="{09D518D5-B8DC-4C27-B98A-D32DDF67495C}"/>
               </a:ext>
             </a:extLst>
           </p:cNvPr>
@@ -10169,7 +10169,7 @@
           <p:cNvPr id="28" name="TextBox 28">
             <a:extLst xmlns:a="http://schemas.openxmlformats.org/drawingml/2006/main">
               <a:ext uri="{FF2B5EF4-FFF2-40B4-BE49-F238E27FC236}">
-                <a16:creationId xmlns:a16="http://schemas.microsoft.com/office/drawing/2014/main" id="{63F4ADCA-A5B2-4F77-A0CE-AA601FE0143A}"/>
+                <a16:creationId xmlns:a16="http://schemas.microsoft.com/office/drawing/2014/main" id="{102CECA3-7A9B-4521-9E2E-A4636BAB0B5C}"/>
               </a:ext>
             </a:extLst>
           </p:cNvPr>
@@ -10209,7 +10209,7 @@
           <p:cNvPr id="29" name="TextBox 29">
             <a:extLst xmlns:a="http://schemas.openxmlformats.org/drawingml/2006/main">
               <a:ext uri="{FF2B5EF4-FFF2-40B4-BE49-F238E27FC236}">
-                <a16:creationId xmlns:a16="http://schemas.microsoft.com/office/drawing/2014/main" id="{3FF30D5C-37F8-45DF-9421-CFFC7EF3D0BB}"/>
+                <a16:creationId xmlns:a16="http://schemas.microsoft.com/office/drawing/2014/main" id="{8C76406D-6194-4BE5-8B2F-65EE0BF4C04F}"/>
               </a:ext>
             </a:extLst>
           </p:cNvPr>
@@ -10258,7 +10258,7 @@
           <p:cNvPr id="30" name="TextBox 30">
             <a:extLst xmlns:a="http://schemas.openxmlformats.org/drawingml/2006/main">
               <a:ext uri="{FF2B5EF4-FFF2-40B4-BE49-F238E27FC236}">
-                <a16:creationId xmlns:a16="http://schemas.microsoft.com/office/drawing/2014/main" id="{94D8DFBE-DDFD-4864-A3F8-21CD48113FE7}"/>
+                <a16:creationId xmlns:a16="http://schemas.microsoft.com/office/drawing/2014/main" id="{91B98A1A-A9B5-429C-AF29-04ED10055695}"/>
               </a:ext>
             </a:extLst>
           </p:cNvPr>
@@ -10310,7 +10310,7 @@
           <p:cNvPr id="31" name="內容_11_改善方案的實驗比較">
             <a:extLst xmlns:a="http://schemas.openxmlformats.org/drawingml/2006/main">
               <a:ext uri="{FF2B5EF4-FFF2-40B4-BE49-F238E27FC236}">
-                <a16:creationId xmlns:a16="http://schemas.microsoft.com/office/drawing/2014/main" id="{D9D9BF9E-6B43-4E39-95D4-9CE0E099A5F5}"/>
+                <a16:creationId xmlns:a16="http://schemas.microsoft.com/office/drawing/2014/main" id="{96019FC4-6853-4445-8EDC-45766785CFCF}"/>
               </a:ext>
             </a:extLst>
           </p:cNvPr>
@@ -10468,7 +10468,7 @@
           <p:cNvPr id="32" name="內容_11_緩衝與調派必須一起評估">
             <a:extLst xmlns:a="http://schemas.openxmlformats.org/drawingml/2006/main">
               <a:ext uri="{FF2B5EF4-FFF2-40B4-BE49-F238E27FC236}">
-                <a16:creationId xmlns:a16="http://schemas.microsoft.com/office/drawing/2014/main" id="{8B38E5F0-262E-472B-A1E9-DB22E1086E77}"/>
+                <a16:creationId xmlns:a16="http://schemas.microsoft.com/office/drawing/2014/main" id="{D57123C4-FDB6-4CF2-BBA3-9865BE89FAA5}"/>
               </a:ext>
             </a:extLst>
           </p:cNvPr>
@@ -10626,7 +10626,7 @@
           <p:cNvPr id="33" name="Chart">
             <a:extLst xmlns:a="http://schemas.openxmlformats.org/drawingml/2006/main">
               <a:ext uri="{FF2B5EF4-FFF2-40B4-BE49-F238E27FC236}">
-                <a16:creationId xmlns:a16="http://schemas.microsoft.com/office/drawing/2014/main" id="{C83EFFF2-1534-424F-9C92-B969A68DBA4C}"/>
+                <a16:creationId xmlns:a16="http://schemas.microsoft.com/office/drawing/2014/main" id="{0007E567-096A-4407-A980-2D1B008D07F2}"/>
               </a:ext>
             </a:extLst>
           </p:cNvPr>
@@ -10639,7 +10639,7 @@
         </p:xfrm>
         <a:graphic xmlns:a="http://schemas.openxmlformats.org/drawingml/2006/main">
           <a:graphicData uri="http://schemas.openxmlformats.org/drawingml/2006/chart">
-            <c:chart xmlns:r="http://schemas.openxmlformats.org/officeDocument/2006/relationships" xmlns:c="http://schemas.openxmlformats.org/drawingml/2006/chart" r:id="R5e1833d6ebaf405f"/>
+            <c:chart xmlns:r="http://schemas.openxmlformats.org/officeDocument/2006/relationships" xmlns:c="http://schemas.openxmlformats.org/drawingml/2006/chart" r:id="R47b70b3d5f474e26"/>
           </a:graphicData>
         </a:graphic>
       </p:graphicFrame>
@@ -10648,7 +10648,7 @@
           <p:cNvPr id="34" name="內容_11_3種情境 × 15種處方／長">
             <a:extLst xmlns:a="http://schemas.openxmlformats.org/drawingml/2006/main">
               <a:ext uri="{FF2B5EF4-FFF2-40B4-BE49-F238E27FC236}">
-                <a16:creationId xmlns:a16="http://schemas.microsoft.com/office/drawing/2014/main" id="{225EAE23-D5C8-456E-B577-00B9458D811A}"/>
+                <a16:creationId xmlns:a16="http://schemas.microsoft.com/office/drawing/2014/main" id="{E301F862-5F90-4655-AB3E-ADA4CB5F8395}"/>
               </a:ext>
             </a:extLst>
           </p:cNvPr>
@@ -10804,7 +10804,7 @@
     </p:spTree>
     <p:extLst>
       <p:ext uri="{BB962C8B-B14F-4D97-AF65-F5344CB8AC3E}">
-        <p14:creationId xmlns:p14="http://schemas.microsoft.com/office/powerpoint/2010/main" val="771388846"/>
+        <p14:creationId xmlns:p14="http://schemas.microsoft.com/office/powerpoint/2010/main" val="925478205"/>
       </p:ext>
     </p:extLst>
   </p:cSld>
@@ -10828,7 +10828,7 @@
           <p:cNvPr id="2" name="Freeform 2">
             <a:extLst xmlns:a="http://schemas.openxmlformats.org/drawingml/2006/main">
               <a:ext uri="{FF2B5EF4-FFF2-40B4-BE49-F238E27FC236}">
-                <a16:creationId xmlns:a16="http://schemas.microsoft.com/office/drawing/2014/main" id="{2B9A34E2-E98F-4DD3-95E6-FE8223ECE929}"/>
+                <a16:creationId xmlns:a16="http://schemas.microsoft.com/office/drawing/2014/main" id="{5567F26E-B2F6-48DE-B6FC-84E7E5FC02B1}"/>
               </a:ext>
             </a:extLst>
           </p:cNvPr>
@@ -10866,7 +10866,7 @@
             </a:pathLst>
           </a:custGeom>
           <a:blipFill xmlns:a="http://schemas.openxmlformats.org/drawingml/2006/main">
-            <a:blip xmlns:r="http://schemas.openxmlformats.org/officeDocument/2006/relationships" r:embed="R596c2b27dc304ef0"/>
+            <a:blip xmlns:r="http://schemas.openxmlformats.org/officeDocument/2006/relationships" r:embed="R1720538b893d4c4d"/>
             <a:stretch>
               <a:fillRect l="-35258" t="-5555" r="-24931" b="-72434"/>
             </a:stretch>
@@ -10878,7 +10878,7 @@
           <p:cNvPr id="4" name="Freeform 4">
             <a:extLst xmlns:a="http://schemas.openxmlformats.org/drawingml/2006/main">
               <a:ext uri="{FF2B5EF4-FFF2-40B4-BE49-F238E27FC236}">
-                <a16:creationId xmlns:a16="http://schemas.microsoft.com/office/drawing/2014/main" id="{684FEEC4-1B8F-4C3E-9050-1AF39D970468}"/>
+                <a16:creationId xmlns:a16="http://schemas.microsoft.com/office/drawing/2014/main" id="{30058F0E-5F7D-4BA1-A681-728CD298FE69}"/>
               </a:ext>
             </a:extLst>
           </p:cNvPr>
@@ -10952,7 +10952,7 @@
           <p:cNvPr id="5" name="TextBox 5">
             <a:extLst xmlns:a="http://schemas.openxmlformats.org/drawingml/2006/main">
               <a:ext uri="{FF2B5EF4-FFF2-40B4-BE49-F238E27FC236}">
-                <a16:creationId xmlns:a16="http://schemas.microsoft.com/office/drawing/2014/main" id="{EADA0A1C-9873-422D-A35B-2F90364DC59C}"/>
+                <a16:creationId xmlns:a16="http://schemas.microsoft.com/office/drawing/2014/main" id="{96A85D41-5A7B-4E6F-8498-BD49771933BC}"/>
               </a:ext>
             </a:extLst>
           </p:cNvPr>
@@ -10988,7 +10988,7 @@
           <p:cNvPr id="6" name="Freeform 6">
             <a:extLst xmlns:a="http://schemas.openxmlformats.org/drawingml/2006/main">
               <a:ext uri="{FF2B5EF4-FFF2-40B4-BE49-F238E27FC236}">
-                <a16:creationId xmlns:a16="http://schemas.microsoft.com/office/drawing/2014/main" id="{02A79CD8-4E29-4FFD-B168-7D8A5F7FF4F6}"/>
+                <a16:creationId xmlns:a16="http://schemas.microsoft.com/office/drawing/2014/main" id="{E0525A6F-C852-4D2F-AF8F-C7ACCB4813A1}"/>
               </a:ext>
             </a:extLst>
           </p:cNvPr>
@@ -11026,7 +11026,7 @@
             </a:pathLst>
           </a:custGeom>
           <a:blipFill xmlns:a="http://schemas.openxmlformats.org/drawingml/2006/main">
-            <a:blip xmlns:r="http://schemas.openxmlformats.org/officeDocument/2006/relationships" r:embed="Rd83dfc26769046e8"/>
+            <a:blip xmlns:r="http://schemas.openxmlformats.org/officeDocument/2006/relationships" r:embed="Rdb4389401a784ae9"/>
             <a:stretch>
               <a:fillRect l="0" t="0" r="0" b="0"/>
             </a:stretch>
@@ -11038,7 +11038,7 @@
           <p:cNvPr id="8" name="Freeform 8">
             <a:extLst xmlns:a="http://schemas.openxmlformats.org/drawingml/2006/main">
               <a:ext uri="{FF2B5EF4-FFF2-40B4-BE49-F238E27FC236}">
-                <a16:creationId xmlns:a16="http://schemas.microsoft.com/office/drawing/2014/main" id="{E4952800-DFE8-4E37-A977-83DCA3B236CD}"/>
+                <a16:creationId xmlns:a16="http://schemas.microsoft.com/office/drawing/2014/main" id="{A6B43337-207D-403A-BDBC-3D5DB12422FE}"/>
               </a:ext>
             </a:extLst>
           </p:cNvPr>
@@ -11097,7 +11097,7 @@
           <p:cNvPr id="9" name="TextBox 9">
             <a:extLst xmlns:a="http://schemas.openxmlformats.org/drawingml/2006/main">
               <a:ext uri="{FF2B5EF4-FFF2-40B4-BE49-F238E27FC236}">
-                <a16:creationId xmlns:a16="http://schemas.microsoft.com/office/drawing/2014/main" id="{F3615ACB-F9E0-4AB8-B047-FA2894472A01}"/>
+                <a16:creationId xmlns:a16="http://schemas.microsoft.com/office/drawing/2014/main" id="{3878D39F-8E89-4C31-B4F1-DA509B13CDF8}"/>
               </a:ext>
             </a:extLst>
           </p:cNvPr>
@@ -11137,7 +11137,7 @@
           <p:cNvPr id="10" name="Freeform 10">
             <a:extLst xmlns:a="http://schemas.openxmlformats.org/drawingml/2006/main">
               <a:ext uri="{FF2B5EF4-FFF2-40B4-BE49-F238E27FC236}">
-                <a16:creationId xmlns:a16="http://schemas.microsoft.com/office/drawing/2014/main" id="{D6B15FAF-B63D-445A-A801-00658DA2871F}"/>
+                <a16:creationId xmlns:a16="http://schemas.microsoft.com/office/drawing/2014/main" id="{C4331467-BDF3-4CC5-A5CA-2EA07A5985D9}"/>
               </a:ext>
             </a:extLst>
           </p:cNvPr>
@@ -11185,7 +11185,7 @@
           <p:cNvPr id="12" name="Freeform 12">
             <a:extLst xmlns:a="http://schemas.openxmlformats.org/drawingml/2006/main">
               <a:ext uri="{FF2B5EF4-FFF2-40B4-BE49-F238E27FC236}">
-                <a16:creationId xmlns:a16="http://schemas.microsoft.com/office/drawing/2014/main" id="{3360862A-0F93-40A2-961E-FE9BDADE409A}"/>
+                <a16:creationId xmlns:a16="http://schemas.microsoft.com/office/drawing/2014/main" id="{A2429DCE-F6F1-4B5C-9FD5-8E7F6D81CE66}"/>
               </a:ext>
             </a:extLst>
           </p:cNvPr>
@@ -11244,7 +11244,7 @@
           <p:cNvPr id="13" name="TextBox 13">
             <a:extLst xmlns:a="http://schemas.openxmlformats.org/drawingml/2006/main">
               <a:ext uri="{FF2B5EF4-FFF2-40B4-BE49-F238E27FC236}">
-                <a16:creationId xmlns:a16="http://schemas.microsoft.com/office/drawing/2014/main" id="{42CE6122-343C-4F8C-A2B6-A66C6AE7A8DE}"/>
+                <a16:creationId xmlns:a16="http://schemas.microsoft.com/office/drawing/2014/main" id="{58E3C7B9-167A-4333-B579-DBAB3ED4530B}"/>
               </a:ext>
             </a:extLst>
           </p:cNvPr>
@@ -11284,7 +11284,7 @@
           <p:cNvPr id="14" name="Freeform 14">
             <a:extLst xmlns:a="http://schemas.openxmlformats.org/drawingml/2006/main">
               <a:ext uri="{FF2B5EF4-FFF2-40B4-BE49-F238E27FC236}">
-                <a16:creationId xmlns:a16="http://schemas.microsoft.com/office/drawing/2014/main" id="{CF44FEB9-6801-4D38-A1B6-2F6A0F044D76}"/>
+                <a16:creationId xmlns:a16="http://schemas.microsoft.com/office/drawing/2014/main" id="{8D78BCF3-A4AA-4DA6-B892-A6FE974B8903}"/>
               </a:ext>
             </a:extLst>
           </p:cNvPr>
@@ -11332,7 +11332,7 @@
           <p:cNvPr id="15" name="Freeform 15">
             <a:extLst xmlns:a="http://schemas.openxmlformats.org/drawingml/2006/main">
               <a:ext uri="{FF2B5EF4-FFF2-40B4-BE49-F238E27FC236}">
-                <a16:creationId xmlns:a16="http://schemas.microsoft.com/office/drawing/2014/main" id="{9F638F20-FF79-4E43-832F-7350BF9E033E}"/>
+                <a16:creationId xmlns:a16="http://schemas.microsoft.com/office/drawing/2014/main" id="{88DE9B9F-9373-4E68-BF15-1B689EFA21D1}"/>
               </a:ext>
             </a:extLst>
           </p:cNvPr>
@@ -11380,7 +11380,7 @@
           <p:cNvPr id="16" name="TextBox 16">
             <a:extLst xmlns:a="http://schemas.openxmlformats.org/drawingml/2006/main">
               <a:ext uri="{FF2B5EF4-FFF2-40B4-BE49-F238E27FC236}">
-                <a16:creationId xmlns:a16="http://schemas.microsoft.com/office/drawing/2014/main" id="{7CA4B91F-D025-451C-A883-3305AED3CE04}"/>
+                <a16:creationId xmlns:a16="http://schemas.microsoft.com/office/drawing/2014/main" id="{9DF9D66C-41DA-4A97-9BBE-FCB9FC837BE3}"/>
               </a:ext>
             </a:extLst>
           </p:cNvPr>
@@ -11432,7 +11432,7 @@
           <p:cNvPr id="17" name="TextBox 17">
             <a:extLst xmlns:a="http://schemas.openxmlformats.org/drawingml/2006/main">
               <a:ext uri="{FF2B5EF4-FFF2-40B4-BE49-F238E27FC236}">
-                <a16:creationId xmlns:a16="http://schemas.microsoft.com/office/drawing/2014/main" id="{6ECFE17E-9CC4-4B6E-9C0E-C8041D09A483}"/>
+                <a16:creationId xmlns:a16="http://schemas.microsoft.com/office/drawing/2014/main" id="{28CBBE2E-B993-46FD-AB4F-FB84E14ACC8B}"/>
               </a:ext>
             </a:extLst>
           </p:cNvPr>
@@ -11593,7 +11593,7 @@
           <p:cNvPr id="18" name="TextBox 18">
             <a:extLst xmlns:a="http://schemas.openxmlformats.org/drawingml/2006/main">
               <a:ext uri="{FF2B5EF4-FFF2-40B4-BE49-F238E27FC236}">
-                <a16:creationId xmlns:a16="http://schemas.microsoft.com/office/drawing/2014/main" id="{E8DC47B0-42C6-49DC-B636-C193D3CD14F7}"/>
+                <a16:creationId xmlns:a16="http://schemas.microsoft.com/office/drawing/2014/main" id="{21927A1B-B4E0-49E9-9FF0-6040FEA304DC}"/>
               </a:ext>
             </a:extLst>
           </p:cNvPr>
@@ -11647,7 +11647,7 @@
           <p:cNvPr id="19" name="TextBox 19">
             <a:extLst xmlns:a="http://schemas.openxmlformats.org/drawingml/2006/main">
               <a:ext uri="{FF2B5EF4-FFF2-40B4-BE49-F238E27FC236}">
-                <a16:creationId xmlns:a16="http://schemas.microsoft.com/office/drawing/2014/main" id="{CB3264EA-8C0D-4ABF-AE84-AE6E0D781EEC}"/>
+                <a16:creationId xmlns:a16="http://schemas.microsoft.com/office/drawing/2014/main" id="{4A147D38-718C-4400-8AE0-AB4959067481}"/>
               </a:ext>
             </a:extLst>
           </p:cNvPr>
@@ -11699,7 +11699,7 @@
           <p:cNvPr id="20" name="TextBox 20">
             <a:extLst xmlns:a="http://schemas.openxmlformats.org/drawingml/2006/main">
               <a:ext uri="{FF2B5EF4-FFF2-40B4-BE49-F238E27FC236}">
-                <a16:creationId xmlns:a16="http://schemas.microsoft.com/office/drawing/2014/main" id="{8F7877DF-7E1F-484A-9965-79809C9DC5C6}"/>
+                <a16:creationId xmlns:a16="http://schemas.microsoft.com/office/drawing/2014/main" id="{931AEB59-EC1D-4946-A051-5DF7D8A338D0}"/>
               </a:ext>
             </a:extLst>
           </p:cNvPr>
@@ -11751,7 +11751,7 @@
           <p:cNvPr id="21" name="TextBox 21">
             <a:extLst xmlns:a="http://schemas.openxmlformats.org/drawingml/2006/main">
               <a:ext uri="{FF2B5EF4-FFF2-40B4-BE49-F238E27FC236}">
-                <a16:creationId xmlns:a16="http://schemas.microsoft.com/office/drawing/2014/main" id="{F23AEE0C-31E0-499B-AFE2-FA4CA505B002}"/>
+                <a16:creationId xmlns:a16="http://schemas.microsoft.com/office/drawing/2014/main" id="{E59BB929-BF35-401D-A790-2D126B23CDEA}"/>
               </a:ext>
             </a:extLst>
           </p:cNvPr>
@@ -11803,7 +11803,7 @@
           <p:cNvPr id="22" name="TextBox 22">
             <a:extLst xmlns:a="http://schemas.openxmlformats.org/drawingml/2006/main">
               <a:ext uri="{FF2B5EF4-FFF2-40B4-BE49-F238E27FC236}">
-                <a16:creationId xmlns:a16="http://schemas.microsoft.com/office/drawing/2014/main" id="{11B0A4A3-8903-4B69-8D84-6759DDB33D7F}"/>
+                <a16:creationId xmlns:a16="http://schemas.microsoft.com/office/drawing/2014/main" id="{F4F6C722-42E7-46C5-BA94-567D0B2E6658}"/>
               </a:ext>
             </a:extLst>
           </p:cNvPr>
@@ -11855,7 +11855,7 @@
           <p:cNvPr id="23" name="TextBox 23">
             <a:extLst xmlns:a="http://schemas.openxmlformats.org/drawingml/2006/main">
               <a:ext uri="{FF2B5EF4-FFF2-40B4-BE49-F238E27FC236}">
-                <a16:creationId xmlns:a16="http://schemas.microsoft.com/office/drawing/2014/main" id="{089CE975-1C8A-498C-A630-B7869EB69B5E}"/>
+                <a16:creationId xmlns:a16="http://schemas.microsoft.com/office/drawing/2014/main" id="{B392AF73-E5B9-4F04-A4FE-3D9DE6C77DB8}"/>
               </a:ext>
             </a:extLst>
           </p:cNvPr>
@@ -11907,7 +11907,7 @@
           <p:cNvPr id="24" name="內容_12_主推：聯合改善＋12公尺緩衝">
             <a:extLst xmlns:a="http://schemas.openxmlformats.org/drawingml/2006/main">
               <a:ext uri="{FF2B5EF4-FFF2-40B4-BE49-F238E27FC236}">
-                <a16:creationId xmlns:a16="http://schemas.microsoft.com/office/drawing/2014/main" id="{5C9DD203-4BA0-4DE7-A1B7-A0B0082E836A}"/>
+                <a16:creationId xmlns:a16="http://schemas.microsoft.com/office/drawing/2014/main" id="{230A7A05-4493-4B05-87F4-70A2E4ED767F}"/>
               </a:ext>
             </a:extLst>
           </p:cNvPr>
@@ -12065,7 +12065,7 @@
           <p:cNvPr id="25" name="內容_12_有服務要求才採用，8公尺為備">
             <a:extLst xmlns:a="http://schemas.openxmlformats.org/drawingml/2006/main">
               <a:ext uri="{FF2B5EF4-FFF2-40B4-BE49-F238E27FC236}">
-                <a16:creationId xmlns:a16="http://schemas.microsoft.com/office/drawing/2014/main" id="{E9A6C0F2-69AD-43EA-92A8-259094CA838E}"/>
+                <a16:creationId xmlns:a16="http://schemas.microsoft.com/office/drawing/2014/main" id="{A5FEAB65-2526-4376-B57C-EF781A70BC74}"/>
               </a:ext>
             </a:extLst>
           </p:cNvPr>
@@ -12223,7 +12223,7 @@
           <p:cNvPr id="26" name="">
             <a:extLst xmlns:a="http://schemas.openxmlformats.org/drawingml/2006/main">
               <a:ext uri="{FF2B5EF4-FFF2-40B4-BE49-F238E27FC236}">
-                <a16:creationId xmlns:a16="http://schemas.microsoft.com/office/drawing/2014/main" id="{AB19B044-85C9-4CE0-8C0B-460BCBCA7F28}"/>
+                <a16:creationId xmlns:a16="http://schemas.microsoft.com/office/drawing/2014/main" id="{68F5C192-F1BD-4A33-8676-09B76ECAA20B}"/>
               </a:ext>
             </a:extLst>
           </p:cNvPr>
@@ -13037,7 +13037,7 @@
           <p:cNvPr id="27" name="內容_12_本表是短波尖峰情境；各方案3">
             <a:extLst xmlns:a="http://schemas.openxmlformats.org/drawingml/2006/main">
               <a:ext uri="{FF2B5EF4-FFF2-40B4-BE49-F238E27FC236}">
-                <a16:creationId xmlns:a16="http://schemas.microsoft.com/office/drawing/2014/main" id="{47101364-EF7C-45F3-82EF-94A74985540D}"/>
+                <a16:creationId xmlns:a16="http://schemas.microsoft.com/office/drawing/2014/main" id="{38DDEFC2-CDCF-4DF6-8C80-60ABE471EBD6}"/>
               </a:ext>
             </a:extLst>
           </p:cNvPr>
@@ -13195,7 +13195,7 @@
           <p:cNvPr id="28" name="內容_12_主推12公尺採額外信賴區間上">
             <a:extLst xmlns:a="http://schemas.openxmlformats.org/drawingml/2006/main">
               <a:ext uri="{FF2B5EF4-FFF2-40B4-BE49-F238E27FC236}">
-                <a16:creationId xmlns:a16="http://schemas.microsoft.com/office/drawing/2014/main" id="{78315E8C-6F93-443B-804F-65BF63BF5228}"/>
+                <a16:creationId xmlns:a16="http://schemas.microsoft.com/office/drawing/2014/main" id="{EF4DEDA7-9410-4E39-9793-EE2213A14248}"/>
               </a:ext>
             </a:extLst>
           </p:cNvPr>
@@ -13351,7 +13351,7 @@
     </p:spTree>
     <p:extLst>
       <p:ext uri="{BB962C8B-B14F-4D97-AF65-F5344CB8AC3E}">
-        <p14:creationId xmlns:p14="http://schemas.microsoft.com/office/powerpoint/2010/main" val="87870982"/>
+        <p14:creationId xmlns:p14="http://schemas.microsoft.com/office/powerpoint/2010/main" val="2070118241"/>
       </p:ext>
     </p:extLst>
   </p:cSld>
@@ -13375,7 +13375,7 @@
           <p:cNvPr id="2" name="Freeform 2">
             <a:extLst xmlns:a="http://schemas.openxmlformats.org/drawingml/2006/main">
               <a:ext uri="{FF2B5EF4-FFF2-40B4-BE49-F238E27FC236}">
-                <a16:creationId xmlns:a16="http://schemas.microsoft.com/office/drawing/2014/main" id="{D16E4213-55D5-4D6A-91B1-EF82153DA850}"/>
+                <a16:creationId xmlns:a16="http://schemas.microsoft.com/office/drawing/2014/main" id="{F2F480D8-15F0-4D7C-9490-73F364B54AA5}"/>
               </a:ext>
             </a:extLst>
           </p:cNvPr>
@@ -13413,7 +13413,7 @@
             </a:pathLst>
           </a:custGeom>
           <a:blipFill xmlns:a="http://schemas.openxmlformats.org/drawingml/2006/main">
-            <a:blip xmlns:r="http://schemas.openxmlformats.org/officeDocument/2006/relationships" r:embed="R91ff395e48d148bb"/>
+            <a:blip xmlns:r="http://schemas.openxmlformats.org/officeDocument/2006/relationships" r:embed="R2cd8c87b54d94920"/>
             <a:stretch>
               <a:fillRect l="-35258" t="-5555" r="-24931" b="-72434"/>
             </a:stretch>
@@ -13425,7 +13425,7 @@
           <p:cNvPr id="4" name="Freeform 4">
             <a:extLst xmlns:a="http://schemas.openxmlformats.org/drawingml/2006/main">
               <a:ext uri="{FF2B5EF4-FFF2-40B4-BE49-F238E27FC236}">
-                <a16:creationId xmlns:a16="http://schemas.microsoft.com/office/drawing/2014/main" id="{77C387DD-8787-4F2F-BBEB-9D3AD4B6B187}"/>
+                <a16:creationId xmlns:a16="http://schemas.microsoft.com/office/drawing/2014/main" id="{48061CFB-CE20-4464-972B-A3AE113AB5E7}"/>
               </a:ext>
             </a:extLst>
           </p:cNvPr>
@@ -13499,7 +13499,7 @@
           <p:cNvPr id="5" name="TextBox 5">
             <a:extLst xmlns:a="http://schemas.openxmlformats.org/drawingml/2006/main">
               <a:ext uri="{FF2B5EF4-FFF2-40B4-BE49-F238E27FC236}">
-                <a16:creationId xmlns:a16="http://schemas.microsoft.com/office/drawing/2014/main" id="{D95B309F-5BD9-4584-987D-DD135D52E889}"/>
+                <a16:creationId xmlns:a16="http://schemas.microsoft.com/office/drawing/2014/main" id="{88BA951C-7482-4932-A188-116A959ACCE1}"/>
               </a:ext>
             </a:extLst>
           </p:cNvPr>
@@ -13535,7 +13535,7 @@
           <p:cNvPr id="6" name="Freeform 6">
             <a:extLst xmlns:a="http://schemas.openxmlformats.org/drawingml/2006/main">
               <a:ext uri="{FF2B5EF4-FFF2-40B4-BE49-F238E27FC236}">
-                <a16:creationId xmlns:a16="http://schemas.microsoft.com/office/drawing/2014/main" id="{26539721-88B2-46F2-9655-E672565D775E}"/>
+                <a16:creationId xmlns:a16="http://schemas.microsoft.com/office/drawing/2014/main" id="{BBCD2865-3592-4F8B-B4D0-055081BA4599}"/>
               </a:ext>
             </a:extLst>
           </p:cNvPr>
@@ -13573,7 +13573,7 @@
             </a:pathLst>
           </a:custGeom>
           <a:blipFill xmlns:a="http://schemas.openxmlformats.org/drawingml/2006/main">
-            <a:blip xmlns:r="http://schemas.openxmlformats.org/officeDocument/2006/relationships" r:embed="R374163514b3244fb"/>
+            <a:blip xmlns:r="http://schemas.openxmlformats.org/officeDocument/2006/relationships" r:embed="R0aed0ec5a49b4f1f"/>
             <a:stretch>
               <a:fillRect l="0" t="0" r="0" b="0"/>
             </a:stretch>
@@ -13585,7 +13585,7 @@
           <p:cNvPr id="7" name="TextBox 7">
             <a:extLst xmlns:a="http://schemas.openxmlformats.org/drawingml/2006/main">
               <a:ext uri="{FF2B5EF4-FFF2-40B4-BE49-F238E27FC236}">
-                <a16:creationId xmlns:a16="http://schemas.microsoft.com/office/drawing/2014/main" id="{A152ED35-C196-4918-AC0C-188DBE26B235}"/>
+                <a16:creationId xmlns:a16="http://schemas.microsoft.com/office/drawing/2014/main" id="{796FC870-D1A1-4FE4-B7E8-678B42721C58}"/>
               </a:ext>
             </a:extLst>
           </p:cNvPr>
@@ -13746,7 +13746,7 @@
           <p:cNvPr id="8" name="TextBox 8">
             <a:extLst xmlns:a="http://schemas.openxmlformats.org/drawingml/2006/main">
               <a:ext uri="{FF2B5EF4-FFF2-40B4-BE49-F238E27FC236}">
-                <a16:creationId xmlns:a16="http://schemas.microsoft.com/office/drawing/2014/main" id="{C6B82643-BECB-4475-8717-2A356FEEAF5C}"/>
+                <a16:creationId xmlns:a16="http://schemas.microsoft.com/office/drawing/2014/main" id="{B2179683-B33E-48ED-AFED-84730EDF1284}"/>
               </a:ext>
             </a:extLst>
           </p:cNvPr>
@@ -13800,7 +13800,7 @@
           <p:cNvPr id="9" name="TextBox 9">
             <a:extLst xmlns:a="http://schemas.openxmlformats.org/drawingml/2006/main">
               <a:ext uri="{FF2B5EF4-FFF2-40B4-BE49-F238E27FC236}">
-                <a16:creationId xmlns:a16="http://schemas.microsoft.com/office/drawing/2014/main" id="{3F223F3B-6392-4E63-9D74-9D8D1C21BCCD}"/>
+                <a16:creationId xmlns:a16="http://schemas.microsoft.com/office/drawing/2014/main" id="{33864A15-0227-46AE-B76A-8D34788F6C6F}"/>
               </a:ext>
             </a:extLst>
           </p:cNvPr>
@@ -13852,7 +13852,7 @@
           <p:cNvPr id="10" name="TextBox 10">
             <a:extLst xmlns:a="http://schemas.openxmlformats.org/drawingml/2006/main">
               <a:ext uri="{FF2B5EF4-FFF2-40B4-BE49-F238E27FC236}">
-                <a16:creationId xmlns:a16="http://schemas.microsoft.com/office/drawing/2014/main" id="{21529C91-E416-4366-AA1D-5FAC1C539B85}"/>
+                <a16:creationId xmlns:a16="http://schemas.microsoft.com/office/drawing/2014/main" id="{9F1BCBFE-5FBA-4895-B7A0-87E9729EF8D0}"/>
               </a:ext>
             </a:extLst>
           </p:cNvPr>
@@ -13904,7 +13904,7 @@
           <p:cNvPr id="11" name="TextBox 11">
             <a:extLst xmlns:a="http://schemas.openxmlformats.org/drawingml/2006/main">
               <a:ext uri="{FF2B5EF4-FFF2-40B4-BE49-F238E27FC236}">
-                <a16:creationId xmlns:a16="http://schemas.microsoft.com/office/drawing/2014/main" id="{D5C87AAB-3CC9-4E2C-961E-55A075DA3B9C}"/>
+                <a16:creationId xmlns:a16="http://schemas.microsoft.com/office/drawing/2014/main" id="{3501A4EC-3643-4B9A-9678-38348BBB0AF0}"/>
               </a:ext>
             </a:extLst>
           </p:cNvPr>
@@ -13956,7 +13956,7 @@
           <p:cNvPr id="12" name="Freeform 12">
             <a:extLst xmlns:a="http://schemas.openxmlformats.org/drawingml/2006/main">
               <a:ext uri="{FF2B5EF4-FFF2-40B4-BE49-F238E27FC236}">
-                <a16:creationId xmlns:a16="http://schemas.microsoft.com/office/drawing/2014/main" id="{6AEA3541-E8C1-477E-8C3A-DE1492C5A278}"/>
+                <a16:creationId xmlns:a16="http://schemas.microsoft.com/office/drawing/2014/main" id="{0F3344E4-0B3B-4533-854F-D7960523CA8D}"/>
               </a:ext>
             </a:extLst>
           </p:cNvPr>
@@ -14004,7 +14004,7 @@
           <p:cNvPr id="14" name="Freeform 14">
             <a:extLst xmlns:a="http://schemas.openxmlformats.org/drawingml/2006/main">
               <a:ext uri="{FF2B5EF4-FFF2-40B4-BE49-F238E27FC236}">
-                <a16:creationId xmlns:a16="http://schemas.microsoft.com/office/drawing/2014/main" id="{675E6342-834C-41D8-8522-3285ACB7FE0F}"/>
+                <a16:creationId xmlns:a16="http://schemas.microsoft.com/office/drawing/2014/main" id="{D872FBC6-018C-47F2-9D7B-3D7978C6DB56}"/>
               </a:ext>
             </a:extLst>
           </p:cNvPr>
@@ -14049,7 +14049,7 @@
           <p:cNvPr id="15" name="Freeform 15">
             <a:extLst xmlns:a="http://schemas.openxmlformats.org/drawingml/2006/main">
               <a:ext uri="{FF2B5EF4-FFF2-40B4-BE49-F238E27FC236}">
-                <a16:creationId xmlns:a16="http://schemas.microsoft.com/office/drawing/2014/main" id="{831FE506-F381-438E-96AF-492408B7EABE}"/>
+                <a16:creationId xmlns:a16="http://schemas.microsoft.com/office/drawing/2014/main" id="{92598141-94E4-48F2-BDE9-13BE90EFF5B4}"/>
               </a:ext>
             </a:extLst>
           </p:cNvPr>
@@ -14097,7 +14097,7 @@
           <p:cNvPr id="17" name="Freeform 17">
             <a:extLst xmlns:a="http://schemas.openxmlformats.org/drawingml/2006/main">
               <a:ext uri="{FF2B5EF4-FFF2-40B4-BE49-F238E27FC236}">
-                <a16:creationId xmlns:a16="http://schemas.microsoft.com/office/drawing/2014/main" id="{D661456B-66F8-4FF7-BF81-34CAA4917AF6}"/>
+                <a16:creationId xmlns:a16="http://schemas.microsoft.com/office/drawing/2014/main" id="{E4B4D9FE-D2B1-4D5F-AB5F-84BBF1AD691D}"/>
               </a:ext>
             </a:extLst>
           </p:cNvPr>
@@ -14142,7 +14142,7 @@
           <p:cNvPr id="18" name="內容_13_財務：投資與營運分開">
             <a:extLst xmlns:a="http://schemas.openxmlformats.org/drawingml/2006/main">
               <a:ext uri="{FF2B5EF4-FFF2-40B4-BE49-F238E27FC236}">
-                <a16:creationId xmlns:a16="http://schemas.microsoft.com/office/drawing/2014/main" id="{212AD8A8-DDAA-49C5-BB1F-D9588D0200CD}"/>
+                <a16:creationId xmlns:a16="http://schemas.microsoft.com/office/drawing/2014/main" id="{62D4E8F8-8F46-4F5A-AD2B-B02123CB8BB1}"/>
               </a:ext>
             </a:extLst>
           </p:cNvPr>
@@ -14300,7 +14300,7 @@
           <p:cNvPr id="19" name="內容_13_服務改善，仍無正向回收期">
             <a:extLst xmlns:a="http://schemas.openxmlformats.org/drawingml/2006/main">
               <a:ext uri="{FF2B5EF4-FFF2-40B4-BE49-F238E27FC236}">
-                <a16:creationId xmlns:a16="http://schemas.microsoft.com/office/drawing/2014/main" id="{5396E7FB-CA78-43FE-AA86-A6518BD09C7F}"/>
+                <a16:creationId xmlns:a16="http://schemas.microsoft.com/office/drawing/2014/main" id="{80F35FFC-3835-48D6-826D-D503C07D5681}"/>
               </a:ext>
             </a:extLst>
           </p:cNvPr>
@@ -14458,7 +14458,7 @@
           <p:cNvPr id="20" name="">
             <a:extLst xmlns:a="http://schemas.openxmlformats.org/drawingml/2006/main">
               <a:ext uri="{FF2B5EF4-FFF2-40B4-BE49-F238E27FC236}">
-                <a16:creationId xmlns:a16="http://schemas.microsoft.com/office/drawing/2014/main" id="{A6BBABA1-909F-4666-BA68-5DEDF1E0B201}"/>
+                <a16:creationId xmlns:a16="http://schemas.microsoft.com/office/drawing/2014/main" id="{7F2D627E-B926-42E4-B570-85915CB383B8}"/>
               </a:ext>
             </a:extLst>
           </p:cNvPr>
@@ -15085,7 +15085,7 @@
           <p:cNvPr id="21" name="內容_13_主實驗 1350次的24小時">
             <a:extLst xmlns:a="http://schemas.openxmlformats.org/drawingml/2006/main">
               <a:ext uri="{FF2B5EF4-FFF2-40B4-BE49-F238E27FC236}">
-                <a16:creationId xmlns:a16="http://schemas.microsoft.com/office/drawing/2014/main" id="{EE70BC91-5B8E-476A-813A-C2B599BD6B83}"/>
+                <a16:creationId xmlns:a16="http://schemas.microsoft.com/office/drawing/2014/main" id="{C3576F85-5782-49A4-8BF0-27A1B16594FE}"/>
               </a:ext>
             </a:extLst>
           </p:cNvPr>
@@ -15241,7 +15241,7 @@
     </p:spTree>
     <p:extLst>
       <p:ext uri="{BB962C8B-B14F-4D97-AF65-F5344CB8AC3E}">
-        <p14:creationId xmlns:p14="http://schemas.microsoft.com/office/powerpoint/2010/main" val="277658480"/>
+        <p14:creationId xmlns:p14="http://schemas.microsoft.com/office/powerpoint/2010/main" val="505162148"/>
       </p:ext>
     </p:extLst>
   </p:cSld>
@@ -15265,7 +15265,7 @@
           <p:cNvPr id="2" name="Freeform 2">
             <a:extLst xmlns:a="http://schemas.openxmlformats.org/drawingml/2006/main">
               <a:ext uri="{FF2B5EF4-FFF2-40B4-BE49-F238E27FC236}">
-                <a16:creationId xmlns:a16="http://schemas.microsoft.com/office/drawing/2014/main" id="{F286B556-3F8A-4564-A878-0695E56CCD59}"/>
+                <a16:creationId xmlns:a16="http://schemas.microsoft.com/office/drawing/2014/main" id="{8D6DB995-EB65-47C7-8DF8-88470F4EE164}"/>
               </a:ext>
             </a:extLst>
           </p:cNvPr>
@@ -15303,7 +15303,7 @@
             </a:pathLst>
           </a:custGeom>
           <a:blipFill xmlns:a="http://schemas.openxmlformats.org/drawingml/2006/main">
-            <a:blip xmlns:r="http://schemas.openxmlformats.org/officeDocument/2006/relationships" r:embed="R184db7cb9690440f"/>
+            <a:blip xmlns:r="http://schemas.openxmlformats.org/officeDocument/2006/relationships" r:embed="R2f9474f771fc4cc2"/>
             <a:stretch>
               <a:fillRect l="-35258" t="-5555" r="-24931" b="-72434"/>
             </a:stretch>
@@ -15315,7 +15315,7 @@
           <p:cNvPr id="4" name="Freeform 4">
             <a:extLst xmlns:a="http://schemas.openxmlformats.org/drawingml/2006/main">
               <a:ext uri="{FF2B5EF4-FFF2-40B4-BE49-F238E27FC236}">
-                <a16:creationId xmlns:a16="http://schemas.microsoft.com/office/drawing/2014/main" id="{073B9B98-D47F-4F45-AEFF-0B478B039D13}"/>
+                <a16:creationId xmlns:a16="http://schemas.microsoft.com/office/drawing/2014/main" id="{6E543763-9501-4D5D-B573-E49A4BA8E17D}"/>
               </a:ext>
             </a:extLst>
           </p:cNvPr>
@@ -15389,7 +15389,7 @@
           <p:cNvPr id="5" name="TextBox 5">
             <a:extLst xmlns:a="http://schemas.openxmlformats.org/drawingml/2006/main">
               <a:ext uri="{FF2B5EF4-FFF2-40B4-BE49-F238E27FC236}">
-                <a16:creationId xmlns:a16="http://schemas.microsoft.com/office/drawing/2014/main" id="{2539E50A-DB16-4A86-AC34-D7AC3C3A97EC}"/>
+                <a16:creationId xmlns:a16="http://schemas.microsoft.com/office/drawing/2014/main" id="{8C2CE558-5BBD-4B02-A951-D676162A94D5}"/>
               </a:ext>
             </a:extLst>
           </p:cNvPr>
@@ -15425,7 +15425,7 @@
           <p:cNvPr id="6" name="Freeform 6">
             <a:extLst xmlns:a="http://schemas.openxmlformats.org/drawingml/2006/main">
               <a:ext uri="{FF2B5EF4-FFF2-40B4-BE49-F238E27FC236}">
-                <a16:creationId xmlns:a16="http://schemas.microsoft.com/office/drawing/2014/main" id="{5F55F929-1E20-43BB-AEDB-5978B06C4E93}"/>
+                <a16:creationId xmlns:a16="http://schemas.microsoft.com/office/drawing/2014/main" id="{2526EC2C-EE7A-44D7-B005-E9942C381AAF}"/>
               </a:ext>
             </a:extLst>
           </p:cNvPr>
@@ -15463,7 +15463,7 @@
             </a:pathLst>
           </a:custGeom>
           <a:blipFill xmlns:a="http://schemas.openxmlformats.org/drawingml/2006/main">
-            <a:blip xmlns:r="http://schemas.openxmlformats.org/officeDocument/2006/relationships" r:embed="R8349cc93021648d4"/>
+            <a:blip xmlns:r="http://schemas.openxmlformats.org/officeDocument/2006/relationships" r:embed="Re8827a7bdd5c4962"/>
             <a:stretch>
               <a:fillRect l="0" t="0" r="0" b="0"/>
             </a:stretch>
@@ -15475,7 +15475,7 @@
           <p:cNvPr id="7" name="Freeform 7">
             <a:extLst xmlns:a="http://schemas.openxmlformats.org/drawingml/2006/main">
               <a:ext uri="{FF2B5EF4-FFF2-40B4-BE49-F238E27FC236}">
-                <a16:creationId xmlns:a16="http://schemas.microsoft.com/office/drawing/2014/main" id="{91960055-FD3C-491E-8173-1AA8084F3E27}"/>
+                <a16:creationId xmlns:a16="http://schemas.microsoft.com/office/drawing/2014/main" id="{0B82C4C2-0B38-46A0-BDA3-A9ACC6AFF310}"/>
               </a:ext>
             </a:extLst>
           </p:cNvPr>
@@ -15523,7 +15523,7 @@
           <p:cNvPr id="8" name="TextBox 8">
             <a:extLst xmlns:a="http://schemas.openxmlformats.org/drawingml/2006/main">
               <a:ext uri="{FF2B5EF4-FFF2-40B4-BE49-F238E27FC236}">
-                <a16:creationId xmlns:a16="http://schemas.microsoft.com/office/drawing/2014/main" id="{16D12D85-F5CF-4837-B4EA-DFD9C6766D16}"/>
+                <a16:creationId xmlns:a16="http://schemas.microsoft.com/office/drawing/2014/main" id="{AA0282DC-0AB0-4628-A9D9-3D9EF4F68BF6}"/>
               </a:ext>
             </a:extLst>
           </p:cNvPr>
@@ -15684,7 +15684,7 @@
           <p:cNvPr id="9" name="TextBox 9">
             <a:extLst xmlns:a="http://schemas.openxmlformats.org/drawingml/2006/main">
               <a:ext uri="{FF2B5EF4-FFF2-40B4-BE49-F238E27FC236}">
-                <a16:creationId xmlns:a16="http://schemas.microsoft.com/office/drawing/2014/main" id="{BC5F5482-FB0A-49DE-A3A1-01DEB43B5CF5}"/>
+                <a16:creationId xmlns:a16="http://schemas.microsoft.com/office/drawing/2014/main" id="{A2ECCAB4-C87A-4039-84B0-12205D05124B}"/>
               </a:ext>
             </a:extLst>
           </p:cNvPr>
@@ -15738,7 +15738,7 @@
           <p:cNvPr id="10" name="TextBox 10">
             <a:extLst xmlns:a="http://schemas.openxmlformats.org/drawingml/2006/main">
               <a:ext uri="{FF2B5EF4-FFF2-40B4-BE49-F238E27FC236}">
-                <a16:creationId xmlns:a16="http://schemas.microsoft.com/office/drawing/2014/main" id="{3A6918FF-828C-4F2E-A699-EF3F28F09CD5}"/>
+                <a16:creationId xmlns:a16="http://schemas.microsoft.com/office/drawing/2014/main" id="{3FB23778-980B-4E59-96F2-EA802896F2B1}"/>
               </a:ext>
             </a:extLst>
           </p:cNvPr>
@@ -15790,7 +15790,7 @@
           <p:cNvPr id="11" name="TextBox 11">
             <a:extLst xmlns:a="http://schemas.openxmlformats.org/drawingml/2006/main">
               <a:ext uri="{FF2B5EF4-FFF2-40B4-BE49-F238E27FC236}">
-                <a16:creationId xmlns:a16="http://schemas.microsoft.com/office/drawing/2014/main" id="{672F772C-C06D-4142-9178-D1FFFB286144}"/>
+                <a16:creationId xmlns:a16="http://schemas.microsoft.com/office/drawing/2014/main" id="{384F8092-3AA9-4358-A9C1-CBFBE1180441}"/>
               </a:ext>
             </a:extLst>
           </p:cNvPr>
@@ -15842,7 +15842,7 @@
           <p:cNvPr id="12" name="TextBox 12">
             <a:extLst xmlns:a="http://schemas.openxmlformats.org/drawingml/2006/main">
               <a:ext uri="{FF2B5EF4-FFF2-40B4-BE49-F238E27FC236}">
-                <a16:creationId xmlns:a16="http://schemas.microsoft.com/office/drawing/2014/main" id="{2277C1F5-FE36-4FE0-9A46-6FC8EF3EFEC0}"/>
+                <a16:creationId xmlns:a16="http://schemas.microsoft.com/office/drawing/2014/main" id="{7384B6DC-1605-4529-941A-5F4F871801FA}"/>
               </a:ext>
             </a:extLst>
           </p:cNvPr>
@@ -15894,7 +15894,7 @@
           <p:cNvPr id="13" name="Freeform 13">
             <a:extLst xmlns:a="http://schemas.openxmlformats.org/drawingml/2006/main">
               <a:ext uri="{FF2B5EF4-FFF2-40B4-BE49-F238E27FC236}">
-                <a16:creationId xmlns:a16="http://schemas.microsoft.com/office/drawing/2014/main" id="{B26DE0E6-7375-43C1-A0FC-2CE3DB0C019E}"/>
+                <a16:creationId xmlns:a16="http://schemas.microsoft.com/office/drawing/2014/main" id="{A2B0DEF3-1782-4B4A-82A3-4F697C621410}"/>
               </a:ext>
             </a:extLst>
           </p:cNvPr>
@@ -15942,7 +15942,7 @@
           <p:cNvPr id="14" name="內容_14_展示：指標要可比較">
             <a:extLst xmlns:a="http://schemas.openxmlformats.org/drawingml/2006/main">
               <a:ext uri="{FF2B5EF4-FFF2-40B4-BE49-F238E27FC236}">
-                <a16:creationId xmlns:a16="http://schemas.microsoft.com/office/drawing/2014/main" id="{7ABAFD0A-2090-4F26-9957-FE7F5E463D00}"/>
+                <a16:creationId xmlns:a16="http://schemas.microsoft.com/office/drawing/2014/main" id="{D78BD11C-CA9C-4EB3-A3FC-4F396D6E1432}"/>
               </a:ext>
             </a:extLst>
           </p:cNvPr>
@@ -16100,7 +16100,7 @@
           <p:cNvPr id="15" name="內容_14_設備占比熱圖，取代含糊著色">
             <a:extLst xmlns:a="http://schemas.openxmlformats.org/drawingml/2006/main">
               <a:ext uri="{FF2B5EF4-FFF2-40B4-BE49-F238E27FC236}">
-                <a16:creationId xmlns:a16="http://schemas.microsoft.com/office/drawing/2014/main" id="{2FD07968-1A6C-4579-8BC4-B51025C96847}"/>
+                <a16:creationId xmlns:a16="http://schemas.microsoft.com/office/drawing/2014/main" id="{0DB22683-5414-46F0-B28F-1234C80C4033}"/>
               </a:ext>
             </a:extLst>
           </p:cNvPr>
@@ -16258,7 +16258,7 @@
           <p:cNvPr id="16" name="內容_14_前＝改善前現況；後＝12公尺">
             <a:extLst xmlns:a="http://schemas.openxmlformats.org/drawingml/2006/main">
               <a:ext uri="{FF2B5EF4-FFF2-40B4-BE49-F238E27FC236}">
-                <a16:creationId xmlns:a16="http://schemas.microsoft.com/office/drawing/2014/main" id="{6288EE56-46E6-4F7A-9B3D-E726370C48BB}"/>
+                <a16:creationId xmlns:a16="http://schemas.microsoft.com/office/drawing/2014/main" id="{B91D2C83-7A45-4DFA-8EDA-57C432CEF592}"/>
               </a:ext>
             </a:extLst>
           </p:cNvPr>
@@ -16416,7 +16416,7 @@
           <p:cNvPr id="17" name="">
             <a:extLst xmlns:a="http://schemas.openxmlformats.org/drawingml/2006/main">
               <a:ext uri="{FF2B5EF4-FFF2-40B4-BE49-F238E27FC236}">
-                <a16:creationId xmlns:a16="http://schemas.microsoft.com/office/drawing/2014/main" id="{60606812-DC57-4D00-A080-F86408A1F7A3}"/>
+                <a16:creationId xmlns:a16="http://schemas.microsoft.com/office/drawing/2014/main" id="{D0A35A7F-74D1-4BEF-B5AE-B006FD3B90A8}"/>
               </a:ext>
             </a:extLst>
           </p:cNvPr>
@@ -17978,7 +17978,7 @@
           <p:cNvPr id="18" name="內容_14_加工色階0–100%；阻塞色">
             <a:extLst xmlns:a="http://schemas.openxmlformats.org/drawingml/2006/main">
               <a:ext uri="{FF2B5EF4-FFF2-40B4-BE49-F238E27FC236}">
-                <a16:creationId xmlns:a16="http://schemas.microsoft.com/office/drawing/2014/main" id="{80A69E4F-6549-44F5-B674-5DB2C9C85E9F}"/>
+                <a16:creationId xmlns:a16="http://schemas.microsoft.com/office/drawing/2014/main" id="{07C710AB-5B78-48BE-990A-05BA50FE6E6B}"/>
               </a:ext>
             </a:extLst>
           </p:cNvPr>
@@ -18159,7 +18159,7 @@
           <p:cNvPr id="19" name="內容_14_在製量趨勢／清洗狀態">
             <a:extLst xmlns:a="http://schemas.openxmlformats.org/drawingml/2006/main">
               <a:ext uri="{FF2B5EF4-FFF2-40B4-BE49-F238E27FC236}">
-                <a16:creationId xmlns:a16="http://schemas.microsoft.com/office/drawing/2014/main" id="{1B8CBFBC-F061-4894-9E38-7303269EBB89}"/>
+                <a16:creationId xmlns:a16="http://schemas.microsoft.com/office/drawing/2014/main" id="{EA939E67-684E-47A0-B829-CA97C8338A5D}"/>
               </a:ext>
             </a:extLst>
           </p:cNvPr>
@@ -18317,7 +18317,7 @@
           <p:cNvPr id="20" name="">
             <a:extLst xmlns:a="http://schemas.openxmlformats.org/drawingml/2006/main">
               <a:ext uri="{FF2B5EF4-FFF2-40B4-BE49-F238E27FC236}">
-                <a16:creationId xmlns:a16="http://schemas.microsoft.com/office/drawing/2014/main" id="{ACA38DB3-FE76-458E-9155-92D91A17C55F}"/>
+                <a16:creationId xmlns:a16="http://schemas.microsoft.com/office/drawing/2014/main" id="{F141449D-0E43-48CE-B79A-50DB82BCFE63}"/>
               </a:ext>
             </a:extLst>
           </p:cNvPr>
@@ -18327,7 +18327,7 @@
           <p:nvPr/>
         </p:nvPicPr>
         <p:blipFill>
-          <a:blip xmlns:r="http://schemas.openxmlformats.org/officeDocument/2006/relationships" xmlns:a="http://schemas.openxmlformats.org/drawingml/2006/main" r:embed="R7a6d87b3ac9b414d"/>
+          <a:blip xmlns:r="http://schemas.openxmlformats.org/officeDocument/2006/relationships" xmlns:a="http://schemas.openxmlformats.org/drawingml/2006/main" r:embed="Rd82029037ac44ae3"/>
           <a:srcRect xmlns:a="http://schemas.openxmlformats.org/drawingml/2006/main" l="0" t="53500" r="10000" b="7000"/>
           <a:stretch xmlns:a="http://schemas.openxmlformats.org/drawingml/2006/main"/>
         </p:blipFill>
@@ -18346,7 +18346,7 @@
           <p:cNvPr id="21" name="內容_14_3D圖改稱設備績效著色截圖。">
             <a:extLst xmlns:a="http://schemas.openxmlformats.org/drawingml/2006/main">
               <a:ext uri="{FF2B5EF4-FFF2-40B4-BE49-F238E27FC236}">
-                <a16:creationId xmlns:a16="http://schemas.microsoft.com/office/drawing/2014/main" id="{1577E2E4-55AB-46F2-B3C0-F1C2683EDD32}"/>
+                <a16:creationId xmlns:a16="http://schemas.microsoft.com/office/drawing/2014/main" id="{44565EE0-CBCF-44C6-AA04-16B56FEA0B41}"/>
               </a:ext>
             </a:extLst>
           </p:cNvPr>
@@ -18502,7 +18502,7 @@
     </p:spTree>
     <p:extLst>
       <p:ext uri="{BB962C8B-B14F-4D97-AF65-F5344CB8AC3E}">
-        <p14:creationId xmlns:p14="http://schemas.microsoft.com/office/powerpoint/2010/main" val="442984991"/>
+        <p14:creationId xmlns:p14="http://schemas.microsoft.com/office/powerpoint/2010/main" val="802695828"/>
       </p:ext>
     </p:extLst>
   </p:cSld>
@@ -18526,7 +18526,7 @@
           <p:cNvPr id="2" name="Freeform 2">
             <a:extLst xmlns:a="http://schemas.openxmlformats.org/drawingml/2006/main">
               <a:ext uri="{FF2B5EF4-FFF2-40B4-BE49-F238E27FC236}">
-                <a16:creationId xmlns:a16="http://schemas.microsoft.com/office/drawing/2014/main" id="{2D5FACE5-6670-48F5-B43A-2E23C4BD552F}"/>
+                <a16:creationId xmlns:a16="http://schemas.microsoft.com/office/drawing/2014/main" id="{FD26DB9C-D3E6-42C1-8B25-AC4ED9DA1023}"/>
               </a:ext>
             </a:extLst>
           </p:cNvPr>
@@ -18564,7 +18564,7 @@
             </a:pathLst>
           </a:custGeom>
           <a:blipFill xmlns:a="http://schemas.openxmlformats.org/drawingml/2006/main">
-            <a:blip xmlns:r="http://schemas.openxmlformats.org/officeDocument/2006/relationships" r:embed="Rc72495e3b99b4fb2"/>
+            <a:blip xmlns:r="http://schemas.openxmlformats.org/officeDocument/2006/relationships" r:embed="Rdcb8938edb0149fc"/>
             <a:stretch>
               <a:fillRect l="-4156" t="0" r="-2479" b="-18484"/>
             </a:stretch>
@@ -18576,7 +18576,7 @@
           <p:cNvPr id="3" name="Freeform 3">
             <a:extLst xmlns:a="http://schemas.openxmlformats.org/drawingml/2006/main">
               <a:ext uri="{FF2B5EF4-FFF2-40B4-BE49-F238E27FC236}">
-                <a16:creationId xmlns:a16="http://schemas.microsoft.com/office/drawing/2014/main" id="{0C8077D4-1B1E-4B56-B6D2-0135C89E2482}"/>
+                <a16:creationId xmlns:a16="http://schemas.microsoft.com/office/drawing/2014/main" id="{C89B82AD-DAD0-4B6B-B380-7C8148DC9383}"/>
               </a:ext>
             </a:extLst>
           </p:cNvPr>
@@ -18614,7 +18614,7 @@
             </a:pathLst>
           </a:custGeom>
           <a:blipFill xmlns:a="http://schemas.openxmlformats.org/drawingml/2006/main">
-            <a:blip xmlns:r="http://schemas.openxmlformats.org/officeDocument/2006/relationships" r:embed="R407d394364414af7"/>
+            <a:blip xmlns:r="http://schemas.openxmlformats.org/officeDocument/2006/relationships" r:embed="R5237223522f24bcb"/>
             <a:stretch>
               <a:fillRect l="0" t="0" r="0" b="0"/>
             </a:stretch>
@@ -18626,7 +18626,7 @@
           <p:cNvPr id="5" name="Freeform 5">
             <a:extLst xmlns:a="http://schemas.openxmlformats.org/drawingml/2006/main">
               <a:ext uri="{FF2B5EF4-FFF2-40B4-BE49-F238E27FC236}">
-                <a16:creationId xmlns:a16="http://schemas.microsoft.com/office/drawing/2014/main" id="{A60E0CA1-8C2F-41B4-921D-60889A1AD1E5}"/>
+                <a16:creationId xmlns:a16="http://schemas.microsoft.com/office/drawing/2014/main" id="{78437739-B6D1-48AC-9C0E-4088339AA318}"/>
               </a:ext>
             </a:extLst>
           </p:cNvPr>
@@ -18700,7 +18700,7 @@
           <p:cNvPr id="6" name="TextBox 6">
             <a:extLst xmlns:a="http://schemas.openxmlformats.org/drawingml/2006/main">
               <a:ext uri="{FF2B5EF4-FFF2-40B4-BE49-F238E27FC236}">
-                <a16:creationId xmlns:a16="http://schemas.microsoft.com/office/drawing/2014/main" id="{8440F016-432A-431C-AC7E-7FEA03F429DB}"/>
+                <a16:creationId xmlns:a16="http://schemas.microsoft.com/office/drawing/2014/main" id="{5D5E747B-35CA-4A03-A9F6-3144F26C2C1D}"/>
               </a:ext>
             </a:extLst>
           </p:cNvPr>
@@ -18736,7 +18736,7 @@
           <p:cNvPr id="7" name="Freeform 7">
             <a:extLst xmlns:a="http://schemas.openxmlformats.org/drawingml/2006/main">
               <a:ext uri="{FF2B5EF4-FFF2-40B4-BE49-F238E27FC236}">
-                <a16:creationId xmlns:a16="http://schemas.microsoft.com/office/drawing/2014/main" id="{A1537AC8-6F1A-4F1E-8A6B-26D8034B734A}"/>
+                <a16:creationId xmlns:a16="http://schemas.microsoft.com/office/drawing/2014/main" id="{BA066395-FA35-4E38-B661-C54DBDE79A3B}"/>
               </a:ext>
             </a:extLst>
           </p:cNvPr>
@@ -18784,7 +18784,7 @@
           <p:cNvPr id="8" name="TextBox 8">
             <a:extLst xmlns:a="http://schemas.openxmlformats.org/drawingml/2006/main">
               <a:ext uri="{FF2B5EF4-FFF2-40B4-BE49-F238E27FC236}">
-                <a16:creationId xmlns:a16="http://schemas.microsoft.com/office/drawing/2014/main" id="{8399903F-D560-4C06-BAC7-304AB104891E}"/>
+                <a16:creationId xmlns:a16="http://schemas.microsoft.com/office/drawing/2014/main" id="{CAA118C0-2710-466A-905C-CA94F43024C7}"/>
               </a:ext>
             </a:extLst>
           </p:cNvPr>
@@ -18838,7 +18838,7 @@
           <p:cNvPr id="9" name="TextBox 9">
             <a:extLst xmlns:a="http://schemas.openxmlformats.org/drawingml/2006/main">
               <a:ext uri="{FF2B5EF4-FFF2-40B4-BE49-F238E27FC236}">
-                <a16:creationId xmlns:a16="http://schemas.microsoft.com/office/drawing/2014/main" id="{B3E1DBB0-9F2A-40FB-81C6-6ADA6DE37196}"/>
+                <a16:creationId xmlns:a16="http://schemas.microsoft.com/office/drawing/2014/main" id="{B9AAA9BD-40FB-4CD0-B8E9-49B021CF2936}"/>
               </a:ext>
             </a:extLst>
           </p:cNvPr>
@@ -18890,7 +18890,7 @@
           <p:cNvPr id="10" name="TextBox 10">
             <a:extLst xmlns:a="http://schemas.openxmlformats.org/drawingml/2006/main">
               <a:ext uri="{FF2B5EF4-FFF2-40B4-BE49-F238E27FC236}">
-                <a16:creationId xmlns:a16="http://schemas.microsoft.com/office/drawing/2014/main" id="{AC5C9941-9E2D-4CFF-9745-C2A7BE077BB4}"/>
+                <a16:creationId xmlns:a16="http://schemas.microsoft.com/office/drawing/2014/main" id="{936B2AF8-E9AF-4151-9A02-0E102E2BF327}"/>
               </a:ext>
             </a:extLst>
           </p:cNvPr>
@@ -19051,7 +19051,7 @@
           <p:cNvPr id="11" name="TextBox 11">
             <a:extLst xmlns:a="http://schemas.openxmlformats.org/drawingml/2006/main">
               <a:ext uri="{FF2B5EF4-FFF2-40B4-BE49-F238E27FC236}">
-                <a16:creationId xmlns:a16="http://schemas.microsoft.com/office/drawing/2014/main" id="{109F7638-170A-4277-AFD1-C26F1505D92D}"/>
+                <a16:creationId xmlns:a16="http://schemas.microsoft.com/office/drawing/2014/main" id="{4DFA9A72-19F3-4EF7-B725-1B1E1D14AD42}"/>
               </a:ext>
             </a:extLst>
           </p:cNvPr>
@@ -19103,7 +19103,7 @@
           <p:cNvPr id="12" name="Freeform 12">
             <a:extLst xmlns:a="http://schemas.openxmlformats.org/drawingml/2006/main">
               <a:ext uri="{FF2B5EF4-FFF2-40B4-BE49-F238E27FC236}">
-                <a16:creationId xmlns:a16="http://schemas.microsoft.com/office/drawing/2014/main" id="{39403F6D-45CC-44CF-BAF0-CA7A84980B5B}"/>
+                <a16:creationId xmlns:a16="http://schemas.microsoft.com/office/drawing/2014/main" id="{624FF258-588D-4A50-9D80-33D8771BCB4A}"/>
               </a:ext>
             </a:extLst>
           </p:cNvPr>
@@ -19151,7 +19151,7 @@
           <p:cNvPr id="13" name="">
             <a:extLst xmlns:a="http://schemas.openxmlformats.org/drawingml/2006/main">
               <a:ext uri="{FF2B5EF4-FFF2-40B4-BE49-F238E27FC236}">
-                <a16:creationId xmlns:a16="http://schemas.microsoft.com/office/drawing/2014/main" id="{E23364A6-FF07-4723-B850-F5ED53409CF6}"/>
+                <a16:creationId xmlns:a16="http://schemas.microsoft.com/office/drawing/2014/main" id="{087CBCB9-DAC4-4A26-9A1E-2FB266A10227}"/>
               </a:ext>
             </a:extLst>
           </p:cNvPr>
@@ -19161,7 +19161,7 @@
           <p:nvPr/>
         </p:nvPicPr>
         <p:blipFill>
-          <a:blip xmlns:r="http://schemas.openxmlformats.org/officeDocument/2006/relationships" xmlns:a="http://schemas.openxmlformats.org/drawingml/2006/main" r:embed="Rc98cad8c30f94f68"/>
+          <a:blip xmlns:r="http://schemas.openxmlformats.org/officeDocument/2006/relationships" xmlns:a="http://schemas.openxmlformats.org/drawingml/2006/main" r:embed="Rb1ecefd1573344cd"/>
           <a:srcRect xmlns:a="http://schemas.openxmlformats.org/drawingml/2006/main" l="21025" t="21025" r="0" b="0"/>
           <a:stretch xmlns:a="http://schemas.openxmlformats.org/drawingml/2006/main"/>
         </p:blipFill>
@@ -19180,7 +19180,7 @@
           <p:cNvPr id="14" name="內容_15_主推聯合改善＋12公尺緩衝">
             <a:extLst xmlns:a="http://schemas.openxmlformats.org/drawingml/2006/main">
               <a:ext uri="{FF2B5EF4-FFF2-40B4-BE49-F238E27FC236}">
-                <a16:creationId xmlns:a16="http://schemas.microsoft.com/office/drawing/2014/main" id="{3F639895-466F-492E-8568-A758798A35EC}"/>
+                <a16:creationId xmlns:a16="http://schemas.microsoft.com/office/drawing/2014/main" id="{410E93CE-113B-4975-994C-819A7C4F1DE9}"/>
               </a:ext>
             </a:extLst>
           </p:cNvPr>
@@ -19338,7 +19338,7 @@
           <p:cNvPr id="15" name="內容_15_短波尖峰有服務要求才採用；投">
             <a:extLst xmlns:a="http://schemas.openxmlformats.org/drawingml/2006/main">
               <a:ext uri="{FF2B5EF4-FFF2-40B4-BE49-F238E27FC236}">
-                <a16:creationId xmlns:a16="http://schemas.microsoft.com/office/drawing/2014/main" id="{B500FA03-9579-4C50-9045-9BA9AF5C9B90}"/>
+                <a16:creationId xmlns:a16="http://schemas.microsoft.com/office/drawing/2014/main" id="{28D9F380-0DB0-4142-A724-A69B66FAB7FF}"/>
               </a:ext>
             </a:extLst>
           </p:cNvPr>
@@ -19496,7 +19496,7 @@
           <p:cNvPr id="16" name="內容_15_只加緩衝不足；8公尺聯合方案">
             <a:extLst xmlns:a="http://schemas.openxmlformats.org/drawingml/2006/main">
               <a:ext uri="{FF2B5EF4-FFF2-40B4-BE49-F238E27FC236}">
-                <a16:creationId xmlns:a16="http://schemas.microsoft.com/office/drawing/2014/main" id="{D3ADA446-03A0-49DC-8B4F-60F3DEC4C982}"/>
+                <a16:creationId xmlns:a16="http://schemas.microsoft.com/office/drawing/2014/main" id="{0451B994-209C-4EEC-B6E9-7754CC4C86FD}"/>
               </a:ext>
             </a:extLst>
           </p:cNvPr>
@@ -19654,7 +19654,7 @@
           <p:cNvPr id="17" name="內容_15_答辯問答　原生模型、資料庫、">
             <a:extLst xmlns:a="http://schemas.openxmlformats.org/drawingml/2006/main">
               <a:ext uri="{FF2B5EF4-FFF2-40B4-BE49-F238E27FC236}">
-                <a16:creationId xmlns:a16="http://schemas.microsoft.com/office/drawing/2014/main" id="{F609F420-E8CA-499A-A674-25C98CE03A5C}"/>
+                <a16:creationId xmlns:a16="http://schemas.microsoft.com/office/drawing/2014/main" id="{BECD7887-091C-432D-A9B4-9BB15BAEAF11}"/>
               </a:ext>
             </a:extLst>
           </p:cNvPr>
@@ -19810,7 +19810,7 @@
     </p:spTree>
     <p:extLst>
       <p:ext uri="{BB962C8B-B14F-4D97-AF65-F5344CB8AC3E}">
-        <p14:creationId xmlns:p14="http://schemas.microsoft.com/office/powerpoint/2010/main" val="729423682"/>
+        <p14:creationId xmlns:p14="http://schemas.microsoft.com/office/powerpoint/2010/main" val="1646975911"/>
       </p:ext>
     </p:extLst>
   </p:cSld>
@@ -19834,7 +19834,7 @@
           <p:cNvPr id="2" name="Freeform 2">
             <a:extLst xmlns:a="http://schemas.openxmlformats.org/drawingml/2006/main">
               <a:ext uri="{FF2B5EF4-FFF2-40B4-BE49-F238E27FC236}">
-                <a16:creationId xmlns:a16="http://schemas.microsoft.com/office/drawing/2014/main" id="{C4333568-05C8-4E28-A7F5-95EDCEF9E4F8}"/>
+                <a16:creationId xmlns:a16="http://schemas.microsoft.com/office/drawing/2014/main" id="{E6640D45-AC17-4761-8326-C7D49ADBAF26}"/>
               </a:ext>
             </a:extLst>
           </p:cNvPr>
@@ -19872,7 +19872,7 @@
             </a:pathLst>
           </a:custGeom>
           <a:blipFill xmlns:a="http://schemas.openxmlformats.org/drawingml/2006/main">
-            <a:blip xmlns:r="http://schemas.openxmlformats.org/officeDocument/2006/relationships" r:embed="R18d5b0636136425a"/>
+            <a:blip xmlns:r="http://schemas.openxmlformats.org/officeDocument/2006/relationships" r:embed="R03fd43b154bd49f0"/>
             <a:stretch>
               <a:fillRect l="-35258" t="-5555" r="-24931" b="-72434"/>
             </a:stretch>
@@ -19884,7 +19884,7 @@
           <p:cNvPr id="4" name="Freeform 4">
             <a:extLst xmlns:a="http://schemas.openxmlformats.org/drawingml/2006/main">
               <a:ext uri="{FF2B5EF4-FFF2-40B4-BE49-F238E27FC236}">
-                <a16:creationId xmlns:a16="http://schemas.microsoft.com/office/drawing/2014/main" id="{A94D0ED5-FD39-43D0-9BBD-208F4073C9F9}"/>
+                <a16:creationId xmlns:a16="http://schemas.microsoft.com/office/drawing/2014/main" id="{9153196C-9214-4773-A28E-1F513EACDA2F}"/>
               </a:ext>
             </a:extLst>
           </p:cNvPr>
@@ -19958,7 +19958,7 @@
           <p:cNvPr id="5" name="TextBox 5">
             <a:extLst xmlns:a="http://schemas.openxmlformats.org/drawingml/2006/main">
               <a:ext uri="{FF2B5EF4-FFF2-40B4-BE49-F238E27FC236}">
-                <a16:creationId xmlns:a16="http://schemas.microsoft.com/office/drawing/2014/main" id="{39F9FFF6-590B-42AD-B871-782C5000CAD0}"/>
+                <a16:creationId xmlns:a16="http://schemas.microsoft.com/office/drawing/2014/main" id="{C48DEA3C-1992-456A-833A-069E5F08A993}"/>
               </a:ext>
             </a:extLst>
           </p:cNvPr>
@@ -19994,7 +19994,7 @@
           <p:cNvPr id="6" name="Freeform 6">
             <a:extLst xmlns:a="http://schemas.openxmlformats.org/drawingml/2006/main">
               <a:ext uri="{FF2B5EF4-FFF2-40B4-BE49-F238E27FC236}">
-                <a16:creationId xmlns:a16="http://schemas.microsoft.com/office/drawing/2014/main" id="{43124F56-1AEA-4339-BC72-A3AA20A9F73A}"/>
+                <a16:creationId xmlns:a16="http://schemas.microsoft.com/office/drawing/2014/main" id="{D4ACAC53-44DD-4BC8-A1D8-426AA926BBF8}"/>
               </a:ext>
             </a:extLst>
           </p:cNvPr>
@@ -20042,7 +20042,7 @@
           <p:cNvPr id="7" name="Freeform 7">
             <a:extLst xmlns:a="http://schemas.openxmlformats.org/drawingml/2006/main">
               <a:ext uri="{FF2B5EF4-FFF2-40B4-BE49-F238E27FC236}">
-                <a16:creationId xmlns:a16="http://schemas.microsoft.com/office/drawing/2014/main" id="{0B6720F8-8344-4151-9A1F-93DD80AB0C99}"/>
+                <a16:creationId xmlns:a16="http://schemas.microsoft.com/office/drawing/2014/main" id="{11073B9C-145D-4F58-AA04-F5BAC83CA8F2}"/>
               </a:ext>
             </a:extLst>
           </p:cNvPr>
@@ -20080,10 +20080,10 @@
             </a:pathLst>
           </a:custGeom>
           <a:blipFill xmlns:a="http://schemas.openxmlformats.org/drawingml/2006/main">
-            <a:blip xmlns:r="http://schemas.openxmlformats.org/officeDocument/2006/relationships" r:embed="Rb4c94726c68c48d4">
+            <a:blip xmlns:r="http://schemas.openxmlformats.org/officeDocument/2006/relationships" r:embed="Ra5f83fbc15ce4a89">
               <a:extLst>
                 <a:ext uri="{96DAC541-7B7A-43D3-8B79-37D633B846F1}">
-                  <asvg:svgBlip xmlns:asvg="http://schemas.microsoft.com/office/drawing/2016/SVG/main" r:embed="R45c99dde17f147de"/>
+                  <asvg:svgBlip xmlns:asvg="http://schemas.microsoft.com/office/drawing/2016/SVG/main" r:embed="Re04de250419b4a27"/>
                 </a:ext>
               </a:extLst>
             </a:blip>
@@ -20098,7 +20098,7 @@
           <p:cNvPr id="8" name="Freeform 8">
             <a:extLst xmlns:a="http://schemas.openxmlformats.org/drawingml/2006/main">
               <a:ext uri="{FF2B5EF4-FFF2-40B4-BE49-F238E27FC236}">
-                <a16:creationId xmlns:a16="http://schemas.microsoft.com/office/drawing/2014/main" id="{A66291FE-8677-4009-8320-A8C7737E5661}"/>
+                <a16:creationId xmlns:a16="http://schemas.microsoft.com/office/drawing/2014/main" id="{AD99454C-B275-40C7-9B9A-E93718976BD9}"/>
               </a:ext>
             </a:extLst>
           </p:cNvPr>
@@ -20136,10 +20136,10 @@
             </a:pathLst>
           </a:custGeom>
           <a:blipFill xmlns:a="http://schemas.openxmlformats.org/drawingml/2006/main">
-            <a:blip xmlns:r="http://schemas.openxmlformats.org/officeDocument/2006/relationships" r:embed="Rb4c94726c68c48d4">
+            <a:blip xmlns:r="http://schemas.openxmlformats.org/officeDocument/2006/relationships" r:embed="Ra5f83fbc15ce4a89">
               <a:extLst>
                 <a:ext uri="{96DAC541-7B7A-43D3-8B79-37D633B846F1}">
-                  <asvg:svgBlip xmlns:asvg="http://schemas.microsoft.com/office/drawing/2016/SVG/main" r:embed="R45c99dde17f147de"/>
+                  <asvg:svgBlip xmlns:asvg="http://schemas.microsoft.com/office/drawing/2016/SVG/main" r:embed="Re04de250419b4a27"/>
                 </a:ext>
               </a:extLst>
             </a:blip>
@@ -20154,7 +20154,7 @@
           <p:cNvPr id="9" name="Freeform 9">
             <a:extLst xmlns:a="http://schemas.openxmlformats.org/drawingml/2006/main">
               <a:ext uri="{FF2B5EF4-FFF2-40B4-BE49-F238E27FC236}">
-                <a16:creationId xmlns:a16="http://schemas.microsoft.com/office/drawing/2014/main" id="{124A2024-4370-43B1-BBCC-68E2B1EC91D9}"/>
+                <a16:creationId xmlns:a16="http://schemas.microsoft.com/office/drawing/2014/main" id="{FFB3B20B-C44F-43B6-AAE6-515E6A1CDBE3}"/>
               </a:ext>
             </a:extLst>
           </p:cNvPr>
@@ -20202,7 +20202,7 @@
           <p:cNvPr id="10" name="Freeform 10">
             <a:extLst xmlns:a="http://schemas.openxmlformats.org/drawingml/2006/main">
               <a:ext uri="{FF2B5EF4-FFF2-40B4-BE49-F238E27FC236}">
-                <a16:creationId xmlns:a16="http://schemas.microsoft.com/office/drawing/2014/main" id="{0E3D5AE7-1C2E-4ED7-AFE7-C615DFB317A7}"/>
+                <a16:creationId xmlns:a16="http://schemas.microsoft.com/office/drawing/2014/main" id="{061D7791-4B83-44EC-B314-8C160BE7609B}"/>
               </a:ext>
             </a:extLst>
           </p:cNvPr>
@@ -20240,7 +20240,7 @@
             </a:pathLst>
           </a:custGeom>
           <a:blipFill xmlns:a="http://schemas.openxmlformats.org/drawingml/2006/main">
-            <a:blip xmlns:r="http://schemas.openxmlformats.org/officeDocument/2006/relationships" r:embed="R59385007c52042e0"/>
+            <a:blip xmlns:r="http://schemas.openxmlformats.org/officeDocument/2006/relationships" r:embed="R57661d670b774e6a"/>
             <a:stretch>
               <a:fillRect l="0" t="0" r="0" b="0"/>
             </a:stretch>
@@ -20252,7 +20252,7 @@
           <p:cNvPr id="11" name="TextBox 11">
             <a:extLst xmlns:a="http://schemas.openxmlformats.org/drawingml/2006/main">
               <a:ext uri="{FF2B5EF4-FFF2-40B4-BE49-F238E27FC236}">
-                <a16:creationId xmlns:a16="http://schemas.microsoft.com/office/drawing/2014/main" id="{EDEC774A-5262-4808-8374-C8FB15F42D39}"/>
+                <a16:creationId xmlns:a16="http://schemas.microsoft.com/office/drawing/2014/main" id="{C148E808-4559-4806-8C99-3DD29A1405DC}"/>
               </a:ext>
             </a:extLst>
           </p:cNvPr>
@@ -20413,7 +20413,7 @@
           <p:cNvPr id="12" name="TextBox 12">
             <a:extLst xmlns:a="http://schemas.openxmlformats.org/drawingml/2006/main">
               <a:ext uri="{FF2B5EF4-FFF2-40B4-BE49-F238E27FC236}">
-                <a16:creationId xmlns:a16="http://schemas.microsoft.com/office/drawing/2014/main" id="{2808648A-7CAC-440C-91EC-23122EEA51A0}"/>
+                <a16:creationId xmlns:a16="http://schemas.microsoft.com/office/drawing/2014/main" id="{469C22E0-0C7F-4072-A20B-F26D2F22EAD7}"/>
               </a:ext>
             </a:extLst>
           </p:cNvPr>
@@ -20465,7 +20465,7 @@
           <p:cNvPr id="13" name="TextBox 13">
             <a:extLst xmlns:a="http://schemas.openxmlformats.org/drawingml/2006/main">
               <a:ext uri="{FF2B5EF4-FFF2-40B4-BE49-F238E27FC236}">
-                <a16:creationId xmlns:a16="http://schemas.microsoft.com/office/drawing/2014/main" id="{9EF05600-469B-424C-84E5-B66FED65F4D2}"/>
+                <a16:creationId xmlns:a16="http://schemas.microsoft.com/office/drawing/2014/main" id="{66B00542-DAED-4502-8A8D-05FFDA42787E}"/>
               </a:ext>
             </a:extLst>
           </p:cNvPr>
@@ -20517,7 +20517,7 @@
           <p:cNvPr id="14" name="TextBox 14">
             <a:extLst xmlns:a="http://schemas.openxmlformats.org/drawingml/2006/main">
               <a:ext uri="{FF2B5EF4-FFF2-40B4-BE49-F238E27FC236}">
-                <a16:creationId xmlns:a16="http://schemas.microsoft.com/office/drawing/2014/main" id="{725E81B4-BE29-4B55-A86F-56EAA7339EA0}"/>
+                <a16:creationId xmlns:a16="http://schemas.microsoft.com/office/drawing/2014/main" id="{8F55669B-4B5F-47D2-B84B-677EF895DF6B}"/>
               </a:ext>
             </a:extLst>
           </p:cNvPr>
@@ -20568,10 +20568,10 @@
       </p:sp>
       <p:sp>
         <p:nvSpPr>
-          <p:cNvPr id="15" name="內容_2_先讀代號">
+          <p:cNvPr id="15" name="內容_2_情境與方案設定">
             <a:extLst xmlns:a="http://schemas.openxmlformats.org/drawingml/2006/main">
               <a:ext uri="{FF2B5EF4-FFF2-40B4-BE49-F238E27FC236}">
-                <a16:creationId xmlns:a16="http://schemas.microsoft.com/office/drawing/2014/main" id="{B8F32FEA-7208-4CCB-B6B3-8E06669BFCDD}"/>
+                <a16:creationId xmlns:a16="http://schemas.microsoft.com/office/drawing/2014/main" id="{91E8E052-5873-499D-94FA-A843DDB3B036}"/>
               </a:ext>
             </a:extLst>
           </p:cNvPr>
@@ -20719,17 +20719,17 @@
                 <a:ea typeface="Microsoft JhengHei"/>
                 <a:cs typeface="Microsoft JhengHei"/>
               </a:rPr>
-              <a:t>先讀代號</a:t>
+              <a:t>情境與方案設定</a:t>
             </a:r>
           </a:p>
         </p:txBody>
       </p:sp>
       <p:sp>
         <p:nvSpPr>
-          <p:cNvPr id="16" name="內容_2_需求情境與改善方案是兩件事">
+          <p:cNvPr id="16" name="內容_2_三種需求情境與五種改善方案">
             <a:extLst xmlns:a="http://schemas.openxmlformats.org/drawingml/2006/main">
               <a:ext uri="{FF2B5EF4-FFF2-40B4-BE49-F238E27FC236}">
-                <a16:creationId xmlns:a16="http://schemas.microsoft.com/office/drawing/2014/main" id="{8445254C-67C1-4368-840C-7F453BCED8C7}"/>
+                <a16:creationId xmlns:a16="http://schemas.microsoft.com/office/drawing/2014/main" id="{A0F0CF37-5FB8-40C6-A6AA-3E4555A967AD}"/>
               </a:ext>
             </a:extLst>
           </p:cNvPr>
@@ -20877,7 +20877,7 @@
                 <a:ea typeface="Microsoft JhengHei"/>
                 <a:cs typeface="Microsoft JhengHei"/>
               </a:rPr>
-              <a:t>需求情境與改善方案是兩件事</a:t>
+              <a:t>三種需求情境與五種改善方案</a:t>
             </a:r>
           </a:p>
         </p:txBody>
@@ -20887,7 +20887,7 @@
           <p:cNvPr id="17" name="">
             <a:extLst xmlns:a="http://schemas.openxmlformats.org/drawingml/2006/main">
               <a:ext uri="{FF2B5EF4-FFF2-40B4-BE49-F238E27FC236}">
-                <a16:creationId xmlns:a16="http://schemas.microsoft.com/office/drawing/2014/main" id="{1534FB80-4BA8-459A-99F2-904004098B17}"/>
+                <a16:creationId xmlns:a16="http://schemas.microsoft.com/office/drawing/2014/main" id="{5B7F7AF0-3ED3-48BB-97E7-BC7499621BF5}"/>
               </a:ext>
             </a:extLst>
           </p:cNvPr>
@@ -20914,7 +20914,7 @@
                     <a:lstStyle/>
                     <a:p>
                       <a:r>
-                        <a:rPr sz="1650" b="1">
+                        <a:rPr sz="1575" b="1">
                           <a:solidFill>
                             <a:srgbClr val="DF96DA"/>
                           </a:solidFill>
@@ -20922,7 +20922,7 @@
                           <a:ea typeface="Microsoft JhengHei"/>
                           <a:cs typeface="Microsoft JhengHei"/>
                         </a:rPr>
-                        <a:t>代碼</a:t>
+                        <a:t>名稱（代號）</a:t>
                       </a:r>
                     </a:p>
                   </a:txBody>
@@ -20962,7 +20962,7 @@
                     <a:lstStyle/>
                     <a:p>
                       <a:r>
-                        <a:rPr sz="1650" b="1">
+                        <a:rPr sz="1575" b="1">
                           <a:solidFill>
                             <a:srgbClr val="DF96DA"/>
                           </a:solidFill>
@@ -20970,7 +20970,7 @@
                           <a:ea typeface="Microsoft JhengHei"/>
                           <a:cs typeface="Microsoft JhengHei"/>
                         </a:rPr>
-                        <a:t>中文名稱</a:t>
+                        <a:t>類別</a:t>
                       </a:r>
                     </a:p>
                   </a:txBody>
@@ -21004,7 +21004,7 @@
                     <a:lstStyle/>
                     <a:p>
                       <a:r>
-                        <a:rPr sz="1650" b="1">
+                        <a:rPr sz="1575" b="1">
                           <a:solidFill>
                             <a:srgbClr val="DF96DA"/>
                           </a:solidFill>
@@ -21048,7 +21048,7 @@
                     <a:lstStyle/>
                     <a:p>
                       <a:r>
-                        <a:rPr sz="1650" b="0">
+                        <a:rPr sz="1575" b="0">
                           <a:solidFill>
                             <a:srgbClr val="F6E0F5"/>
                           </a:solidFill>
@@ -21056,7 +21056,7 @@
                           <a:ea typeface="Microsoft JhengHei"/>
                           <a:cs typeface="Microsoft JhengHei"/>
                         </a:rPr>
-                        <a:t>S0</a:t>
+                        <a:t>平日基準情境（S0）</a:t>
                       </a:r>
                     </a:p>
                   </a:txBody>
@@ -21090,7 +21090,7 @@
                     <a:lstStyle/>
                     <a:p>
                       <a:r>
-                        <a:rPr sz="1650" b="0">
+                        <a:rPr sz="1575" b="0">
                           <a:solidFill>
                             <a:srgbClr val="F6E0F5"/>
                           </a:solidFill>
@@ -21098,7 +21098,7 @@
                           <a:ea typeface="Microsoft JhengHei"/>
                           <a:cs typeface="Microsoft JhengHei"/>
                         </a:rPr>
-                        <a:t>平日基準情境</a:t>
+                        <a:t>需求情境</a:t>
                       </a:r>
                     </a:p>
                   </a:txBody>
@@ -21126,7 +21126,7 @@
                     <a:lstStyle/>
                     <a:p>
                       <a:r>
-                        <a:rPr sz="1650" b="0">
+                        <a:rPr sz="1575" b="0">
                           <a:solidFill>
                             <a:srgbClr val="F6E0F5"/>
                           </a:solidFill>
@@ -21164,7 +21164,7 @@
                     <a:lstStyle/>
                     <a:p>
                       <a:r>
-                        <a:rPr sz="1650" b="0">
+                        <a:rPr sz="1575" b="0">
                           <a:solidFill>
                             <a:srgbClr val="F6E0F5"/>
                           </a:solidFill>
@@ -21172,7 +21172,7 @@
                           <a:ea typeface="Microsoft JhengHei"/>
                           <a:cs typeface="Microsoft JhengHei"/>
                         </a:rPr>
-                        <a:t>S1</a:t>
+                        <a:t>短波尖峰情境（S1）</a:t>
                       </a:r>
                     </a:p>
                   </a:txBody>
@@ -21206,7 +21206,7 @@
                     <a:lstStyle/>
                     <a:p>
                       <a:r>
-                        <a:rPr sz="1650" b="0">
+                        <a:rPr sz="1575" b="0">
                           <a:solidFill>
                             <a:srgbClr val="F6E0F5"/>
                           </a:solidFill>
@@ -21214,7 +21214,7 @@
                           <a:ea typeface="Microsoft JhengHei"/>
                           <a:cs typeface="Microsoft JhengHei"/>
                         </a:rPr>
-                        <a:t>短波尖峰情境</a:t>
+                        <a:t>需求情境</a:t>
                       </a:r>
                     </a:p>
                   </a:txBody>
@@ -21242,7 +21242,7 @@
                     <a:lstStyle/>
                     <a:p>
                       <a:r>
-                        <a:rPr sz="1650" b="0">
+                        <a:rPr sz="1575" b="0">
                           <a:solidFill>
                             <a:srgbClr val="F6E0F5"/>
                           </a:solidFill>
@@ -21280,7 +21280,7 @@
                     <a:lstStyle/>
                     <a:p>
                       <a:r>
-                        <a:rPr sz="1650" b="0">
+                        <a:rPr sz="1575" b="0">
                           <a:solidFill>
                             <a:srgbClr val="F6E0F5"/>
                           </a:solidFill>
@@ -21288,7 +21288,7 @@
                           <a:ea typeface="Microsoft JhengHei"/>
                           <a:cs typeface="Microsoft JhengHei"/>
                         </a:rPr>
-                        <a:t>S1_4.5</a:t>
+                        <a:t>較高短波尖峰情境（S1_4.5）</a:t>
                       </a:r>
                     </a:p>
                   </a:txBody>
@@ -21322,7 +21322,7 @@
                     <a:lstStyle/>
                     <a:p>
                       <a:r>
-                        <a:rPr sz="1650" b="0">
+                        <a:rPr sz="1575" b="0">
                           <a:solidFill>
                             <a:srgbClr val="F6E0F5"/>
                           </a:solidFill>
@@ -21330,7 +21330,7 @@
                           <a:ea typeface="Microsoft JhengHei"/>
                           <a:cs typeface="Microsoft JhengHei"/>
                         </a:rPr>
-                        <a:t>較高短波尖峰情境</a:t>
+                        <a:t>需求情境</a:t>
                       </a:r>
                     </a:p>
                   </a:txBody>
@@ -21358,7 +21358,7 @@
                     <a:lstStyle/>
                     <a:p>
                       <a:r>
-                        <a:rPr sz="1650" b="0">
+                        <a:rPr sz="1575" b="0">
                           <a:solidFill>
                             <a:srgbClr val="F6E0F5"/>
                           </a:solidFill>
@@ -21396,7 +21396,7 @@
                     <a:lstStyle/>
                     <a:p>
                       <a:r>
-                        <a:rPr sz="1650" b="0">
+                        <a:rPr sz="1575" b="0">
                           <a:solidFill>
                             <a:srgbClr val="F6E0F5"/>
                           </a:solidFill>
@@ -21404,7 +21404,7 @@
                           <a:ea typeface="Microsoft JhengHei"/>
                           <a:cs typeface="Microsoft JhengHei"/>
                         </a:rPr>
-                        <a:t>P0（現況）</a:t>
+                        <a:t>維持現況（P0）</a:t>
                       </a:r>
                     </a:p>
                   </a:txBody>
@@ -21438,7 +21438,7 @@
                     <a:lstStyle/>
                     <a:p>
                       <a:r>
-                        <a:rPr sz="1650" b="0">
+                        <a:rPr sz="1575" b="0">
                           <a:solidFill>
                             <a:srgbClr val="F6E0F5"/>
                           </a:solidFill>
@@ -21446,7 +21446,7 @@
                           <a:ea typeface="Microsoft JhengHei"/>
                           <a:cs typeface="Microsoft JhengHei"/>
                         </a:rPr>
-                        <a:t>維持現況</a:t>
+                        <a:t>改善方案</a:t>
                       </a:r>
                     </a:p>
                   </a:txBody>
@@ -21474,7 +21474,7 @@
                     <a:lstStyle/>
                     <a:p>
                       <a:r>
-                        <a:rPr sz="1650" b="0">
+                        <a:rPr sz="1575" b="0">
                           <a:solidFill>
                             <a:srgbClr val="F6E0F5"/>
                           </a:solidFill>
@@ -21512,7 +21512,7 @@
                     <a:lstStyle/>
                     <a:p>
                       <a:r>
-                        <a:rPr sz="1650" b="0">
+                        <a:rPr sz="1575" b="0">
                           <a:solidFill>
                             <a:srgbClr val="F6E0F5"/>
                           </a:solidFill>
@@ -21520,7 +21520,7 @@
                           <a:ea typeface="Microsoft JhengHei"/>
                           <a:cs typeface="Microsoft JhengHei"/>
                         </a:rPr>
-                        <a:t>P1</a:t>
+                        <a:t>增設第二台清洗機（P1）</a:t>
                       </a:r>
                     </a:p>
                   </a:txBody>
@@ -21554,7 +21554,7 @@
                     <a:lstStyle/>
                     <a:p>
                       <a:r>
-                        <a:rPr sz="1650" b="0">
+                        <a:rPr sz="1575" b="0">
                           <a:solidFill>
                             <a:srgbClr val="F6E0F5"/>
                           </a:solidFill>
@@ -21562,7 +21562,7 @@
                           <a:ea typeface="Microsoft JhengHei"/>
                           <a:cs typeface="Microsoft JhengHei"/>
                         </a:rPr>
-                        <a:t>增加第二台清洗機</a:t>
+                        <a:t>改善方案</a:t>
                       </a:r>
                     </a:p>
                   </a:txBody>
@@ -21590,7 +21590,7 @@
                     <a:lstStyle/>
                     <a:p>
                       <a:r>
-                        <a:rPr sz="1650" b="0">
+                        <a:rPr sz="1575" b="0">
                           <a:solidFill>
                             <a:srgbClr val="F6E0F5"/>
                           </a:solidFill>
@@ -21628,7 +21628,7 @@
                     <a:lstStyle/>
                     <a:p>
                       <a:r>
-                        <a:rPr sz="1650" b="0">
+                        <a:rPr sz="1575" b="0">
                           <a:solidFill>
                             <a:srgbClr val="F6E0F5"/>
                           </a:solidFill>
@@ -21636,7 +21636,7 @@
                           <a:ea typeface="Microsoft JhengHei"/>
                           <a:cs typeface="Microsoft JhengHei"/>
                         </a:rPr>
-                        <a:t>P2</a:t>
+                        <a:t>僅加緩衝（P2）</a:t>
                       </a:r>
                     </a:p>
                   </a:txBody>
@@ -21670,7 +21670,7 @@
                     <a:lstStyle/>
                     <a:p>
                       <a:r>
-                        <a:rPr sz="1650" b="0">
+                        <a:rPr sz="1575" b="0">
                           <a:solidFill>
                             <a:srgbClr val="F6E0F5"/>
                           </a:solidFill>
@@ -21678,7 +21678,7 @@
                           <a:ea typeface="Microsoft JhengHei"/>
                           <a:cs typeface="Microsoft JhengHei"/>
                         </a:rPr>
-                        <a:t>僅增加緩衝</a:t>
+                        <a:t>改善方案</a:t>
                       </a:r>
                     </a:p>
                   </a:txBody>
@@ -21706,7 +21706,7 @@
                     <a:lstStyle/>
                     <a:p>
                       <a:r>
-                        <a:rPr sz="1650" b="0">
+                        <a:rPr sz="1575" b="0">
                           <a:solidFill>
                             <a:srgbClr val="F6E0F5"/>
                           </a:solidFill>
@@ -21744,7 +21744,7 @@
                     <a:lstStyle/>
                     <a:p>
                       <a:r>
-                        <a:rPr sz="1650" b="0">
+                        <a:rPr sz="1575" b="0">
                           <a:solidFill>
                             <a:srgbClr val="F6E0F5"/>
                           </a:solidFill>
@@ -21752,7 +21752,7 @@
                           <a:ea typeface="Microsoft JhengHei"/>
                           <a:cs typeface="Microsoft JhengHei"/>
                         </a:rPr>
-                        <a:t>P3</a:t>
+                        <a:t>外包清洗（P3）</a:t>
                       </a:r>
                     </a:p>
                   </a:txBody>
@@ -21786,7 +21786,7 @@
                     <a:lstStyle/>
                     <a:p>
                       <a:r>
-                        <a:rPr sz="1650" b="0">
+                        <a:rPr sz="1575" b="0">
                           <a:solidFill>
                             <a:srgbClr val="F6E0F5"/>
                           </a:solidFill>
@@ -21794,7 +21794,7 @@
                           <a:ea typeface="Microsoft JhengHei"/>
                           <a:cs typeface="Microsoft JhengHei"/>
                         </a:rPr>
-                        <a:t>外包清洗</a:t>
+                        <a:t>改善方案</a:t>
                       </a:r>
                     </a:p>
                   </a:txBody>
@@ -21822,7 +21822,7 @@
                     <a:lstStyle/>
                     <a:p>
                       <a:r>
-                        <a:rPr sz="1650" b="0">
+                        <a:rPr sz="1575" b="0">
                           <a:solidFill>
                             <a:srgbClr val="F6E0F5"/>
                           </a:solidFill>
@@ -21860,7 +21860,7 @@
                     <a:lstStyle/>
                     <a:p>
                       <a:r>
-                        <a:rPr sz="1650" b="0">
+                        <a:rPr sz="1575" b="0">
                           <a:solidFill>
                             <a:srgbClr val="F6E0F5"/>
                           </a:solidFill>
@@ -21868,7 +21868,7 @@
                           <a:ea typeface="Microsoft JhengHei"/>
                           <a:cs typeface="Microsoft JhengHei"/>
                         </a:rPr>
-                        <a:t>P4</a:t>
+                        <a:t>聯合改善（P4）</a:t>
                       </a:r>
                     </a:p>
                   </a:txBody>
@@ -21902,7 +21902,7 @@
                     <a:lstStyle/>
                     <a:p>
                       <a:r>
-                        <a:rPr sz="1650" b="0">
+                        <a:rPr sz="1575" b="0">
                           <a:solidFill>
                             <a:srgbClr val="F6E0F5"/>
                           </a:solidFill>
@@ -21910,7 +21910,7 @@
                           <a:ea typeface="Microsoft JhengHei"/>
                           <a:cs typeface="Microsoft JhengHei"/>
                         </a:rPr>
-                        <a:t>聯合改善</a:t>
+                        <a:t>改善方案</a:t>
                       </a:r>
                     </a:p>
                   </a:txBody>
@@ -21938,7 +21938,7 @@
                     <a:lstStyle/>
                     <a:p>
                       <a:r>
-                        <a:rPr sz="1650" b="0">
+                        <a:rPr sz="1575" b="0">
                           <a:solidFill>
                             <a:srgbClr val="F6E0F5"/>
                           </a:solidFill>
@@ -21975,10 +21975,10 @@
       </p:graphicFrame>
       <p:sp>
         <p:nvSpPr>
-          <p:cNvPr id="18" name="內容_2_S＝需求情境，P＝改善方案；">
+          <p:cNvPr id="18" name="內容_2_需求情境決定到達量，改善方案">
             <a:extLst xmlns:a="http://schemas.openxmlformats.org/drawingml/2006/main">
               <a:ext uri="{FF2B5EF4-FFF2-40B4-BE49-F238E27FC236}">
-                <a16:creationId xmlns:a16="http://schemas.microsoft.com/office/drawing/2014/main" id="{1560078A-CD04-4B9E-AFF0-F11D39470AA9}"/>
+                <a16:creationId xmlns:a16="http://schemas.microsoft.com/office/drawing/2014/main" id="{875F6862-BA9C-4295-8168-D6D0808D2311}"/>
               </a:ext>
             </a:extLst>
           </p:cNvPr>
@@ -22126,7 +22126,7 @@
                 <a:ea typeface="Microsoft JhengHei"/>
                 <a:cs typeface="Microsoft JhengHei"/>
               </a:rPr>
-              <a:t>S＝需求情境，P＝改善方案；m代表公尺，8公尺是緩衝長度；min代表分鐘，h代表小時。</a:t>
+              <a:t>需求情境決定到達量，改善方案決定設備與調度。緩衝長度用公尺，等待時間用分鐘。</a:t>
             </a:r>
           </a:p>
         </p:txBody>
@@ -22134,7 +22134,7 @@
     </p:spTree>
     <p:extLst>
       <p:ext uri="{BB962C8B-B14F-4D97-AF65-F5344CB8AC3E}">
-        <p14:creationId xmlns:p14="http://schemas.microsoft.com/office/powerpoint/2010/main" val="1948526633"/>
+        <p14:creationId xmlns:p14="http://schemas.microsoft.com/office/powerpoint/2010/main" val="149190272"/>
       </p:ext>
     </p:extLst>
   </p:cSld>
@@ -22158,7 +22158,7 @@
           <p:cNvPr id="2" name="Freeform 2">
             <a:extLst xmlns:a="http://schemas.openxmlformats.org/drawingml/2006/main">
               <a:ext uri="{FF2B5EF4-FFF2-40B4-BE49-F238E27FC236}">
-                <a16:creationId xmlns:a16="http://schemas.microsoft.com/office/drawing/2014/main" id="{64830B72-C18E-43E6-BDCE-6164C1187880}"/>
+                <a16:creationId xmlns:a16="http://schemas.microsoft.com/office/drawing/2014/main" id="{78985B8B-A6B5-49EF-80E0-E4799D620A4A}"/>
               </a:ext>
             </a:extLst>
           </p:cNvPr>
@@ -22196,7 +22196,7 @@
             </a:pathLst>
           </a:custGeom>
           <a:blipFill xmlns:a="http://schemas.openxmlformats.org/drawingml/2006/main">
-            <a:blip xmlns:r="http://schemas.openxmlformats.org/officeDocument/2006/relationships" r:embed="R05322418d767471d"/>
+            <a:blip xmlns:r="http://schemas.openxmlformats.org/officeDocument/2006/relationships" r:embed="Ra61bf1f7bcce4054"/>
             <a:stretch>
               <a:fillRect l="-35258" t="-5555" r="-24931" b="-72434"/>
             </a:stretch>
@@ -22208,7 +22208,7 @@
           <p:cNvPr id="4" name="Freeform 4">
             <a:extLst xmlns:a="http://schemas.openxmlformats.org/drawingml/2006/main">
               <a:ext uri="{FF2B5EF4-FFF2-40B4-BE49-F238E27FC236}">
-                <a16:creationId xmlns:a16="http://schemas.microsoft.com/office/drawing/2014/main" id="{317A2325-BFC3-4327-B78A-A57C8EDFCE42}"/>
+                <a16:creationId xmlns:a16="http://schemas.microsoft.com/office/drawing/2014/main" id="{72A452A2-53BD-447B-94FD-C7EEF9589B8B}"/>
               </a:ext>
             </a:extLst>
           </p:cNvPr>
@@ -22282,7 +22282,7 @@
           <p:cNvPr id="5" name="TextBox 5">
             <a:extLst xmlns:a="http://schemas.openxmlformats.org/drawingml/2006/main">
               <a:ext uri="{FF2B5EF4-FFF2-40B4-BE49-F238E27FC236}">
-                <a16:creationId xmlns:a16="http://schemas.microsoft.com/office/drawing/2014/main" id="{EB82EAF7-A3E2-49B2-A229-8C5C62252760}"/>
+                <a16:creationId xmlns:a16="http://schemas.microsoft.com/office/drawing/2014/main" id="{45836DC1-4E58-45B7-922B-D078B0AA265F}"/>
               </a:ext>
             </a:extLst>
           </p:cNvPr>
@@ -22318,7 +22318,7 @@
           <p:cNvPr id="6" name="Freeform 6">
             <a:extLst xmlns:a="http://schemas.openxmlformats.org/drawingml/2006/main">
               <a:ext uri="{FF2B5EF4-FFF2-40B4-BE49-F238E27FC236}">
-                <a16:creationId xmlns:a16="http://schemas.microsoft.com/office/drawing/2014/main" id="{C50331AF-E410-4393-90BD-65EB696EAB1A}"/>
+                <a16:creationId xmlns:a16="http://schemas.microsoft.com/office/drawing/2014/main" id="{08CCB521-23F3-46C1-8891-98B2FDA2E4F8}"/>
               </a:ext>
             </a:extLst>
           </p:cNvPr>
@@ -22366,7 +22366,7 @@
           <p:cNvPr id="7" name="Freeform 7">
             <a:extLst xmlns:a="http://schemas.openxmlformats.org/drawingml/2006/main">
               <a:ext uri="{FF2B5EF4-FFF2-40B4-BE49-F238E27FC236}">
-                <a16:creationId xmlns:a16="http://schemas.microsoft.com/office/drawing/2014/main" id="{A0970212-9BDF-4F0B-AD97-38F4C990111F}"/>
+                <a16:creationId xmlns:a16="http://schemas.microsoft.com/office/drawing/2014/main" id="{BED38AB1-C7E3-4FE1-B079-1438AD12FC59}"/>
               </a:ext>
             </a:extLst>
           </p:cNvPr>
@@ -22404,10 +22404,10 @@
             </a:pathLst>
           </a:custGeom>
           <a:blipFill xmlns:a="http://schemas.openxmlformats.org/drawingml/2006/main">
-            <a:blip xmlns:r="http://schemas.openxmlformats.org/officeDocument/2006/relationships" r:embed="Rb00df977399b4d86">
+            <a:blip xmlns:r="http://schemas.openxmlformats.org/officeDocument/2006/relationships" r:embed="Rd18d9229f6414c4b">
               <a:extLst>
                 <a:ext uri="{96DAC541-7B7A-43D3-8B79-37D633B846F1}">
-                  <asvg:svgBlip xmlns:asvg="http://schemas.microsoft.com/office/drawing/2016/SVG/main" r:embed="Raf5d50fd734e4e00"/>
+                  <asvg:svgBlip xmlns:asvg="http://schemas.microsoft.com/office/drawing/2016/SVG/main" r:embed="Rb695a796b954485f"/>
                 </a:ext>
               </a:extLst>
             </a:blip>
@@ -22422,7 +22422,7 @@
           <p:cNvPr id="8" name="Freeform 8">
             <a:extLst xmlns:a="http://schemas.openxmlformats.org/drawingml/2006/main">
               <a:ext uri="{FF2B5EF4-FFF2-40B4-BE49-F238E27FC236}">
-                <a16:creationId xmlns:a16="http://schemas.microsoft.com/office/drawing/2014/main" id="{55714828-BFE9-4872-95E6-4D3811E345F3}"/>
+                <a16:creationId xmlns:a16="http://schemas.microsoft.com/office/drawing/2014/main" id="{8092908E-094A-4C79-A744-BC13EC5799C2}"/>
               </a:ext>
             </a:extLst>
           </p:cNvPr>
@@ -22460,10 +22460,10 @@
             </a:pathLst>
           </a:custGeom>
           <a:blipFill xmlns:a="http://schemas.openxmlformats.org/drawingml/2006/main">
-            <a:blip xmlns:r="http://schemas.openxmlformats.org/officeDocument/2006/relationships" r:embed="Rb00df977399b4d86">
+            <a:blip xmlns:r="http://schemas.openxmlformats.org/officeDocument/2006/relationships" r:embed="Rd18d9229f6414c4b">
               <a:extLst>
                 <a:ext uri="{96DAC541-7B7A-43D3-8B79-37D633B846F1}">
-                  <asvg:svgBlip xmlns:asvg="http://schemas.microsoft.com/office/drawing/2016/SVG/main" r:embed="Raf5d50fd734e4e00"/>
+                  <asvg:svgBlip xmlns:asvg="http://schemas.microsoft.com/office/drawing/2016/SVG/main" r:embed="Rb695a796b954485f"/>
                 </a:ext>
               </a:extLst>
             </a:blip>
@@ -22478,7 +22478,7 @@
           <p:cNvPr id="9" name="TextBox 9">
             <a:extLst xmlns:a="http://schemas.openxmlformats.org/drawingml/2006/main">
               <a:ext uri="{FF2B5EF4-FFF2-40B4-BE49-F238E27FC236}">
-                <a16:creationId xmlns:a16="http://schemas.microsoft.com/office/drawing/2014/main" id="{485A7F35-5A4C-4603-AC79-34B039707C3C}"/>
+                <a16:creationId xmlns:a16="http://schemas.microsoft.com/office/drawing/2014/main" id="{59D95409-1DFF-41EE-9F89-1A3F9D2D9FB0}"/>
               </a:ext>
             </a:extLst>
           </p:cNvPr>
@@ -22639,7 +22639,7 @@
           <p:cNvPr id="10" name="TextBox 10">
             <a:extLst xmlns:a="http://schemas.openxmlformats.org/drawingml/2006/main">
               <a:ext uri="{FF2B5EF4-FFF2-40B4-BE49-F238E27FC236}">
-                <a16:creationId xmlns:a16="http://schemas.microsoft.com/office/drawing/2014/main" id="{48521113-1CB7-491D-A151-0EBBC4F364E5}"/>
+                <a16:creationId xmlns:a16="http://schemas.microsoft.com/office/drawing/2014/main" id="{D699EBCD-5882-4FF2-B85F-42F3C384809F}"/>
               </a:ext>
             </a:extLst>
           </p:cNvPr>
@@ -22691,7 +22691,7 @@
           <p:cNvPr id="11" name="TextBox 11">
             <a:extLst xmlns:a="http://schemas.openxmlformats.org/drawingml/2006/main">
               <a:ext uri="{FF2B5EF4-FFF2-40B4-BE49-F238E27FC236}">
-                <a16:creationId xmlns:a16="http://schemas.microsoft.com/office/drawing/2014/main" id="{26C0E5D5-F056-4E31-AD40-41F104508234}"/>
+                <a16:creationId xmlns:a16="http://schemas.microsoft.com/office/drawing/2014/main" id="{CAAD0B5A-79F4-4CB1-B2FF-C824638B1A20}"/>
               </a:ext>
             </a:extLst>
           </p:cNvPr>
@@ -22743,7 +22743,7 @@
           <p:cNvPr id="12" name="TextBox 12">
             <a:extLst xmlns:a="http://schemas.openxmlformats.org/drawingml/2006/main">
               <a:ext uri="{FF2B5EF4-FFF2-40B4-BE49-F238E27FC236}">
-                <a16:creationId xmlns:a16="http://schemas.microsoft.com/office/drawing/2014/main" id="{166349A9-2574-41E8-ABE9-E09D4C81DB56}"/>
+                <a16:creationId xmlns:a16="http://schemas.microsoft.com/office/drawing/2014/main" id="{8C14F4B7-EBE1-4DF8-94F6-91F6FB9D7C79}"/>
               </a:ext>
             </a:extLst>
           </p:cNvPr>
@@ -22795,7 +22795,7 @@
           <p:cNvPr id="13" name="Freeform 13">
             <a:extLst xmlns:a="http://schemas.openxmlformats.org/drawingml/2006/main">
               <a:ext uri="{FF2B5EF4-FFF2-40B4-BE49-F238E27FC236}">
-                <a16:creationId xmlns:a16="http://schemas.microsoft.com/office/drawing/2014/main" id="{5AE00000-B7FF-4033-934E-C0ADD82AC5D1}"/>
+                <a16:creationId xmlns:a16="http://schemas.microsoft.com/office/drawing/2014/main" id="{02A3E847-04B2-4901-AE57-A794923FB2F5}"/>
               </a:ext>
             </a:extLst>
           </p:cNvPr>
@@ -22833,7 +22833,7 @@
             </a:pathLst>
           </a:custGeom>
           <a:blipFill xmlns:a="http://schemas.openxmlformats.org/drawingml/2006/main">
-            <a:blip xmlns:r="http://schemas.openxmlformats.org/officeDocument/2006/relationships" r:embed="R1f7da8c8f7de45c2"/>
+            <a:blip xmlns:r="http://schemas.openxmlformats.org/officeDocument/2006/relationships" r:embed="Rb5defca6221a4e15"/>
             <a:stretch>
               <a:fillRect l="0" t="0" r="0" b="0"/>
             </a:stretch>
@@ -22845,7 +22845,7 @@
           <p:cNvPr id="14" name="TextBox 14">
             <a:extLst xmlns:a="http://schemas.openxmlformats.org/drawingml/2006/main">
               <a:ext uri="{FF2B5EF4-FFF2-40B4-BE49-F238E27FC236}">
-                <a16:creationId xmlns:a16="http://schemas.microsoft.com/office/drawing/2014/main" id="{BA0B8662-16F0-429B-8344-FFC4BF1FB62F}"/>
+                <a16:creationId xmlns:a16="http://schemas.microsoft.com/office/drawing/2014/main" id="{E206FCF6-BE8D-402E-A98C-06F5894B4C9D}"/>
               </a:ext>
             </a:extLst>
           </p:cNvPr>
@@ -22899,7 +22899,7 @@
           <p:cNvPr id="15" name="內容_3_先讀指標與數字">
             <a:extLst xmlns:a="http://schemas.openxmlformats.org/drawingml/2006/main">
               <a:ext uri="{FF2B5EF4-FFF2-40B4-BE49-F238E27FC236}">
-                <a16:creationId xmlns:a16="http://schemas.microsoft.com/office/drawing/2014/main" id="{9D7817FC-53D4-4FAD-9105-796B585325C5}"/>
+                <a16:creationId xmlns:a16="http://schemas.microsoft.com/office/drawing/2014/main" id="{0EF2848A-58C5-4FA5-ABE7-43BE354D4B9F}"/>
               </a:ext>
             </a:extLst>
           </p:cNvPr>
@@ -23057,7 +23057,7 @@
           <p:cNvPr id="16" name="內容_3_表中的方括號是平均估計的範圍">
             <a:extLst xmlns:a="http://schemas.openxmlformats.org/drawingml/2006/main">
               <a:ext uri="{FF2B5EF4-FFF2-40B4-BE49-F238E27FC236}">
-                <a16:creationId xmlns:a16="http://schemas.microsoft.com/office/drawing/2014/main" id="{4EF7125F-294D-40E2-8A38-04BEBA088B62}"/>
+                <a16:creationId xmlns:a16="http://schemas.microsoft.com/office/drawing/2014/main" id="{1F5A69DD-0C18-4586-A143-539471994CC0}"/>
               </a:ext>
             </a:extLst>
           </p:cNvPr>
@@ -23215,7 +23215,7 @@
           <p:cNvPr id="17" name="內容_3_數字格式：平均值 [95%信">
             <a:extLst xmlns:a="http://schemas.openxmlformats.org/drawingml/2006/main">
               <a:ext uri="{FF2B5EF4-FFF2-40B4-BE49-F238E27FC236}">
-                <a16:creationId xmlns:a16="http://schemas.microsoft.com/office/drawing/2014/main" id="{CEFB6093-842F-4471-8E96-19427D708791}"/>
+                <a16:creationId xmlns:a16="http://schemas.microsoft.com/office/drawing/2014/main" id="{C62B019C-4AC4-43D9-B9F3-14AD494D982D}"/>
               </a:ext>
             </a:extLst>
           </p:cNvPr>
@@ -23373,7 +23373,7 @@
           <p:cNvPr id="18" name="">
             <a:extLst xmlns:a="http://schemas.openxmlformats.org/drawingml/2006/main">
               <a:ext uri="{FF2B5EF4-FFF2-40B4-BE49-F238E27FC236}">
-                <a16:creationId xmlns:a16="http://schemas.microsoft.com/office/drawing/2014/main" id="{2958F9DE-8F04-4A5C-87F5-984AF22E3293}"/>
+                <a16:creationId xmlns:a16="http://schemas.microsoft.com/office/drawing/2014/main" id="{366BDFAE-DAAE-4040-82A1-3858DB571B52}"/>
               </a:ext>
             </a:extLst>
           </p:cNvPr>
@@ -24000,7 +24000,7 @@
           <p:cNvPr id="19" name="內容_3_每方案重複30次，報平均與9">
             <a:extLst xmlns:a="http://schemas.openxmlformats.org/drawingml/2006/main">
               <a:ext uri="{FF2B5EF4-FFF2-40B4-BE49-F238E27FC236}">
-                <a16:creationId xmlns:a16="http://schemas.microsoft.com/office/drawing/2014/main" id="{E0758B0A-7413-4573-B5D4-0B37407A4626}"/>
+                <a16:creationId xmlns:a16="http://schemas.microsoft.com/office/drawing/2014/main" id="{2D2FC233-3C25-4310-AC21-84AF4505205C}"/>
               </a:ext>
             </a:extLst>
           </p:cNvPr>
@@ -24156,7 +24156,7 @@
     </p:spTree>
     <p:extLst>
       <p:ext uri="{BB962C8B-B14F-4D97-AF65-F5344CB8AC3E}">
-        <p14:creationId xmlns:p14="http://schemas.microsoft.com/office/powerpoint/2010/main" val="314059529"/>
+        <p14:creationId xmlns:p14="http://schemas.microsoft.com/office/powerpoint/2010/main" val="457860364"/>
       </p:ext>
     </p:extLst>
   </p:cSld>
@@ -24180,7 +24180,7 @@
           <p:cNvPr id="2" name="Freeform 2">
             <a:extLst xmlns:a="http://schemas.openxmlformats.org/drawingml/2006/main">
               <a:ext uri="{FF2B5EF4-FFF2-40B4-BE49-F238E27FC236}">
-                <a16:creationId xmlns:a16="http://schemas.microsoft.com/office/drawing/2014/main" id="{84316A11-6113-41BD-A4EA-2CAC175E47F5}"/>
+                <a16:creationId xmlns:a16="http://schemas.microsoft.com/office/drawing/2014/main" id="{7B265A35-ADB3-4B2B-A0BA-B570E6E1D97E}"/>
               </a:ext>
             </a:extLst>
           </p:cNvPr>
@@ -24218,7 +24218,7 @@
             </a:pathLst>
           </a:custGeom>
           <a:blipFill xmlns:a="http://schemas.openxmlformats.org/drawingml/2006/main">
-            <a:blip xmlns:r="http://schemas.openxmlformats.org/officeDocument/2006/relationships" r:embed="Rcc1dbbdeedbf427e"/>
+            <a:blip xmlns:r="http://schemas.openxmlformats.org/officeDocument/2006/relationships" r:embed="R08e5b485363c4696"/>
             <a:stretch>
               <a:fillRect l="-35258" t="-5555" r="-24931" b="-72434"/>
             </a:stretch>
@@ -24230,7 +24230,7 @@
           <p:cNvPr id="4" name="Freeform 4">
             <a:extLst xmlns:a="http://schemas.openxmlformats.org/drawingml/2006/main">
               <a:ext uri="{FF2B5EF4-FFF2-40B4-BE49-F238E27FC236}">
-                <a16:creationId xmlns:a16="http://schemas.microsoft.com/office/drawing/2014/main" id="{457D2A52-F95E-45D7-882C-D0B6BD652F40}"/>
+                <a16:creationId xmlns:a16="http://schemas.microsoft.com/office/drawing/2014/main" id="{546B5B49-FE7E-48E8-8897-28B7486293D5}"/>
               </a:ext>
             </a:extLst>
           </p:cNvPr>
@@ -24304,7 +24304,7 @@
           <p:cNvPr id="5" name="TextBox 5">
             <a:extLst xmlns:a="http://schemas.openxmlformats.org/drawingml/2006/main">
               <a:ext uri="{FF2B5EF4-FFF2-40B4-BE49-F238E27FC236}">
-                <a16:creationId xmlns:a16="http://schemas.microsoft.com/office/drawing/2014/main" id="{7D0A9266-9E5E-4F04-866D-183829C1D651}"/>
+                <a16:creationId xmlns:a16="http://schemas.microsoft.com/office/drawing/2014/main" id="{2AD6863A-5153-4140-BAA7-71327D045B62}"/>
               </a:ext>
             </a:extLst>
           </p:cNvPr>
@@ -24340,7 +24340,7 @@
           <p:cNvPr id="6" name="Freeform 6">
             <a:extLst xmlns:a="http://schemas.openxmlformats.org/drawingml/2006/main">
               <a:ext uri="{FF2B5EF4-FFF2-40B4-BE49-F238E27FC236}">
-                <a16:creationId xmlns:a16="http://schemas.microsoft.com/office/drawing/2014/main" id="{48D35765-942A-40E7-8644-E26CF37AE47A}"/>
+                <a16:creationId xmlns:a16="http://schemas.microsoft.com/office/drawing/2014/main" id="{F1CB3193-9D6F-450F-9AD9-0381493F793B}"/>
               </a:ext>
             </a:extLst>
           </p:cNvPr>
@@ -24378,7 +24378,7 @@
             </a:pathLst>
           </a:custGeom>
           <a:blipFill xmlns:a="http://schemas.openxmlformats.org/drawingml/2006/main">
-            <a:blip xmlns:r="http://schemas.openxmlformats.org/officeDocument/2006/relationships" r:embed="Rb103b94aad3e4714"/>
+            <a:blip xmlns:r="http://schemas.openxmlformats.org/officeDocument/2006/relationships" r:embed="R2b68495f806142d7"/>
             <a:stretch>
               <a:fillRect l="0" t="0" r="0" b="0"/>
             </a:stretch>
@@ -24390,7 +24390,7 @@
           <p:cNvPr id="7" name="Freeform 7">
             <a:extLst xmlns:a="http://schemas.openxmlformats.org/drawingml/2006/main">
               <a:ext uri="{FF2B5EF4-FFF2-40B4-BE49-F238E27FC236}">
-                <a16:creationId xmlns:a16="http://schemas.microsoft.com/office/drawing/2014/main" id="{18A0130D-C320-4BF4-853D-E9AC8C36FD2C}"/>
+                <a16:creationId xmlns:a16="http://schemas.microsoft.com/office/drawing/2014/main" id="{A957D529-2587-4BF9-A2C4-348677B69058}"/>
               </a:ext>
             </a:extLst>
           </p:cNvPr>
@@ -24428,10 +24428,10 @@
             </a:pathLst>
           </a:custGeom>
           <a:blipFill xmlns:a="http://schemas.openxmlformats.org/drawingml/2006/main">
-            <a:blip xmlns:r="http://schemas.openxmlformats.org/officeDocument/2006/relationships" r:embed="R08f2abfc398e4ab4">
+            <a:blip xmlns:r="http://schemas.openxmlformats.org/officeDocument/2006/relationships" r:embed="R8e3f5ed1065345f2">
               <a:extLst>
                 <a:ext uri="{96DAC541-7B7A-43D3-8B79-37D633B846F1}">
-                  <asvg:svgBlip xmlns:asvg="http://schemas.microsoft.com/office/drawing/2016/SVG/main" r:embed="Re0e342745b224f03"/>
+                  <asvg:svgBlip xmlns:asvg="http://schemas.microsoft.com/office/drawing/2016/SVG/main" r:embed="R6a7c1a27b83d4dd3"/>
                 </a:ext>
               </a:extLst>
             </a:blip>
@@ -24446,7 +24446,7 @@
           <p:cNvPr id="8" name="Freeform 8">
             <a:extLst xmlns:a="http://schemas.openxmlformats.org/drawingml/2006/main">
               <a:ext uri="{FF2B5EF4-FFF2-40B4-BE49-F238E27FC236}">
-                <a16:creationId xmlns:a16="http://schemas.microsoft.com/office/drawing/2014/main" id="{5933915F-352C-49FA-A347-6B43943D67FA}"/>
+                <a16:creationId xmlns:a16="http://schemas.microsoft.com/office/drawing/2014/main" id="{FC35061B-C50E-4572-8E05-2D0579A4A56F}"/>
               </a:ext>
             </a:extLst>
           </p:cNvPr>
@@ -24484,10 +24484,10 @@
             </a:pathLst>
           </a:custGeom>
           <a:blipFill xmlns:a="http://schemas.openxmlformats.org/drawingml/2006/main">
-            <a:blip xmlns:r="http://schemas.openxmlformats.org/officeDocument/2006/relationships" r:embed="R08f2abfc398e4ab4">
+            <a:blip xmlns:r="http://schemas.openxmlformats.org/officeDocument/2006/relationships" r:embed="R8e3f5ed1065345f2">
               <a:extLst>
                 <a:ext uri="{96DAC541-7B7A-43D3-8B79-37D633B846F1}">
-                  <asvg:svgBlip xmlns:asvg="http://schemas.microsoft.com/office/drawing/2016/SVG/main" r:embed="Re0e342745b224f03"/>
+                  <asvg:svgBlip xmlns:asvg="http://schemas.microsoft.com/office/drawing/2016/SVG/main" r:embed="R6a7c1a27b83d4dd3"/>
                 </a:ext>
               </a:extLst>
             </a:blip>
@@ -24502,7 +24502,7 @@
           <p:cNvPr id="9" name="Freeform 9">
             <a:extLst xmlns:a="http://schemas.openxmlformats.org/drawingml/2006/main">
               <a:ext uri="{FF2B5EF4-FFF2-40B4-BE49-F238E27FC236}">
-                <a16:creationId xmlns:a16="http://schemas.microsoft.com/office/drawing/2014/main" id="{D2899B2B-1CF2-440F-9546-628358CC180A}"/>
+                <a16:creationId xmlns:a16="http://schemas.microsoft.com/office/drawing/2014/main" id="{8446ED29-0AE7-4989-A4AD-3D1C21167F6C}"/>
               </a:ext>
             </a:extLst>
           </p:cNvPr>
@@ -24550,7 +24550,7 @@
           <p:cNvPr id="10" name="Freeform 10">
             <a:extLst xmlns:a="http://schemas.openxmlformats.org/drawingml/2006/main">
               <a:ext uri="{FF2B5EF4-FFF2-40B4-BE49-F238E27FC236}">
-                <a16:creationId xmlns:a16="http://schemas.microsoft.com/office/drawing/2014/main" id="{5C303221-18C6-47E1-B521-875D41DEC602}"/>
+                <a16:creationId xmlns:a16="http://schemas.microsoft.com/office/drawing/2014/main" id="{63AD508A-1CE3-4CDC-B858-59F2C1F59627}"/>
               </a:ext>
             </a:extLst>
           </p:cNvPr>
@@ -24598,7 +24598,7 @@
           <p:cNvPr id="11" name="TextBox 11">
             <a:extLst xmlns:a="http://schemas.openxmlformats.org/drawingml/2006/main">
               <a:ext uri="{FF2B5EF4-FFF2-40B4-BE49-F238E27FC236}">
-                <a16:creationId xmlns:a16="http://schemas.microsoft.com/office/drawing/2014/main" id="{4FA4B58A-09B9-49E3-9BF6-C2C27EE330B4}"/>
+                <a16:creationId xmlns:a16="http://schemas.microsoft.com/office/drawing/2014/main" id="{1CC23A62-84A1-47C9-BF0E-DE9F57C2C4EF}"/>
               </a:ext>
             </a:extLst>
           </p:cNvPr>
@@ -24759,7 +24759,7 @@
           <p:cNvPr id="12" name="TextBox 12">
             <a:extLst xmlns:a="http://schemas.openxmlformats.org/drawingml/2006/main">
               <a:ext uri="{FF2B5EF4-FFF2-40B4-BE49-F238E27FC236}">
-                <a16:creationId xmlns:a16="http://schemas.microsoft.com/office/drawing/2014/main" id="{9C5A2443-7873-4F62-82F0-28C68F94D441}"/>
+                <a16:creationId xmlns:a16="http://schemas.microsoft.com/office/drawing/2014/main" id="{CA6B788A-8A4E-49EE-9F61-FF0E02A35668}"/>
               </a:ext>
             </a:extLst>
           </p:cNvPr>
@@ -24813,7 +24813,7 @@
           <p:cNvPr id="13" name="TextBox 13">
             <a:extLst xmlns:a="http://schemas.openxmlformats.org/drawingml/2006/main">
               <a:ext uri="{FF2B5EF4-FFF2-40B4-BE49-F238E27FC236}">
-                <a16:creationId xmlns:a16="http://schemas.microsoft.com/office/drawing/2014/main" id="{4B00BFB9-8D5D-4BAC-88E8-286F7160AD8F}"/>
+                <a16:creationId xmlns:a16="http://schemas.microsoft.com/office/drawing/2014/main" id="{FC8177F8-1A2E-448E-9AD9-66FACB69D4C4}"/>
               </a:ext>
             </a:extLst>
           </p:cNvPr>
@@ -24865,7 +24865,7 @@
           <p:cNvPr id="14" name="TextBox 14">
             <a:extLst xmlns:a="http://schemas.openxmlformats.org/drawingml/2006/main">
               <a:ext uri="{FF2B5EF4-FFF2-40B4-BE49-F238E27FC236}">
-                <a16:creationId xmlns:a16="http://schemas.microsoft.com/office/drawing/2014/main" id="{4F65D5D6-8147-4CFD-BBB2-59124187A6CD}"/>
+                <a16:creationId xmlns:a16="http://schemas.microsoft.com/office/drawing/2014/main" id="{B7533ED7-DA82-43AE-9CD2-1D8D15390984}"/>
               </a:ext>
             </a:extLst>
           </p:cNvPr>
@@ -24917,7 +24917,7 @@
           <p:cNvPr id="16" name="Freeform 16">
             <a:extLst xmlns:a="http://schemas.openxmlformats.org/drawingml/2006/main">
               <a:ext uri="{FF2B5EF4-FFF2-40B4-BE49-F238E27FC236}">
-                <a16:creationId xmlns:a16="http://schemas.microsoft.com/office/drawing/2014/main" id="{52E1C491-A989-446F-9018-EF0BA12912E0}"/>
+                <a16:creationId xmlns:a16="http://schemas.microsoft.com/office/drawing/2014/main" id="{004AB030-1B63-4356-B70B-84BB822AADF3}"/>
               </a:ext>
             </a:extLst>
           </p:cNvPr>
@@ -24976,7 +24976,7 @@
           <p:cNvPr id="17" name="TextBox 17">
             <a:extLst xmlns:a="http://schemas.openxmlformats.org/drawingml/2006/main">
               <a:ext uri="{FF2B5EF4-FFF2-40B4-BE49-F238E27FC236}">
-                <a16:creationId xmlns:a16="http://schemas.microsoft.com/office/drawing/2014/main" id="{EC08B9E9-27E8-446A-8FE6-49C8DC0AA408}"/>
+                <a16:creationId xmlns:a16="http://schemas.microsoft.com/office/drawing/2014/main" id="{5D8A6507-C1F1-437D-880D-4A83501C6BEF}"/>
               </a:ext>
             </a:extLst>
           </p:cNvPr>
@@ -25016,7 +25016,7 @@
           <p:cNvPr id="18" name="TextBox 18">
             <a:extLst xmlns:a="http://schemas.openxmlformats.org/drawingml/2006/main">
               <a:ext uri="{FF2B5EF4-FFF2-40B4-BE49-F238E27FC236}">
-                <a16:creationId xmlns:a16="http://schemas.microsoft.com/office/drawing/2014/main" id="{FF53A6F3-B1C0-4F7F-A9D4-4033945993CA}"/>
+                <a16:creationId xmlns:a16="http://schemas.microsoft.com/office/drawing/2014/main" id="{A939D5CF-D5F9-4129-AA0C-F6931B4664EF}"/>
               </a:ext>
             </a:extLst>
           </p:cNvPr>
@@ -25068,7 +25068,7 @@
           <p:cNvPr id="19" name="TextBox 19">
             <a:extLst xmlns:a="http://schemas.openxmlformats.org/drawingml/2006/main">
               <a:ext uri="{FF2B5EF4-FFF2-40B4-BE49-F238E27FC236}">
-                <a16:creationId xmlns:a16="http://schemas.microsoft.com/office/drawing/2014/main" id="{97424E86-E210-4B25-B9FA-1269BFBDBE18}"/>
+                <a16:creationId xmlns:a16="http://schemas.microsoft.com/office/drawing/2014/main" id="{D9C11750-0692-4CAC-84E7-43A6308010C3}"/>
               </a:ext>
             </a:extLst>
           </p:cNvPr>
@@ -25120,7 +25120,7 @@
           <p:cNvPr id="21" name="Freeform 21">
             <a:extLst xmlns:a="http://schemas.openxmlformats.org/drawingml/2006/main">
               <a:ext uri="{FF2B5EF4-FFF2-40B4-BE49-F238E27FC236}">
-                <a16:creationId xmlns:a16="http://schemas.microsoft.com/office/drawing/2014/main" id="{8F7EE56B-75CB-44BB-BEBB-5AA20B3C83B2}"/>
+                <a16:creationId xmlns:a16="http://schemas.microsoft.com/office/drawing/2014/main" id="{3EFB824A-7D09-4EFD-9CBD-26B93FDB4860}"/>
               </a:ext>
             </a:extLst>
           </p:cNvPr>
@@ -25179,7 +25179,7 @@
           <p:cNvPr id="22" name="TextBox 22">
             <a:extLst xmlns:a="http://schemas.openxmlformats.org/drawingml/2006/main">
               <a:ext uri="{FF2B5EF4-FFF2-40B4-BE49-F238E27FC236}">
-                <a16:creationId xmlns:a16="http://schemas.microsoft.com/office/drawing/2014/main" id="{C0E18678-0677-4880-8EA1-3AB5C479E582}"/>
+                <a16:creationId xmlns:a16="http://schemas.microsoft.com/office/drawing/2014/main" id="{E9CE38D6-A604-47D3-910A-2A36829797CC}"/>
               </a:ext>
             </a:extLst>
           </p:cNvPr>
@@ -25219,7 +25219,7 @@
           <p:cNvPr id="23" name="TextBox 23">
             <a:extLst xmlns:a="http://schemas.openxmlformats.org/drawingml/2006/main">
               <a:ext uri="{FF2B5EF4-FFF2-40B4-BE49-F238E27FC236}">
-                <a16:creationId xmlns:a16="http://schemas.microsoft.com/office/drawing/2014/main" id="{6E5E2061-8449-45E8-A925-0871CE016497}"/>
+                <a16:creationId xmlns:a16="http://schemas.microsoft.com/office/drawing/2014/main" id="{1FADBAC5-379C-4394-8B90-11D0299ECDE4}"/>
               </a:ext>
             </a:extLst>
           </p:cNvPr>
@@ -25271,7 +25271,7 @@
           <p:cNvPr id="24" name="TextBox 24">
             <a:extLst xmlns:a="http://schemas.openxmlformats.org/drawingml/2006/main">
               <a:ext uri="{FF2B5EF4-FFF2-40B4-BE49-F238E27FC236}">
-                <a16:creationId xmlns:a16="http://schemas.microsoft.com/office/drawing/2014/main" id="{68F7F21E-5686-4D95-94B3-1182E8B777ED}"/>
+                <a16:creationId xmlns:a16="http://schemas.microsoft.com/office/drawing/2014/main" id="{CC22EFA5-4F84-4C98-8A50-DC55EDC9EAFD}"/>
               </a:ext>
             </a:extLst>
           </p:cNvPr>
@@ -25323,7 +25323,7 @@
           <p:cNvPr id="25" name="">
             <a:extLst xmlns:a="http://schemas.openxmlformats.org/drawingml/2006/main">
               <a:ext uri="{FF2B5EF4-FFF2-40B4-BE49-F238E27FC236}">
-                <a16:creationId xmlns:a16="http://schemas.microsoft.com/office/drawing/2014/main" id="{25BC2096-5958-476F-9E40-B82F450EA331}"/>
+                <a16:creationId xmlns:a16="http://schemas.microsoft.com/office/drawing/2014/main" id="{08F33A00-BDD1-4214-AB00-614D6352C140}"/>
               </a:ext>
             </a:extLst>
           </p:cNvPr>
@@ -25333,7 +25333,7 @@
           <p:nvPr/>
         </p:nvPicPr>
         <p:blipFill>
-          <a:blip xmlns:r="http://schemas.openxmlformats.org/officeDocument/2006/relationships" xmlns:a="http://schemas.openxmlformats.org/drawingml/2006/main" r:embed="R5c618ce79824412f"/>
+          <a:blip xmlns:r="http://schemas.openxmlformats.org/officeDocument/2006/relationships" xmlns:a="http://schemas.openxmlformats.org/drawingml/2006/main" r:embed="R698ceadd78ed45c3"/>
           <a:srcRect xmlns:a="http://schemas.openxmlformats.org/drawingml/2006/main" l="45370" t="10500" r="0" b="0"/>
           <a:stretch xmlns:a="http://schemas.openxmlformats.org/drawingml/2006/main"/>
         </p:blipFill>
@@ -25352,7 +25352,7 @@
           <p:cNvPr id="26" name="內容_4_雙閉環架構">
             <a:extLst xmlns:a="http://schemas.openxmlformats.org/drawingml/2006/main">
               <a:ext uri="{FF2B5EF4-FFF2-40B4-BE49-F238E27FC236}">
-                <a16:creationId xmlns:a16="http://schemas.microsoft.com/office/drawing/2014/main" id="{F07BA686-2754-45BE-AD5F-BAB7E52EB8E6}"/>
+                <a16:creationId xmlns:a16="http://schemas.microsoft.com/office/drawing/2014/main" id="{FD30DDFF-9D69-4A2B-9006-C7AF92821002}"/>
               </a:ext>
             </a:extLst>
           </p:cNvPr>
@@ -25510,7 +25510,7 @@
           <p:cNvPr id="27" name="內容_4_商品與循環箱分離後再配對">
             <a:extLst xmlns:a="http://schemas.openxmlformats.org/drawingml/2006/main">
               <a:ext uri="{FF2B5EF4-FFF2-40B4-BE49-F238E27FC236}">
-                <a16:creationId xmlns:a16="http://schemas.microsoft.com/office/drawing/2014/main" id="{436A6468-10E9-4AE3-AFBD-BAD5B92F3F8A}"/>
+                <a16:creationId xmlns:a16="http://schemas.microsoft.com/office/drawing/2014/main" id="{37048AD3-9A24-4F63-99F3-098327ABC6D5}"/>
               </a:ext>
             </a:extLst>
           </p:cNvPr>
@@ -25668,7 +25668,7 @@
           <p:cNvPr id="28" name="">
             <a:extLst xmlns:a="http://schemas.openxmlformats.org/drawingml/2006/main">
               <a:ext uri="{FF2B5EF4-FFF2-40B4-BE49-F238E27FC236}">
-                <a16:creationId xmlns:a16="http://schemas.microsoft.com/office/drawing/2014/main" id="{32860211-6CAC-46CE-81DC-4B55650917C1}"/>
+                <a16:creationId xmlns:a16="http://schemas.microsoft.com/office/drawing/2014/main" id="{FF7D96AB-83FE-4CFD-B18F-456F16852129}"/>
               </a:ext>
             </a:extLst>
           </p:cNvPr>
@@ -25853,7 +25853,7 @@
           <p:cNvPr id="29" name="">
             <a:extLst xmlns:a="http://schemas.openxmlformats.org/drawingml/2006/main">
               <a:ext uri="{FF2B5EF4-FFF2-40B4-BE49-F238E27FC236}">
-                <a16:creationId xmlns:a16="http://schemas.microsoft.com/office/drawing/2014/main" id="{6E48385C-D43D-410D-B33A-DFFF38B650F1}"/>
+                <a16:creationId xmlns:a16="http://schemas.microsoft.com/office/drawing/2014/main" id="{E939DDC4-A3E3-420C-BFCB-0647C802DA7F}"/>
               </a:ext>
             </a:extLst>
           </p:cNvPr>
@@ -26038,7 +26038,7 @@
           <p:cNvPr id="30" name="">
             <a:extLst xmlns:a="http://schemas.openxmlformats.org/drawingml/2006/main">
               <a:ext uri="{FF2B5EF4-FFF2-40B4-BE49-F238E27FC236}">
-                <a16:creationId xmlns:a16="http://schemas.microsoft.com/office/drawing/2014/main" id="{7C7ABDD4-95FE-4BA8-8A7D-B7CBBD38B983}"/>
+                <a16:creationId xmlns:a16="http://schemas.microsoft.com/office/drawing/2014/main" id="{8C40BBAE-5FB5-4AB0-8F62-08664383F1CF}"/>
               </a:ext>
             </a:extLst>
           </p:cNvPr>
@@ -26223,7 +26223,7 @@
           <p:cNvPr id="31" name="">
             <a:extLst xmlns:a="http://schemas.openxmlformats.org/drawingml/2006/main">
               <a:ext uri="{FF2B5EF4-FFF2-40B4-BE49-F238E27FC236}">
-                <a16:creationId xmlns:a16="http://schemas.microsoft.com/office/drawing/2014/main" id="{BF3F3F86-BEC5-40A4-980D-644BE3352F1B}"/>
+                <a16:creationId xmlns:a16="http://schemas.microsoft.com/office/drawing/2014/main" id="{65F0CEF4-651B-487E-8960-BE38A4CF92DE}"/>
               </a:ext>
             </a:extLst>
           </p:cNvPr>
@@ -26408,7 +26408,7 @@
           <p:cNvPr id="32" name="">
             <a:extLst xmlns:a="http://schemas.openxmlformats.org/drawingml/2006/main">
               <a:ext uri="{FF2B5EF4-FFF2-40B4-BE49-F238E27FC236}">
-                <a16:creationId xmlns:a16="http://schemas.microsoft.com/office/drawing/2014/main" id="{C54B245C-6DAE-4ED7-9A61-0DE78FA5A0E8}"/>
+                <a16:creationId xmlns:a16="http://schemas.microsoft.com/office/drawing/2014/main" id="{BF6E3E6E-C5FA-4CCB-8807-E48B4E2D987C}"/>
               </a:ext>
             </a:extLst>
           </p:cNvPr>
@@ -26593,7 +26593,7 @@
           <p:cNvPr id="33" name="">
             <a:extLst xmlns:a="http://schemas.openxmlformats.org/drawingml/2006/main">
               <a:ext uri="{FF2B5EF4-FFF2-40B4-BE49-F238E27FC236}">
-                <a16:creationId xmlns:a16="http://schemas.microsoft.com/office/drawing/2014/main" id="{BCD6CA7C-DC57-4158-AF48-73E6A60C9071}"/>
+                <a16:creationId xmlns:a16="http://schemas.microsoft.com/office/drawing/2014/main" id="{697C8F7F-338E-4FAB-8365-BB447795A08D}"/>
               </a:ext>
             </a:extLst>
           </p:cNvPr>
@@ -26778,7 +26778,7 @@
           <p:cNvPr id="34" name="">
             <a:extLst xmlns:a="http://schemas.openxmlformats.org/drawingml/2006/main">
               <a:ext uri="{FF2B5EF4-FFF2-40B4-BE49-F238E27FC236}">
-                <a16:creationId xmlns:a16="http://schemas.microsoft.com/office/drawing/2014/main" id="{F855D70A-4188-4DD8-B3BB-B1F543D0BD24}"/>
+                <a16:creationId xmlns:a16="http://schemas.microsoft.com/office/drawing/2014/main" id="{28A95589-FE5F-4DBF-941B-44EE1D32CF31}"/>
               </a:ext>
             </a:extLst>
           </p:cNvPr>
@@ -26963,7 +26963,7 @@
           <p:cNvPr id="35" name="內容_4_↗">
             <a:extLst xmlns:a="http://schemas.openxmlformats.org/drawingml/2006/main">
               <a:ext uri="{FF2B5EF4-FFF2-40B4-BE49-F238E27FC236}">
-                <a16:creationId xmlns:a16="http://schemas.microsoft.com/office/drawing/2014/main" id="{902B4C31-6504-4301-99B6-A57166A2AF86}"/>
+                <a16:creationId xmlns:a16="http://schemas.microsoft.com/office/drawing/2014/main" id="{C795830A-3E58-43C8-AE29-AFA03E4DA5B8}"/>
               </a:ext>
             </a:extLst>
           </p:cNvPr>
@@ -27121,7 +27121,7 @@
           <p:cNvPr id="36" name="內容_4_→">
             <a:extLst xmlns:a="http://schemas.openxmlformats.org/drawingml/2006/main">
               <a:ext uri="{FF2B5EF4-FFF2-40B4-BE49-F238E27FC236}">
-                <a16:creationId xmlns:a16="http://schemas.microsoft.com/office/drawing/2014/main" id="{0288791D-D715-4099-B1A1-A73EBADA7C55}"/>
+                <a16:creationId xmlns:a16="http://schemas.microsoft.com/office/drawing/2014/main" id="{9EC27487-2AD2-47E5-A84E-D3081AA5C3ED}"/>
               </a:ext>
             </a:extLst>
           </p:cNvPr>
@@ -27279,7 +27279,7 @@
           <p:cNvPr id="37" name="內容_4_↘">
             <a:extLst xmlns:a="http://schemas.openxmlformats.org/drawingml/2006/main">
               <a:ext uri="{FF2B5EF4-FFF2-40B4-BE49-F238E27FC236}">
-                <a16:creationId xmlns:a16="http://schemas.microsoft.com/office/drawing/2014/main" id="{C5E51052-80A8-4F7A-AB44-223D86F6C7DB}"/>
+                <a16:creationId xmlns:a16="http://schemas.microsoft.com/office/drawing/2014/main" id="{5B32DEF0-A97A-4630-9614-03D34B499399}"/>
               </a:ext>
             </a:extLst>
           </p:cNvPr>
@@ -27437,7 +27437,7 @@
           <p:cNvPr id="38" name="內容_4_↘">
             <a:extLst xmlns:a="http://schemas.openxmlformats.org/drawingml/2006/main">
               <a:ext uri="{FF2B5EF4-FFF2-40B4-BE49-F238E27FC236}">
-                <a16:creationId xmlns:a16="http://schemas.microsoft.com/office/drawing/2014/main" id="{EDD5AC4D-B283-43FE-AA07-AD773359E227}"/>
+                <a16:creationId xmlns:a16="http://schemas.microsoft.com/office/drawing/2014/main" id="{E133F623-E5A3-4E25-A605-444CCFB84520}"/>
               </a:ext>
             </a:extLst>
           </p:cNvPr>
@@ -27595,7 +27595,7 @@
           <p:cNvPr id="39" name="內容_4_→">
             <a:extLst xmlns:a="http://schemas.openxmlformats.org/drawingml/2006/main">
               <a:ext uri="{FF2B5EF4-FFF2-40B4-BE49-F238E27FC236}">
-                <a16:creationId xmlns:a16="http://schemas.microsoft.com/office/drawing/2014/main" id="{EB9B485B-4315-4BE4-8A7D-FD1D8E1D4986}"/>
+                <a16:creationId xmlns:a16="http://schemas.microsoft.com/office/drawing/2014/main" id="{727FF3C7-4A4E-4B84-941A-B567EA0D4C97}"/>
               </a:ext>
             </a:extLst>
           </p:cNvPr>
@@ -27753,7 +27753,7 @@
           <p:cNvPr id="40" name="內容_4_↗">
             <a:extLst xmlns:a="http://schemas.openxmlformats.org/drawingml/2006/main">
               <a:ext uri="{FF2B5EF4-FFF2-40B4-BE49-F238E27FC236}">
-                <a16:creationId xmlns:a16="http://schemas.microsoft.com/office/drawing/2014/main" id="{B4DA2387-2306-42AA-B18B-CBDB89449989}"/>
+                <a16:creationId xmlns:a16="http://schemas.microsoft.com/office/drawing/2014/main" id="{5FCC1047-599F-402A-B986-9DBC1232A703}"/>
               </a:ext>
             </a:extLst>
           </p:cNvPr>
@@ -27911,7 +27911,7 @@
           <p:cNvPr id="41" name="內容_4_→">
             <a:extLst xmlns:a="http://schemas.openxmlformats.org/drawingml/2006/main">
               <a:ext uri="{FF2B5EF4-FFF2-40B4-BE49-F238E27FC236}">
-                <a16:creationId xmlns:a16="http://schemas.microsoft.com/office/drawing/2014/main" id="{6EA951FD-B63C-4B44-95F1-77EF6C8FCE25}"/>
+                <a16:creationId xmlns:a16="http://schemas.microsoft.com/office/drawing/2014/main" id="{81202FAE-B5AD-4410-A736-D05785F29056}"/>
               </a:ext>
             </a:extLst>
           </p:cNvPr>
@@ -28069,7 +28069,7 @@
           <p:cNvPr id="42" name="內容_4_有限500箱資產池，每箱15">
             <a:extLst xmlns:a="http://schemas.openxmlformats.org/drawingml/2006/main">
               <a:ext uri="{FF2B5EF4-FFF2-40B4-BE49-F238E27FC236}">
-                <a16:creationId xmlns:a16="http://schemas.microsoft.com/office/drawing/2014/main" id="{123D6470-C58A-41C6-B607-F37E53300D76}"/>
+                <a16:creationId xmlns:a16="http://schemas.microsoft.com/office/drawing/2014/main" id="{121D58D1-590E-4D7F-B4A8-20B412463C44}"/>
               </a:ext>
             </a:extLst>
           </p:cNvPr>
@@ -28227,7 +28227,7 @@
           <p:cNvPr id="43" name="內容_4_A級做簡單整理，B級需整新，">
             <a:extLst xmlns:a="http://schemas.openxmlformats.org/drawingml/2006/main">
               <a:ext uri="{FF2B5EF4-FFF2-40B4-BE49-F238E27FC236}">
-                <a16:creationId xmlns:a16="http://schemas.microsoft.com/office/drawing/2014/main" id="{4AE20F96-9FB2-40F8-B7E8-A73B2431700A}"/>
+                <a16:creationId xmlns:a16="http://schemas.microsoft.com/office/drawing/2014/main" id="{C15FC290-4F08-4FEE-A42B-FDFEDD7B581A}"/>
               </a:ext>
             </a:extLst>
           </p:cNvPr>
@@ -28383,7 +28383,7 @@
     </p:spTree>
     <p:extLst>
       <p:ext uri="{BB962C8B-B14F-4D97-AF65-F5344CB8AC3E}">
-        <p14:creationId xmlns:p14="http://schemas.microsoft.com/office/powerpoint/2010/main" val="765238933"/>
+        <p14:creationId xmlns:p14="http://schemas.microsoft.com/office/powerpoint/2010/main" val="2033662932"/>
       </p:ext>
     </p:extLst>
   </p:cSld>
@@ -28407,7 +28407,7 @@
           <p:cNvPr id="2" name="Freeform 2">
             <a:extLst xmlns:a="http://schemas.openxmlformats.org/drawingml/2006/main">
               <a:ext uri="{FF2B5EF4-FFF2-40B4-BE49-F238E27FC236}">
-                <a16:creationId xmlns:a16="http://schemas.microsoft.com/office/drawing/2014/main" id="{3F70B8E4-080C-4FEE-BD09-130F09ED3D49}"/>
+                <a16:creationId xmlns:a16="http://schemas.microsoft.com/office/drawing/2014/main" id="{80B069E8-5190-477E-803C-58B0EB527DEB}"/>
               </a:ext>
             </a:extLst>
           </p:cNvPr>
@@ -28445,7 +28445,7 @@
             </a:pathLst>
           </a:custGeom>
           <a:blipFill xmlns:a="http://schemas.openxmlformats.org/drawingml/2006/main">
-            <a:blip xmlns:r="http://schemas.openxmlformats.org/officeDocument/2006/relationships" r:embed="Rff56e7321da24d7d"/>
+            <a:blip xmlns:r="http://schemas.openxmlformats.org/officeDocument/2006/relationships" r:embed="R8102c6ea40584920"/>
             <a:stretch>
               <a:fillRect l="-35258" t="-5555" r="-24931" b="-72434"/>
             </a:stretch>
@@ -28457,7 +28457,7 @@
           <p:cNvPr id="4" name="Freeform 4">
             <a:extLst xmlns:a="http://schemas.openxmlformats.org/drawingml/2006/main">
               <a:ext uri="{FF2B5EF4-FFF2-40B4-BE49-F238E27FC236}">
-                <a16:creationId xmlns:a16="http://schemas.microsoft.com/office/drawing/2014/main" id="{FD27ABE3-05A3-4A5C-BB3D-1F8EE84F2DA6}"/>
+                <a16:creationId xmlns:a16="http://schemas.microsoft.com/office/drawing/2014/main" id="{BBC6E666-2BBC-415A-A72C-226A9E578445}"/>
               </a:ext>
             </a:extLst>
           </p:cNvPr>
@@ -28531,7 +28531,7 @@
           <p:cNvPr id="5" name="TextBox 5">
             <a:extLst xmlns:a="http://schemas.openxmlformats.org/drawingml/2006/main">
               <a:ext uri="{FF2B5EF4-FFF2-40B4-BE49-F238E27FC236}">
-                <a16:creationId xmlns:a16="http://schemas.microsoft.com/office/drawing/2014/main" id="{684B43DA-E321-4DEA-927B-49B735EBA270}"/>
+                <a16:creationId xmlns:a16="http://schemas.microsoft.com/office/drawing/2014/main" id="{D3376BAB-6EC8-46E9-B186-6564C82097CC}"/>
               </a:ext>
             </a:extLst>
           </p:cNvPr>
@@ -28567,7 +28567,7 @@
           <p:cNvPr id="6" name="Freeform 6">
             <a:extLst xmlns:a="http://schemas.openxmlformats.org/drawingml/2006/main">
               <a:ext uri="{FF2B5EF4-FFF2-40B4-BE49-F238E27FC236}">
-                <a16:creationId xmlns:a16="http://schemas.microsoft.com/office/drawing/2014/main" id="{311B51E4-9625-4011-A0F1-DA888BD6FD28}"/>
+                <a16:creationId xmlns:a16="http://schemas.microsoft.com/office/drawing/2014/main" id="{3EC7A356-98E8-4101-A337-1ED72E316E4E}"/>
               </a:ext>
             </a:extLst>
           </p:cNvPr>
@@ -28605,7 +28605,7 @@
             </a:pathLst>
           </a:custGeom>
           <a:blipFill xmlns:a="http://schemas.openxmlformats.org/drawingml/2006/main">
-            <a:blip xmlns:r="http://schemas.openxmlformats.org/officeDocument/2006/relationships" r:embed="R886a694ff6ef4c59"/>
+            <a:blip xmlns:r="http://schemas.openxmlformats.org/officeDocument/2006/relationships" r:embed="Rfb61269ab61d4075"/>
             <a:stretch>
               <a:fillRect l="0" t="0" r="0" b="0"/>
             </a:stretch>
@@ -28617,7 +28617,7 @@
           <p:cNvPr id="7" name="Freeform 7">
             <a:extLst xmlns:a="http://schemas.openxmlformats.org/drawingml/2006/main">
               <a:ext uri="{FF2B5EF4-FFF2-40B4-BE49-F238E27FC236}">
-                <a16:creationId xmlns:a16="http://schemas.microsoft.com/office/drawing/2014/main" id="{A1020F76-AF9C-4880-8857-22BAB2911ED4}"/>
+                <a16:creationId xmlns:a16="http://schemas.microsoft.com/office/drawing/2014/main" id="{B56F1602-11CF-48A9-8780-922B811629A9}"/>
               </a:ext>
             </a:extLst>
           </p:cNvPr>
@@ -28655,10 +28655,10 @@
             </a:pathLst>
           </a:custGeom>
           <a:blipFill xmlns:a="http://schemas.openxmlformats.org/drawingml/2006/main">
-            <a:blip xmlns:r="http://schemas.openxmlformats.org/officeDocument/2006/relationships" r:embed="R654f1d4f1a3746ba">
+            <a:blip xmlns:r="http://schemas.openxmlformats.org/officeDocument/2006/relationships" r:embed="R713b25976bfb44f2">
               <a:extLst>
                 <a:ext uri="{96DAC541-7B7A-43D3-8B79-37D633B846F1}">
-                  <asvg:svgBlip xmlns:asvg="http://schemas.microsoft.com/office/drawing/2016/SVG/main" r:embed="Ra215b423f1ff4f97"/>
+                  <asvg:svgBlip xmlns:asvg="http://schemas.microsoft.com/office/drawing/2016/SVG/main" r:embed="R3fda6af6a7404ab0"/>
                 </a:ext>
               </a:extLst>
             </a:blip>
@@ -28673,7 +28673,7 @@
           <p:cNvPr id="8" name="Freeform 8">
             <a:extLst xmlns:a="http://schemas.openxmlformats.org/drawingml/2006/main">
               <a:ext uri="{FF2B5EF4-FFF2-40B4-BE49-F238E27FC236}">
-                <a16:creationId xmlns:a16="http://schemas.microsoft.com/office/drawing/2014/main" id="{2EA81DCC-AF10-4424-9A45-9EDB99B235BA}"/>
+                <a16:creationId xmlns:a16="http://schemas.microsoft.com/office/drawing/2014/main" id="{6D84E7C3-F07B-40CD-9F71-827C2C8562A4}"/>
               </a:ext>
             </a:extLst>
           </p:cNvPr>
@@ -28711,10 +28711,10 @@
             </a:pathLst>
           </a:custGeom>
           <a:blipFill xmlns:a="http://schemas.openxmlformats.org/drawingml/2006/main">
-            <a:blip xmlns:r="http://schemas.openxmlformats.org/officeDocument/2006/relationships" r:embed="R654f1d4f1a3746ba">
+            <a:blip xmlns:r="http://schemas.openxmlformats.org/officeDocument/2006/relationships" r:embed="R713b25976bfb44f2">
               <a:extLst>
                 <a:ext uri="{96DAC541-7B7A-43D3-8B79-37D633B846F1}">
-                  <asvg:svgBlip xmlns:asvg="http://schemas.microsoft.com/office/drawing/2016/SVG/main" r:embed="Ra215b423f1ff4f97"/>
+                  <asvg:svgBlip xmlns:asvg="http://schemas.microsoft.com/office/drawing/2016/SVG/main" r:embed="R3fda6af6a7404ab0"/>
                 </a:ext>
               </a:extLst>
             </a:blip>
@@ -28729,7 +28729,7 @@
           <p:cNvPr id="9" name="Freeform 9">
             <a:extLst xmlns:a="http://schemas.openxmlformats.org/drawingml/2006/main">
               <a:ext uri="{FF2B5EF4-FFF2-40B4-BE49-F238E27FC236}">
-                <a16:creationId xmlns:a16="http://schemas.microsoft.com/office/drawing/2014/main" id="{F576D18E-69AA-4E69-A70D-F80B00FC7EA1}"/>
+                <a16:creationId xmlns:a16="http://schemas.microsoft.com/office/drawing/2014/main" id="{FF418079-2F9A-439E-B135-FEB17FBF2992}"/>
               </a:ext>
             </a:extLst>
           </p:cNvPr>
@@ -28777,7 +28777,7 @@
           <p:cNvPr id="10" name="TextBox 10">
             <a:extLst xmlns:a="http://schemas.openxmlformats.org/drawingml/2006/main">
               <a:ext uri="{FF2B5EF4-FFF2-40B4-BE49-F238E27FC236}">
-                <a16:creationId xmlns:a16="http://schemas.microsoft.com/office/drawing/2014/main" id="{F7519A7D-25C9-409B-BC12-3975219269A4}"/>
+                <a16:creationId xmlns:a16="http://schemas.microsoft.com/office/drawing/2014/main" id="{CF183161-AD02-4A1C-91CD-314806B21753}"/>
               </a:ext>
             </a:extLst>
           </p:cNvPr>
@@ -28938,7 +28938,7 @@
           <p:cNvPr id="11" name="TextBox 11">
             <a:extLst xmlns:a="http://schemas.openxmlformats.org/drawingml/2006/main">
               <a:ext uri="{FF2B5EF4-FFF2-40B4-BE49-F238E27FC236}">
-                <a16:creationId xmlns:a16="http://schemas.microsoft.com/office/drawing/2014/main" id="{6E8564D9-E8E1-48F2-A927-A0EB9D3EFC82}"/>
+                <a16:creationId xmlns:a16="http://schemas.microsoft.com/office/drawing/2014/main" id="{75E4290E-71B5-41A8-A8A3-83BE7888E401}"/>
               </a:ext>
             </a:extLst>
           </p:cNvPr>
@@ -28992,7 +28992,7 @@
           <p:cNvPr id="12" name="TextBox 12">
             <a:extLst xmlns:a="http://schemas.openxmlformats.org/drawingml/2006/main">
               <a:ext uri="{FF2B5EF4-FFF2-40B4-BE49-F238E27FC236}">
-                <a16:creationId xmlns:a16="http://schemas.microsoft.com/office/drawing/2014/main" id="{1ABEADA7-2635-4490-B6C2-0D879CBC730B}"/>
+                <a16:creationId xmlns:a16="http://schemas.microsoft.com/office/drawing/2014/main" id="{F98A6BFC-2DE8-4C16-9383-C1B10CC574B9}"/>
               </a:ext>
             </a:extLst>
           </p:cNvPr>
@@ -29044,7 +29044,7 @@
           <p:cNvPr id="13" name="TextBox 13">
             <a:extLst xmlns:a="http://schemas.openxmlformats.org/drawingml/2006/main">
               <a:ext uri="{FF2B5EF4-FFF2-40B4-BE49-F238E27FC236}">
-                <a16:creationId xmlns:a16="http://schemas.microsoft.com/office/drawing/2014/main" id="{243354D3-5DDA-45F9-A367-4A923DAAB1A9}"/>
+                <a16:creationId xmlns:a16="http://schemas.microsoft.com/office/drawing/2014/main" id="{80204B22-B7B0-4765-95AB-90294EF0B774}"/>
               </a:ext>
             </a:extLst>
           </p:cNvPr>
@@ -29096,7 +29096,7 @@
           <p:cNvPr id="14" name="Freeform 14">
             <a:extLst xmlns:a="http://schemas.openxmlformats.org/drawingml/2006/main">
               <a:ext uri="{FF2B5EF4-FFF2-40B4-BE49-F238E27FC236}">
-                <a16:creationId xmlns:a16="http://schemas.microsoft.com/office/drawing/2014/main" id="{F372BD86-7588-438A-9DD6-D60604B9D526}"/>
+                <a16:creationId xmlns:a16="http://schemas.microsoft.com/office/drawing/2014/main" id="{A662ED12-2260-4195-A222-C98216C78420}"/>
               </a:ext>
             </a:extLst>
           </p:cNvPr>
@@ -29144,7 +29144,7 @@
           <p:cNvPr id="15" name="Freeform 15">
             <a:extLst xmlns:a="http://schemas.openxmlformats.org/drawingml/2006/main">
               <a:ext uri="{FF2B5EF4-FFF2-40B4-BE49-F238E27FC236}">
-                <a16:creationId xmlns:a16="http://schemas.microsoft.com/office/drawing/2014/main" id="{C24FC02E-F374-46D0-8B12-9BF645B5A15D}"/>
+                <a16:creationId xmlns:a16="http://schemas.microsoft.com/office/drawing/2014/main" id="{68F751B0-C4F9-406E-8933-5BC00909B4D5}"/>
               </a:ext>
             </a:extLst>
           </p:cNvPr>
@@ -29192,7 +29192,7 @@
           <p:cNvPr id="16" name="TextBox 16">
             <a:extLst xmlns:a="http://schemas.openxmlformats.org/drawingml/2006/main">
               <a:ext uri="{FF2B5EF4-FFF2-40B4-BE49-F238E27FC236}">
-                <a16:creationId xmlns:a16="http://schemas.microsoft.com/office/drawing/2014/main" id="{B1CA8324-0D50-44FD-B000-C3D6D6ABDC54}"/>
+                <a16:creationId xmlns:a16="http://schemas.microsoft.com/office/drawing/2014/main" id="{04BF0326-39DF-4879-BCA4-0B70E767C9B1}"/>
               </a:ext>
             </a:extLst>
           </p:cNvPr>
@@ -29241,7 +29241,7 @@
           <p:cNvPr id="17" name="TextBox 17">
             <a:extLst xmlns:a="http://schemas.openxmlformats.org/drawingml/2006/main">
               <a:ext uri="{FF2B5EF4-FFF2-40B4-BE49-F238E27FC236}">
-                <a16:creationId xmlns:a16="http://schemas.microsoft.com/office/drawing/2014/main" id="{BA00C6F7-ABC3-4121-BB5A-A534CD70997C}"/>
+                <a16:creationId xmlns:a16="http://schemas.microsoft.com/office/drawing/2014/main" id="{67B17FC6-2058-4E5F-B290-C1624E454B70}"/>
               </a:ext>
             </a:extLst>
           </p:cNvPr>
@@ -29290,7 +29290,7 @@
           <p:cNvPr id="18" name="TextBox 18">
             <a:extLst xmlns:a="http://schemas.openxmlformats.org/drawingml/2006/main">
               <a:ext uri="{FF2B5EF4-FFF2-40B4-BE49-F238E27FC236}">
-                <a16:creationId xmlns:a16="http://schemas.microsoft.com/office/drawing/2014/main" id="{FB684131-2548-4F1C-86B5-1730C00EA5EC}"/>
+                <a16:creationId xmlns:a16="http://schemas.microsoft.com/office/drawing/2014/main" id="{20818FD8-56C5-4707-95B1-22504B601A8A}"/>
               </a:ext>
             </a:extLst>
           </p:cNvPr>
@@ -29339,7 +29339,7 @@
           <p:cNvPr id="19" name="TextBox 19">
             <a:extLst xmlns:a="http://schemas.openxmlformats.org/drawingml/2006/main">
               <a:ext uri="{FF2B5EF4-FFF2-40B4-BE49-F238E27FC236}">
-                <a16:creationId xmlns:a16="http://schemas.microsoft.com/office/drawing/2014/main" id="{2C3DEC86-1F95-4661-86C1-4D7092E01ECA}"/>
+                <a16:creationId xmlns:a16="http://schemas.microsoft.com/office/drawing/2014/main" id="{0D2CDDD4-F717-493E-80A0-CFBA9CDE79E7}"/>
               </a:ext>
             </a:extLst>
           </p:cNvPr>
@@ -29391,7 +29391,7 @@
           <p:cNvPr id="20" name="TextBox 20">
             <a:extLst xmlns:a="http://schemas.openxmlformats.org/drawingml/2006/main">
               <a:ext uri="{FF2B5EF4-FFF2-40B4-BE49-F238E27FC236}">
-                <a16:creationId xmlns:a16="http://schemas.microsoft.com/office/drawing/2014/main" id="{47F41C8F-62F2-4918-82BB-B79ACB2EDFF0}"/>
+                <a16:creationId xmlns:a16="http://schemas.microsoft.com/office/drawing/2014/main" id="{164E9B70-FC79-49B5-84B8-070013965F4A}"/>
               </a:ext>
             </a:extLst>
           </p:cNvPr>
@@ -29443,7 +29443,7 @@
           <p:cNvPr id="21" name="TextBox 21">
             <a:extLst xmlns:a="http://schemas.openxmlformats.org/drawingml/2006/main">
               <a:ext uri="{FF2B5EF4-FFF2-40B4-BE49-F238E27FC236}">
-                <a16:creationId xmlns:a16="http://schemas.microsoft.com/office/drawing/2014/main" id="{4AC25130-67DC-48B4-AD86-E719BD0D4903}"/>
+                <a16:creationId xmlns:a16="http://schemas.microsoft.com/office/drawing/2014/main" id="{13ACD4AC-09D5-4E33-BA28-55B56F5DCFC7}"/>
               </a:ext>
             </a:extLst>
           </p:cNvPr>
@@ -29495,7 +29495,7 @@
           <p:cNvPr id="22" name="內容_5_三維倉庫佈局">
             <a:extLst xmlns:a="http://schemas.openxmlformats.org/drawingml/2006/main">
               <a:ext uri="{FF2B5EF4-FFF2-40B4-BE49-F238E27FC236}">
-                <a16:creationId xmlns:a16="http://schemas.microsoft.com/office/drawing/2014/main" id="{6926D982-AC07-4798-90B3-EBD46D847C6E}"/>
+                <a16:creationId xmlns:a16="http://schemas.microsoft.com/office/drawing/2014/main" id="{2E9BB2E3-5A89-4E62-8A30-5F0AAB226696}"/>
               </a:ext>
             </a:extLst>
           </p:cNvPr>
@@ -29653,7 +29653,7 @@
           <p:cNvPr id="23" name="內容_5_雙層輸送網的原生運行畫面">
             <a:extLst xmlns:a="http://schemas.openxmlformats.org/drawingml/2006/main">
               <a:ext uri="{FF2B5EF4-FFF2-40B4-BE49-F238E27FC236}">
-                <a16:creationId xmlns:a16="http://schemas.microsoft.com/office/drawing/2014/main" id="{2EEBD832-39B3-4604-AC50-DCAAA304AAFF}"/>
+                <a16:creationId xmlns:a16="http://schemas.microsoft.com/office/drawing/2014/main" id="{76C0AE6B-6558-4C56-BD8F-1FAEE669574F}"/>
               </a:ext>
             </a:extLst>
           </p:cNvPr>
@@ -29811,7 +29811,7 @@
           <p:cNvPr id="24" name="">
             <a:extLst xmlns:a="http://schemas.openxmlformats.org/drawingml/2006/main">
               <a:ext uri="{FF2B5EF4-FFF2-40B4-BE49-F238E27FC236}">
-                <a16:creationId xmlns:a16="http://schemas.microsoft.com/office/drawing/2014/main" id="{21721BD8-DAE5-47F3-9E13-1A5F3D004583}"/>
+                <a16:creationId xmlns:a16="http://schemas.microsoft.com/office/drawing/2014/main" id="{22D7A6A1-55C3-47C0-B373-C76A6D7B8FE6}"/>
               </a:ext>
             </a:extLst>
           </p:cNvPr>
@@ -29821,7 +29821,7 @@
           <p:nvPr/>
         </p:nvPicPr>
         <p:blipFill>
-          <a:blip xmlns:r="http://schemas.openxmlformats.org/officeDocument/2006/relationships" xmlns:a="http://schemas.openxmlformats.org/drawingml/2006/main" r:embed="R4998c41aa2f848d2"/>
+          <a:blip xmlns:r="http://schemas.openxmlformats.org/officeDocument/2006/relationships" xmlns:a="http://schemas.openxmlformats.org/drawingml/2006/main" r:embed="R7df5e654fb2e496d"/>
           <a:srcRect xmlns:a="http://schemas.openxmlformats.org/drawingml/2006/main" l="0" t="20000" r="0" b="15000"/>
           <a:stretch xmlns:a="http://schemas.openxmlformats.org/drawingml/2006/main"/>
         </p:blipFill>
@@ -29840,7 +29840,7 @@
           <p:cNvPr id="25" name="內容_5_短波尖峰、聯合改善、12公尺">
             <a:extLst xmlns:a="http://schemas.openxmlformats.org/drawingml/2006/main">
               <a:ext uri="{FF2B5EF4-FFF2-40B4-BE49-F238E27FC236}">
-                <a16:creationId xmlns:a16="http://schemas.microsoft.com/office/drawing/2014/main" id="{331FC24A-BBA7-44F1-8649-7FE3426020FE}"/>
+                <a16:creationId xmlns:a16="http://schemas.microsoft.com/office/drawing/2014/main" id="{A52515EE-60CF-4EA5-9CDE-D0B95EAD39AE}"/>
               </a:ext>
             </a:extLst>
           </p:cNvPr>
@@ -29996,7 +29996,7 @@
     </p:spTree>
     <p:extLst>
       <p:ext uri="{BB962C8B-B14F-4D97-AF65-F5344CB8AC3E}">
-        <p14:creationId xmlns:p14="http://schemas.microsoft.com/office/powerpoint/2010/main" val="914521362"/>
+        <p14:creationId xmlns:p14="http://schemas.microsoft.com/office/powerpoint/2010/main" val="131057099"/>
       </p:ext>
     </p:extLst>
   </p:cSld>
@@ -30020,7 +30020,7 @@
           <p:cNvPr id="2" name="Freeform 2">
             <a:extLst xmlns:a="http://schemas.openxmlformats.org/drawingml/2006/main">
               <a:ext uri="{FF2B5EF4-FFF2-40B4-BE49-F238E27FC236}">
-                <a16:creationId xmlns:a16="http://schemas.microsoft.com/office/drawing/2014/main" id="{147E8E21-B0EB-4F83-BAD5-6DEBB682B84E}"/>
+                <a16:creationId xmlns:a16="http://schemas.microsoft.com/office/drawing/2014/main" id="{9708C226-69B0-4064-B223-7509D061CA49}"/>
               </a:ext>
             </a:extLst>
           </p:cNvPr>
@@ -30058,7 +30058,7 @@
             </a:pathLst>
           </a:custGeom>
           <a:blipFill xmlns:a="http://schemas.openxmlformats.org/drawingml/2006/main">
-            <a:blip xmlns:r="http://schemas.openxmlformats.org/officeDocument/2006/relationships" r:embed="R47c5b041d70a4c3c"/>
+            <a:blip xmlns:r="http://schemas.openxmlformats.org/officeDocument/2006/relationships" r:embed="R34bbabaa496a4c31"/>
             <a:stretch>
               <a:fillRect l="-35258" t="-5555" r="-24931" b="-72434"/>
             </a:stretch>
@@ -30070,7 +30070,7 @@
           <p:cNvPr id="4" name="Freeform 4">
             <a:extLst xmlns:a="http://schemas.openxmlformats.org/drawingml/2006/main">
               <a:ext uri="{FF2B5EF4-FFF2-40B4-BE49-F238E27FC236}">
-                <a16:creationId xmlns:a16="http://schemas.microsoft.com/office/drawing/2014/main" id="{A6B6CB35-CF56-4A7E-A248-7AA8026DB9D8}"/>
+                <a16:creationId xmlns:a16="http://schemas.microsoft.com/office/drawing/2014/main" id="{4B07EBAF-62D6-40A6-993E-ADA4842FF2F6}"/>
               </a:ext>
             </a:extLst>
           </p:cNvPr>
@@ -30144,7 +30144,7 @@
           <p:cNvPr id="5" name="TextBox 5">
             <a:extLst xmlns:a="http://schemas.openxmlformats.org/drawingml/2006/main">
               <a:ext uri="{FF2B5EF4-FFF2-40B4-BE49-F238E27FC236}">
-                <a16:creationId xmlns:a16="http://schemas.microsoft.com/office/drawing/2014/main" id="{85ABF7DB-CEEE-4460-B167-D748C439152C}"/>
+                <a16:creationId xmlns:a16="http://schemas.microsoft.com/office/drawing/2014/main" id="{79E4A9F0-F57E-4E02-B27F-8AACFE79C9F3}"/>
               </a:ext>
             </a:extLst>
           </p:cNvPr>
@@ -30180,7 +30180,7 @@
           <p:cNvPr id="6" name="Freeform 6">
             <a:extLst xmlns:a="http://schemas.openxmlformats.org/drawingml/2006/main">
               <a:ext uri="{FF2B5EF4-FFF2-40B4-BE49-F238E27FC236}">
-                <a16:creationId xmlns:a16="http://schemas.microsoft.com/office/drawing/2014/main" id="{7AF0E679-5A01-40B9-B698-9DB84F510371}"/>
+                <a16:creationId xmlns:a16="http://schemas.microsoft.com/office/drawing/2014/main" id="{5F900804-6B48-4FCA-BE23-8577BB7EB9A9}"/>
               </a:ext>
             </a:extLst>
           </p:cNvPr>
@@ -30218,7 +30218,7 @@
             </a:pathLst>
           </a:custGeom>
           <a:blipFill xmlns:a="http://schemas.openxmlformats.org/drawingml/2006/main">
-            <a:blip xmlns:r="http://schemas.openxmlformats.org/officeDocument/2006/relationships" r:embed="R9ddda592e5214dbc"/>
+            <a:blip xmlns:r="http://schemas.openxmlformats.org/officeDocument/2006/relationships" r:embed="R4d422bed1d7846dd"/>
             <a:stretch>
               <a:fillRect l="0" t="0" r="0" b="0"/>
             </a:stretch>
@@ -30230,7 +30230,7 @@
           <p:cNvPr id="7" name="Freeform 7">
             <a:extLst xmlns:a="http://schemas.openxmlformats.org/drawingml/2006/main">
               <a:ext uri="{FF2B5EF4-FFF2-40B4-BE49-F238E27FC236}">
-                <a16:creationId xmlns:a16="http://schemas.microsoft.com/office/drawing/2014/main" id="{368AE9C0-6023-48DA-8120-4FDCD9604358}"/>
+                <a16:creationId xmlns:a16="http://schemas.microsoft.com/office/drawing/2014/main" id="{3DB85F58-6467-4C5E-B92E-4658DB3983E1}"/>
               </a:ext>
             </a:extLst>
           </p:cNvPr>
@@ -30268,10 +30268,10 @@
             </a:pathLst>
           </a:custGeom>
           <a:blipFill xmlns:a="http://schemas.openxmlformats.org/drawingml/2006/main">
-            <a:blip xmlns:r="http://schemas.openxmlformats.org/officeDocument/2006/relationships" r:embed="R4b3212d8313f4f2d">
+            <a:blip xmlns:r="http://schemas.openxmlformats.org/officeDocument/2006/relationships" r:embed="R6eb7065a21894392">
               <a:extLst>
                 <a:ext uri="{96DAC541-7B7A-43D3-8B79-37D633B846F1}">
-                  <asvg:svgBlip xmlns:asvg="http://schemas.microsoft.com/office/drawing/2016/SVG/main" r:embed="Rcc05ea273b8f4564"/>
+                  <asvg:svgBlip xmlns:asvg="http://schemas.microsoft.com/office/drawing/2016/SVG/main" r:embed="R15e26f9bf8b64dd8"/>
                 </a:ext>
               </a:extLst>
             </a:blip>
@@ -30286,7 +30286,7 @@
           <p:cNvPr id="8" name="Freeform 8">
             <a:extLst xmlns:a="http://schemas.openxmlformats.org/drawingml/2006/main">
               <a:ext uri="{FF2B5EF4-FFF2-40B4-BE49-F238E27FC236}">
-                <a16:creationId xmlns:a16="http://schemas.microsoft.com/office/drawing/2014/main" id="{8A0ED8EE-B9A4-48F6-8CD7-CA81E5739063}"/>
+                <a16:creationId xmlns:a16="http://schemas.microsoft.com/office/drawing/2014/main" id="{30BEACCE-458C-4DB2-BC29-6764F624592C}"/>
               </a:ext>
             </a:extLst>
           </p:cNvPr>
@@ -30324,10 +30324,10 @@
             </a:pathLst>
           </a:custGeom>
           <a:blipFill xmlns:a="http://schemas.openxmlformats.org/drawingml/2006/main">
-            <a:blip xmlns:r="http://schemas.openxmlformats.org/officeDocument/2006/relationships" r:embed="R4b3212d8313f4f2d">
+            <a:blip xmlns:r="http://schemas.openxmlformats.org/officeDocument/2006/relationships" r:embed="R6eb7065a21894392">
               <a:extLst>
                 <a:ext uri="{96DAC541-7B7A-43D3-8B79-37D633B846F1}">
-                  <asvg:svgBlip xmlns:asvg="http://schemas.microsoft.com/office/drawing/2016/SVG/main" r:embed="Rcc05ea273b8f4564"/>
+                  <asvg:svgBlip xmlns:asvg="http://schemas.microsoft.com/office/drawing/2016/SVG/main" r:embed="R15e26f9bf8b64dd8"/>
                 </a:ext>
               </a:extLst>
             </a:blip>
@@ -30342,7 +30342,7 @@
           <p:cNvPr id="9" name="TextBox 9">
             <a:extLst xmlns:a="http://schemas.openxmlformats.org/drawingml/2006/main">
               <a:ext uri="{FF2B5EF4-FFF2-40B4-BE49-F238E27FC236}">
-                <a16:creationId xmlns:a16="http://schemas.microsoft.com/office/drawing/2014/main" id="{92D3CCFE-694F-4B37-96F0-B8FF21F83B1A}"/>
+                <a16:creationId xmlns:a16="http://schemas.microsoft.com/office/drawing/2014/main" id="{301F0B8E-5785-4ED5-98F8-73B38B3B25CB}"/>
               </a:ext>
             </a:extLst>
           </p:cNvPr>
@@ -30394,7 +30394,7 @@
           <p:cNvPr id="10" name="Freeform 10">
             <a:extLst xmlns:a="http://schemas.openxmlformats.org/drawingml/2006/main">
               <a:ext uri="{FF2B5EF4-FFF2-40B4-BE49-F238E27FC236}">
-                <a16:creationId xmlns:a16="http://schemas.microsoft.com/office/drawing/2014/main" id="{048868FD-82B3-4136-B15A-588F053B0E68}"/>
+                <a16:creationId xmlns:a16="http://schemas.microsoft.com/office/drawing/2014/main" id="{EF8F7AE4-7E49-4001-938F-C26660C58593}"/>
               </a:ext>
             </a:extLst>
           </p:cNvPr>
@@ -30442,7 +30442,7 @@
           <p:cNvPr id="12" name="Freeform 12">
             <a:extLst xmlns:a="http://schemas.openxmlformats.org/drawingml/2006/main">
               <a:ext uri="{FF2B5EF4-FFF2-40B4-BE49-F238E27FC236}">
-                <a16:creationId xmlns:a16="http://schemas.microsoft.com/office/drawing/2014/main" id="{08B49B50-D071-4BAF-8BCD-1BB40D5D7B5F}"/>
+                <a16:creationId xmlns:a16="http://schemas.microsoft.com/office/drawing/2014/main" id="{3C212073-4821-49AD-A39E-60066A01CAF7}"/>
               </a:ext>
             </a:extLst>
           </p:cNvPr>
@@ -30487,7 +30487,7 @@
           <p:cNvPr id="13" name="TextBox 13">
             <a:extLst xmlns:a="http://schemas.openxmlformats.org/drawingml/2006/main">
               <a:ext uri="{FF2B5EF4-FFF2-40B4-BE49-F238E27FC236}">
-                <a16:creationId xmlns:a16="http://schemas.microsoft.com/office/drawing/2014/main" id="{9FEF6C44-D97B-4C33-9EEC-6F9B790A27A3}"/>
+                <a16:creationId xmlns:a16="http://schemas.microsoft.com/office/drawing/2014/main" id="{04C1FE21-3774-45C9-A65D-B2140B604C7F}"/>
               </a:ext>
             </a:extLst>
           </p:cNvPr>
@@ -30648,7 +30648,7 @@
           <p:cNvPr id="14" name="TextBox 14">
             <a:extLst xmlns:a="http://schemas.openxmlformats.org/drawingml/2006/main">
               <a:ext uri="{FF2B5EF4-FFF2-40B4-BE49-F238E27FC236}">
-                <a16:creationId xmlns:a16="http://schemas.microsoft.com/office/drawing/2014/main" id="{B1298442-07EA-4DB7-9277-BD42799B34C8}"/>
+                <a16:creationId xmlns:a16="http://schemas.microsoft.com/office/drawing/2014/main" id="{6B70BF81-6493-4D24-97F0-7461C41BDE63}"/>
               </a:ext>
             </a:extLst>
           </p:cNvPr>
@@ -30702,7 +30702,7 @@
           <p:cNvPr id="15" name="TextBox 15">
             <a:extLst xmlns:a="http://schemas.openxmlformats.org/drawingml/2006/main">
               <a:ext uri="{FF2B5EF4-FFF2-40B4-BE49-F238E27FC236}">
-                <a16:creationId xmlns:a16="http://schemas.microsoft.com/office/drawing/2014/main" id="{11153EFA-5038-482F-A75B-82B11DC27A19}"/>
+                <a16:creationId xmlns:a16="http://schemas.microsoft.com/office/drawing/2014/main" id="{D9301335-A2B0-48EA-877C-A91C97D0C2F6}"/>
               </a:ext>
             </a:extLst>
           </p:cNvPr>
@@ -30754,7 +30754,7 @@
           <p:cNvPr id="16" name="TextBox 16">
             <a:extLst xmlns:a="http://schemas.openxmlformats.org/drawingml/2006/main">
               <a:ext uri="{FF2B5EF4-FFF2-40B4-BE49-F238E27FC236}">
-                <a16:creationId xmlns:a16="http://schemas.microsoft.com/office/drawing/2014/main" id="{04D384FE-3D38-4041-A296-E432181A45F7}"/>
+                <a16:creationId xmlns:a16="http://schemas.microsoft.com/office/drawing/2014/main" id="{D529C73B-08AE-47B0-8DB3-A73BEAFBACE6}"/>
               </a:ext>
             </a:extLst>
           </p:cNvPr>
@@ -30806,7 +30806,7 @@
           <p:cNvPr id="17" name="內容_6_多能工與防呆">
             <a:extLst xmlns:a="http://schemas.openxmlformats.org/drawingml/2006/main">
               <a:ext uri="{FF2B5EF4-FFF2-40B4-BE49-F238E27FC236}">
-                <a16:creationId xmlns:a16="http://schemas.microsoft.com/office/drawing/2014/main" id="{ED2E9C38-9B0E-40FD-A48C-B2B113254568}"/>
+                <a16:creationId xmlns:a16="http://schemas.microsoft.com/office/drawing/2014/main" id="{F7A9B5A2-7C2C-47B6-96F4-1D1368A33D70}"/>
               </a:ext>
             </a:extLst>
           </p:cNvPr>
@@ -30964,7 +30964,7 @@
           <p:cNvPr id="18" name="內容_6_五位多能工與A星尋路法">
             <a:extLst xmlns:a="http://schemas.openxmlformats.org/drawingml/2006/main">
               <a:ext uri="{FF2B5EF4-FFF2-40B4-BE49-F238E27FC236}">
-                <a16:creationId xmlns:a16="http://schemas.microsoft.com/office/drawing/2014/main" id="{237685AC-7749-4F76-8F39-5E1BB79253E9}"/>
+                <a16:creationId xmlns:a16="http://schemas.microsoft.com/office/drawing/2014/main" id="{78BF930E-71A4-4393-8A42-C20A6A7E115B}"/>
               </a:ext>
             </a:extLst>
           </p:cNvPr>
@@ -31122,7 +31122,7 @@
           <p:cNvPr id="19" name="內容_6_品質檢查 隊列 &gt;15 件">
             <a:extLst xmlns:a="http://schemas.openxmlformats.org/drawingml/2006/main">
               <a:ext uri="{FF2B5EF4-FFF2-40B4-BE49-F238E27FC236}">
-                <a16:creationId xmlns:a16="http://schemas.microsoft.com/office/drawing/2014/main" id="{6F2F3156-0212-4C58-84FF-A37EDB21989F}"/>
+                <a16:creationId xmlns:a16="http://schemas.microsoft.com/office/drawing/2014/main" id="{E4E89565-4008-42E4-A2F1-A7FF0FB82CD4}"/>
               </a:ext>
             </a:extLst>
           </p:cNvPr>
@@ -31280,7 +31280,7 @@
           <p:cNvPr id="20" name="內容_6_鎖定支援員，等現有整新任務完">
             <a:extLst xmlns:a="http://schemas.openxmlformats.org/drawingml/2006/main">
               <a:ext uri="{FF2B5EF4-FFF2-40B4-BE49-F238E27FC236}">
-                <a16:creationId xmlns:a16="http://schemas.microsoft.com/office/drawing/2014/main" id="{D198DB10-4244-42B7-A4BC-06E1866906D4}"/>
+                <a16:creationId xmlns:a16="http://schemas.microsoft.com/office/drawing/2014/main" id="{34AEE992-BF4D-49A0-BE05-16AD94AB5628}"/>
               </a:ext>
             </a:extLst>
           </p:cNvPr>
@@ -31507,7 +31507,7 @@
           <p:cNvPr id="21" name="內容_6_5 人">
             <a:extLst xmlns:a="http://schemas.openxmlformats.org/drawingml/2006/main">
               <a:ext uri="{FF2B5EF4-FFF2-40B4-BE49-F238E27FC236}">
-                <a16:creationId xmlns:a16="http://schemas.microsoft.com/office/drawing/2014/main" id="{3FC14C9C-388E-4B5E-B178-290AC6CA5A1E}"/>
+                <a16:creationId xmlns:a16="http://schemas.microsoft.com/office/drawing/2014/main" id="{C1F7392A-754C-4CF7-BA0B-D701CA0BA777}"/>
               </a:ext>
             </a:extLst>
           </p:cNvPr>
@@ -31665,7 +31665,7 @@
           <p:cNvPr id="22" name="內容_6_固定人數&#10;1.4公尺／秒 步">
             <a:extLst xmlns:a="http://schemas.openxmlformats.org/drawingml/2006/main">
               <a:ext uri="{FF2B5EF4-FFF2-40B4-BE49-F238E27FC236}">
-                <a16:creationId xmlns:a16="http://schemas.microsoft.com/office/drawing/2014/main" id="{AEDD77DF-7481-4D31-B0C9-DF13FA83F5FC}"/>
+                <a16:creationId xmlns:a16="http://schemas.microsoft.com/office/drawing/2014/main" id="{FC44F03B-9D0F-4EB9-B348-B07F565312DA}"/>
               </a:ext>
             </a:extLst>
           </p:cNvPr>
@@ -31869,7 +31869,7 @@
           <p:cNvPr id="23" name="內容_6_A星（A*）是尋路方法；5人">
             <a:extLst xmlns:a="http://schemas.openxmlformats.org/drawingml/2006/main">
               <a:ext uri="{FF2B5EF4-FFF2-40B4-BE49-F238E27FC236}">
-                <a16:creationId xmlns:a16="http://schemas.microsoft.com/office/drawing/2014/main" id="{1A811295-95CA-4125-B0E5-3251BC964409}"/>
+                <a16:creationId xmlns:a16="http://schemas.microsoft.com/office/drawing/2014/main" id="{A524399E-4204-4553-98C6-346CA004A1B4}"/>
               </a:ext>
             </a:extLst>
           </p:cNvPr>
@@ -32025,7 +32025,7 @@
     </p:spTree>
     <p:extLst>
       <p:ext uri="{BB962C8B-B14F-4D97-AF65-F5344CB8AC3E}">
-        <p14:creationId xmlns:p14="http://schemas.microsoft.com/office/powerpoint/2010/main" val="1337350568"/>
+        <p14:creationId xmlns:p14="http://schemas.microsoft.com/office/powerpoint/2010/main" val="913722000"/>
       </p:ext>
     </p:extLst>
   </p:cSld>
@@ -32049,7 +32049,7 @@
           <p:cNvPr id="2" name="Freeform 2">
             <a:extLst xmlns:a="http://schemas.openxmlformats.org/drawingml/2006/main">
               <a:ext uri="{FF2B5EF4-FFF2-40B4-BE49-F238E27FC236}">
-                <a16:creationId xmlns:a16="http://schemas.microsoft.com/office/drawing/2014/main" id="{5E69468B-0E52-4996-B384-B7921F92B4F9}"/>
+                <a16:creationId xmlns:a16="http://schemas.microsoft.com/office/drawing/2014/main" id="{22305848-88C9-448C-B1B0-9F703A792618}"/>
               </a:ext>
             </a:extLst>
           </p:cNvPr>
@@ -32087,7 +32087,7 @@
             </a:pathLst>
           </a:custGeom>
           <a:blipFill xmlns:a="http://schemas.openxmlformats.org/drawingml/2006/main">
-            <a:blip xmlns:r="http://schemas.openxmlformats.org/officeDocument/2006/relationships" r:embed="R1267652d75c44adb"/>
+            <a:blip xmlns:r="http://schemas.openxmlformats.org/officeDocument/2006/relationships" r:embed="R4b51157794d64a30"/>
             <a:stretch>
               <a:fillRect l="-35258" t="-5555" r="-24931" b="-72434"/>
             </a:stretch>
@@ -32099,7 +32099,7 @@
           <p:cNvPr id="3" name="TextBox 3">
             <a:extLst xmlns:a="http://schemas.openxmlformats.org/drawingml/2006/main">
               <a:ext uri="{FF2B5EF4-FFF2-40B4-BE49-F238E27FC236}">
-                <a16:creationId xmlns:a16="http://schemas.microsoft.com/office/drawing/2014/main" id="{5B179D0F-2CBB-4775-8BF9-74333A9864FD}"/>
+                <a16:creationId xmlns:a16="http://schemas.microsoft.com/office/drawing/2014/main" id="{68F53DCC-D607-4448-A296-17C94770052B}"/>
               </a:ext>
             </a:extLst>
           </p:cNvPr>
@@ -32151,7 +32151,7 @@
           <p:cNvPr id="4" name="TextBox 4">
             <a:extLst xmlns:a="http://schemas.openxmlformats.org/drawingml/2006/main">
               <a:ext uri="{FF2B5EF4-FFF2-40B4-BE49-F238E27FC236}">
-                <a16:creationId xmlns:a16="http://schemas.microsoft.com/office/drawing/2014/main" id="{BC6803EE-E9B2-4BEA-927B-4F102EB4518B}"/>
+                <a16:creationId xmlns:a16="http://schemas.microsoft.com/office/drawing/2014/main" id="{CF0E1EFA-49A9-46CC-B955-B5C1A4122792}"/>
               </a:ext>
             </a:extLst>
           </p:cNvPr>
@@ -32203,7 +32203,7 @@
           <p:cNvPr id="6" name="Freeform 6">
             <a:extLst xmlns:a="http://schemas.openxmlformats.org/drawingml/2006/main">
               <a:ext uri="{FF2B5EF4-FFF2-40B4-BE49-F238E27FC236}">
-                <a16:creationId xmlns:a16="http://schemas.microsoft.com/office/drawing/2014/main" id="{69D02800-B778-40EF-AF90-98408AC209E0}"/>
+                <a16:creationId xmlns:a16="http://schemas.microsoft.com/office/drawing/2014/main" id="{C06E8091-842C-418B-B1CE-B9E18C806AE1}"/>
               </a:ext>
             </a:extLst>
           </p:cNvPr>
@@ -32277,7 +32277,7 @@
           <p:cNvPr id="7" name="TextBox 7">
             <a:extLst xmlns:a="http://schemas.openxmlformats.org/drawingml/2006/main">
               <a:ext uri="{FF2B5EF4-FFF2-40B4-BE49-F238E27FC236}">
-                <a16:creationId xmlns:a16="http://schemas.microsoft.com/office/drawing/2014/main" id="{6C3D12A9-4543-4872-A5D3-B8DD3B29FCF2}"/>
+                <a16:creationId xmlns:a16="http://schemas.microsoft.com/office/drawing/2014/main" id="{6E355584-F6AE-4A59-A0CB-66D40DDBAB08}"/>
               </a:ext>
             </a:extLst>
           </p:cNvPr>
@@ -32313,7 +32313,7 @@
           <p:cNvPr id="8" name="TextBox 8">
             <a:extLst xmlns:a="http://schemas.openxmlformats.org/drawingml/2006/main">
               <a:ext uri="{FF2B5EF4-FFF2-40B4-BE49-F238E27FC236}">
-                <a16:creationId xmlns:a16="http://schemas.microsoft.com/office/drawing/2014/main" id="{687318FF-DAF8-40DA-8CFC-44ECEBD2D321}"/>
+                <a16:creationId xmlns:a16="http://schemas.microsoft.com/office/drawing/2014/main" id="{6C99C17F-499D-4698-972F-F187D3AD1B9A}"/>
               </a:ext>
             </a:extLst>
           </p:cNvPr>
@@ -32474,7 +32474,7 @@
           <p:cNvPr id="9" name="Freeform 9">
             <a:extLst xmlns:a="http://schemas.openxmlformats.org/drawingml/2006/main">
               <a:ext uri="{FF2B5EF4-FFF2-40B4-BE49-F238E27FC236}">
-                <a16:creationId xmlns:a16="http://schemas.microsoft.com/office/drawing/2014/main" id="{2292E5E7-8B75-4BA1-9D65-63D602469A92}"/>
+                <a16:creationId xmlns:a16="http://schemas.microsoft.com/office/drawing/2014/main" id="{9448575F-00B3-455B-A362-C415B91B47E6}"/>
               </a:ext>
             </a:extLst>
           </p:cNvPr>
@@ -32512,7 +32512,7 @@
             </a:pathLst>
           </a:custGeom>
           <a:blipFill xmlns:a="http://schemas.openxmlformats.org/drawingml/2006/main">
-            <a:blip xmlns:r="http://schemas.openxmlformats.org/officeDocument/2006/relationships" r:embed="R52ac1ba4dfc145ec"/>
+            <a:blip xmlns:r="http://schemas.openxmlformats.org/officeDocument/2006/relationships" r:embed="R8301b25f3cc14a0c"/>
             <a:stretch>
               <a:fillRect l="0" t="0" r="0" b="0"/>
             </a:stretch>
@@ -32524,7 +32524,7 @@
           <p:cNvPr id="10" name="Freeform 10">
             <a:extLst xmlns:a="http://schemas.openxmlformats.org/drawingml/2006/main">
               <a:ext uri="{FF2B5EF4-FFF2-40B4-BE49-F238E27FC236}">
-                <a16:creationId xmlns:a16="http://schemas.microsoft.com/office/drawing/2014/main" id="{4EABFB1D-4959-4CA0-A454-C2DEB007AD78}"/>
+                <a16:creationId xmlns:a16="http://schemas.microsoft.com/office/drawing/2014/main" id="{98E97CC8-727F-4BB8-9702-DE1F3592B326}"/>
               </a:ext>
             </a:extLst>
           </p:cNvPr>
@@ -32562,10 +32562,10 @@
             </a:pathLst>
           </a:custGeom>
           <a:blipFill xmlns:a="http://schemas.openxmlformats.org/drawingml/2006/main">
-            <a:blip xmlns:r="http://schemas.openxmlformats.org/officeDocument/2006/relationships" r:embed="R169b15a1f3274d33">
+            <a:blip xmlns:r="http://schemas.openxmlformats.org/officeDocument/2006/relationships" r:embed="R0ec0a4b66ae64f17">
               <a:extLst>
                 <a:ext uri="{96DAC541-7B7A-43D3-8B79-37D633B846F1}">
-                  <asvg:svgBlip xmlns:asvg="http://schemas.microsoft.com/office/drawing/2016/SVG/main" r:embed="R20cb77a1c271421e"/>
+                  <asvg:svgBlip xmlns:asvg="http://schemas.microsoft.com/office/drawing/2016/SVG/main" r:embed="Rf4389e4d7a114a54"/>
                 </a:ext>
               </a:extLst>
             </a:blip>
@@ -32580,7 +32580,7 @@
           <p:cNvPr id="11" name="Freeform 11">
             <a:extLst xmlns:a="http://schemas.openxmlformats.org/drawingml/2006/main">
               <a:ext uri="{FF2B5EF4-FFF2-40B4-BE49-F238E27FC236}">
-                <a16:creationId xmlns:a16="http://schemas.microsoft.com/office/drawing/2014/main" id="{EF9A4F52-C17B-4722-B0AB-A9EBC60AF82B}"/>
+                <a16:creationId xmlns:a16="http://schemas.microsoft.com/office/drawing/2014/main" id="{B728D628-9E22-4BDE-A8A8-6A428C0C4F4C}"/>
               </a:ext>
             </a:extLst>
           </p:cNvPr>
@@ -32618,10 +32618,10 @@
             </a:pathLst>
           </a:custGeom>
           <a:blipFill xmlns:a="http://schemas.openxmlformats.org/drawingml/2006/main">
-            <a:blip xmlns:r="http://schemas.openxmlformats.org/officeDocument/2006/relationships" r:embed="R169b15a1f3274d33">
+            <a:blip xmlns:r="http://schemas.openxmlformats.org/officeDocument/2006/relationships" r:embed="R0ec0a4b66ae64f17">
               <a:extLst>
                 <a:ext uri="{96DAC541-7B7A-43D3-8B79-37D633B846F1}">
-                  <asvg:svgBlip xmlns:asvg="http://schemas.microsoft.com/office/drawing/2016/SVG/main" r:embed="R20cb77a1c271421e"/>
+                  <asvg:svgBlip xmlns:asvg="http://schemas.microsoft.com/office/drawing/2016/SVG/main" r:embed="Rf4389e4d7a114a54"/>
                 </a:ext>
               </a:extLst>
             </a:blip>
@@ -32636,7 +32636,7 @@
           <p:cNvPr id="12" name="TextBox 12">
             <a:extLst xmlns:a="http://schemas.openxmlformats.org/drawingml/2006/main">
               <a:ext uri="{FF2B5EF4-FFF2-40B4-BE49-F238E27FC236}">
-                <a16:creationId xmlns:a16="http://schemas.microsoft.com/office/drawing/2014/main" id="{E5E11FA6-6D93-489D-81F4-5204655B406B}"/>
+                <a16:creationId xmlns:a16="http://schemas.microsoft.com/office/drawing/2014/main" id="{E593B93A-3DAB-4EC1-A15C-5349954652B5}"/>
               </a:ext>
             </a:extLst>
           </p:cNvPr>
@@ -32690,7 +32690,7 @@
           <p:cNvPr id="14" name="Freeform 14">
             <a:extLst xmlns:a="http://schemas.openxmlformats.org/drawingml/2006/main">
               <a:ext uri="{FF2B5EF4-FFF2-40B4-BE49-F238E27FC236}">
-                <a16:creationId xmlns:a16="http://schemas.microsoft.com/office/drawing/2014/main" id="{6EDFEE28-6B09-495A-ACC1-D55B6E76C6F9}"/>
+                <a16:creationId xmlns:a16="http://schemas.microsoft.com/office/drawing/2014/main" id="{6393FC13-F7DE-4876-A748-D70C732205FF}"/>
               </a:ext>
             </a:extLst>
           </p:cNvPr>
@@ -32749,7 +32749,7 @@
           <p:cNvPr id="15" name="TextBox 15">
             <a:extLst xmlns:a="http://schemas.openxmlformats.org/drawingml/2006/main">
               <a:ext uri="{FF2B5EF4-FFF2-40B4-BE49-F238E27FC236}">
-                <a16:creationId xmlns:a16="http://schemas.microsoft.com/office/drawing/2014/main" id="{D8E943DE-ABED-452F-BBBF-69774D00A800}"/>
+                <a16:creationId xmlns:a16="http://schemas.microsoft.com/office/drawing/2014/main" id="{815CA26A-C7F9-4723-8041-778127DB67BE}"/>
               </a:ext>
             </a:extLst>
           </p:cNvPr>
@@ -32789,7 +32789,7 @@
           <p:cNvPr id="16" name="TextBox 16">
             <a:extLst xmlns:a="http://schemas.openxmlformats.org/drawingml/2006/main">
               <a:ext uri="{FF2B5EF4-FFF2-40B4-BE49-F238E27FC236}">
-                <a16:creationId xmlns:a16="http://schemas.microsoft.com/office/drawing/2014/main" id="{606EA2B7-AE0C-4333-AA40-B3F6B40A2C0C}"/>
+                <a16:creationId xmlns:a16="http://schemas.microsoft.com/office/drawing/2014/main" id="{647779C5-53C4-4D46-B5DD-F520909CC8CA}"/>
               </a:ext>
             </a:extLst>
           </p:cNvPr>
@@ -32838,7 +32838,7 @@
           <p:cNvPr id="17" name="TextBox 17">
             <a:extLst xmlns:a="http://schemas.openxmlformats.org/drawingml/2006/main">
               <a:ext uri="{FF2B5EF4-FFF2-40B4-BE49-F238E27FC236}">
-                <a16:creationId xmlns:a16="http://schemas.microsoft.com/office/drawing/2014/main" id="{3CD9C22D-BCE0-4B45-8EDF-53B562E08EAA}"/>
+                <a16:creationId xmlns:a16="http://schemas.microsoft.com/office/drawing/2014/main" id="{E574FF55-042D-4861-836E-0C66BD167246}"/>
               </a:ext>
             </a:extLst>
           </p:cNvPr>
@@ -32890,7 +32890,7 @@
           <p:cNvPr id="19" name="Freeform 19">
             <a:extLst xmlns:a="http://schemas.openxmlformats.org/drawingml/2006/main">
               <a:ext uri="{FF2B5EF4-FFF2-40B4-BE49-F238E27FC236}">
-                <a16:creationId xmlns:a16="http://schemas.microsoft.com/office/drawing/2014/main" id="{BA66176D-0EAA-4C01-9C9C-3E8F884D6DF9}"/>
+                <a16:creationId xmlns:a16="http://schemas.microsoft.com/office/drawing/2014/main" id="{04578CF9-54D1-445B-9DFA-B00E478F1383}"/>
               </a:ext>
             </a:extLst>
           </p:cNvPr>
@@ -32949,7 +32949,7 @@
           <p:cNvPr id="20" name="TextBox 20">
             <a:extLst xmlns:a="http://schemas.openxmlformats.org/drawingml/2006/main">
               <a:ext uri="{FF2B5EF4-FFF2-40B4-BE49-F238E27FC236}">
-                <a16:creationId xmlns:a16="http://schemas.microsoft.com/office/drawing/2014/main" id="{0D1C9278-980A-4D36-9D0C-EC1228370E8B}"/>
+                <a16:creationId xmlns:a16="http://schemas.microsoft.com/office/drawing/2014/main" id="{CAAECA05-D13E-46F8-A839-B38F2EE942EA}"/>
               </a:ext>
             </a:extLst>
           </p:cNvPr>
@@ -32989,7 +32989,7 @@
           <p:cNvPr id="21" name="TextBox 21">
             <a:extLst xmlns:a="http://schemas.openxmlformats.org/drawingml/2006/main">
               <a:ext uri="{FF2B5EF4-FFF2-40B4-BE49-F238E27FC236}">
-                <a16:creationId xmlns:a16="http://schemas.microsoft.com/office/drawing/2014/main" id="{4783CA58-48FB-426B-97D5-C9ABFBBAA67C}"/>
+                <a16:creationId xmlns:a16="http://schemas.microsoft.com/office/drawing/2014/main" id="{6839E21F-17F9-4513-A138-5B0E277A4D2C}"/>
               </a:ext>
             </a:extLst>
           </p:cNvPr>
@@ -33038,7 +33038,7 @@
           <p:cNvPr id="22" name="TextBox 22">
             <a:extLst xmlns:a="http://schemas.openxmlformats.org/drawingml/2006/main">
               <a:ext uri="{FF2B5EF4-FFF2-40B4-BE49-F238E27FC236}">
-                <a16:creationId xmlns:a16="http://schemas.microsoft.com/office/drawing/2014/main" id="{D1F4F77E-B108-46F6-B757-B8C6B4303D3A}"/>
+                <a16:creationId xmlns:a16="http://schemas.microsoft.com/office/drawing/2014/main" id="{582C3109-3497-45CB-AFC1-770D4BAE35D6}"/>
               </a:ext>
             </a:extLst>
           </p:cNvPr>
@@ -33090,7 +33090,7 @@
           <p:cNvPr id="23" name="AutoShape 23">
             <a:extLst xmlns:a="http://schemas.openxmlformats.org/drawingml/2006/main">
               <a:ext uri="{FF2B5EF4-FFF2-40B4-BE49-F238E27FC236}">
-                <a16:creationId xmlns:a16="http://schemas.microsoft.com/office/drawing/2014/main" id="{70B39103-5C30-4117-A197-1D3CA9B7AFC7}"/>
+                <a16:creationId xmlns:a16="http://schemas.microsoft.com/office/drawing/2014/main" id="{E4C3DE07-CBEA-41E3-9C63-FF6D2BF49E28}"/>
               </a:ext>
             </a:extLst>
           </p:cNvPr>
@@ -33120,7 +33120,7 @@
           <p:cNvPr id="24" name="內容_7_環境指標：門檻與增量">
             <a:extLst xmlns:a="http://schemas.openxmlformats.org/drawingml/2006/main">
               <a:ext uri="{FF2B5EF4-FFF2-40B4-BE49-F238E27FC236}">
-                <a16:creationId xmlns:a16="http://schemas.microsoft.com/office/drawing/2014/main" id="{30FD7FC6-1185-4E89-9544-FA86C3EA575F}"/>
+                <a16:creationId xmlns:a16="http://schemas.microsoft.com/office/drawing/2014/main" id="{B03125EF-2C5E-45CE-BFFC-B2CD4291FB74}"/>
               </a:ext>
             </a:extLst>
           </p:cNvPr>
@@ -33278,7 +33278,7 @@
           <p:cNvPr id="25" name="內容_7_74%達標，不等於聯合方案再">
             <a:extLst xmlns:a="http://schemas.openxmlformats.org/drawingml/2006/main">
               <a:ext uri="{FF2B5EF4-FFF2-40B4-BE49-F238E27FC236}">
-                <a16:creationId xmlns:a16="http://schemas.microsoft.com/office/drawing/2014/main" id="{E17F1848-7CB6-44C9-AF25-485A89D5CC16}"/>
+                <a16:creationId xmlns:a16="http://schemas.microsoft.com/office/drawing/2014/main" id="{5F522578-C20E-4C30-9B9E-BDDF0639F883}"/>
               </a:ext>
             </a:extLst>
           </p:cNvPr>
@@ -33436,7 +33436,7 @@
           <p:cNvPr id="26" name="內容_7_改善前 73.853%">
             <a:extLst xmlns:a="http://schemas.openxmlformats.org/drawingml/2006/main">
               <a:ext uri="{FF2B5EF4-FFF2-40B4-BE49-F238E27FC236}">
-                <a16:creationId xmlns:a16="http://schemas.microsoft.com/office/drawing/2014/main" id="{BC4D5794-3492-48B9-AAA4-D32474B341A3}"/>
+                <a16:creationId xmlns:a16="http://schemas.microsoft.com/office/drawing/2014/main" id="{FDA76BB8-96FE-4FEE-94D1-D36AA4DCA7C7}"/>
               </a:ext>
             </a:extLst>
           </p:cNvPr>
@@ -33594,7 +33594,7 @@
           <p:cNvPr id="27" name="內容_7_每件0.184875 度電&#10;">
             <a:extLst xmlns:a="http://schemas.openxmlformats.org/drawingml/2006/main">
               <a:ext uri="{FF2B5EF4-FFF2-40B4-BE49-F238E27FC236}">
-                <a16:creationId xmlns:a16="http://schemas.microsoft.com/office/drawing/2014/main" id="{FE9F89D8-2D7F-4871-A95B-0945560D6E61}"/>
+                <a16:creationId xmlns:a16="http://schemas.microsoft.com/office/drawing/2014/main" id="{13447319-099C-45CE-B708-57B64F74FF0C}"/>
               </a:ext>
             </a:extLst>
           </p:cNvPr>
@@ -33798,7 +33798,7 @@
           <p:cNvPr id="28" name="內容_7_12公尺聯合：73.995%">
             <a:extLst xmlns:a="http://schemas.openxmlformats.org/drawingml/2006/main">
               <a:ext uri="{FF2B5EF4-FFF2-40B4-BE49-F238E27FC236}">
-                <a16:creationId xmlns:a16="http://schemas.microsoft.com/office/drawing/2014/main" id="{48F64F39-C418-48B8-8242-908EB30B9F15}"/>
+                <a16:creationId xmlns:a16="http://schemas.microsoft.com/office/drawing/2014/main" id="{7D27F06A-559D-429F-94C6-80FFD252F12E}"/>
               </a:ext>
             </a:extLst>
           </p:cNvPr>
@@ -33956,7 +33956,7 @@
           <p:cNvPr id="29" name="內容_7_相較改善前僅 +0.141百">
             <a:extLst xmlns:a="http://schemas.openxmlformats.org/drawingml/2006/main">
               <a:ext uri="{FF2B5EF4-FFF2-40B4-BE49-F238E27FC236}">
-                <a16:creationId xmlns:a16="http://schemas.microsoft.com/office/drawing/2014/main" id="{725FD368-D56A-462A-B293-6FCCDBA8040A}"/>
+                <a16:creationId xmlns:a16="http://schemas.microsoft.com/office/drawing/2014/main" id="{277D9D79-11A3-4260-BEF5-A0D913163DA6}"/>
               </a:ext>
             </a:extLst>
           </p:cNvPr>
@@ -34160,7 +34160,7 @@
           <p:cNvPr id="30" name="內容_7_42%是目標門檻；原始來源未">
             <a:extLst xmlns:a="http://schemas.openxmlformats.org/drawingml/2006/main">
               <a:ext uri="{FF2B5EF4-FFF2-40B4-BE49-F238E27FC236}">
-                <a16:creationId xmlns:a16="http://schemas.microsoft.com/office/drawing/2014/main" id="{5A167EEF-657B-4A89-964A-97953236D3EF}"/>
+                <a16:creationId xmlns:a16="http://schemas.microsoft.com/office/drawing/2014/main" id="{9B82C2CB-0468-402D-913F-3D3C97502A33}"/>
               </a:ext>
             </a:extLst>
           </p:cNvPr>
@@ -34316,7 +34316,7 @@
     </p:spTree>
     <p:extLst>
       <p:ext uri="{BB962C8B-B14F-4D97-AF65-F5344CB8AC3E}">
-        <p14:creationId xmlns:p14="http://schemas.microsoft.com/office/powerpoint/2010/main" val="1484373825"/>
+        <p14:creationId xmlns:p14="http://schemas.microsoft.com/office/powerpoint/2010/main" val="1485290961"/>
       </p:ext>
     </p:extLst>
   </p:cSld>
@@ -34340,7 +34340,7 @@
           <p:cNvPr id="2" name="Freeform 2">
             <a:extLst xmlns:a="http://schemas.openxmlformats.org/drawingml/2006/main">
               <a:ext uri="{FF2B5EF4-FFF2-40B4-BE49-F238E27FC236}">
-                <a16:creationId xmlns:a16="http://schemas.microsoft.com/office/drawing/2014/main" id="{E48E83F6-28D3-49C8-A457-E49598C627A3}"/>
+                <a16:creationId xmlns:a16="http://schemas.microsoft.com/office/drawing/2014/main" id="{47DB7B52-3BF8-4AD5-8B6A-6688A65D8800}"/>
               </a:ext>
             </a:extLst>
           </p:cNvPr>
@@ -34378,7 +34378,7 @@
             </a:pathLst>
           </a:custGeom>
           <a:blipFill xmlns:a="http://schemas.openxmlformats.org/drawingml/2006/main">
-            <a:blip xmlns:r="http://schemas.openxmlformats.org/officeDocument/2006/relationships" r:embed="Rc433bf421ed149cc"/>
+            <a:blip xmlns:r="http://schemas.openxmlformats.org/officeDocument/2006/relationships" r:embed="R5506bb103bb04799"/>
             <a:stretch>
               <a:fillRect l="-35258" t="-5555" r="-24931" b="-72434"/>
             </a:stretch>
@@ -34390,7 +34390,7 @@
           <p:cNvPr id="4" name="Freeform 4">
             <a:extLst xmlns:a="http://schemas.openxmlformats.org/drawingml/2006/main">
               <a:ext uri="{FF2B5EF4-FFF2-40B4-BE49-F238E27FC236}">
-                <a16:creationId xmlns:a16="http://schemas.microsoft.com/office/drawing/2014/main" id="{BFC28C33-AF89-4C55-B1B5-8BDC9AA83E4B}"/>
+                <a16:creationId xmlns:a16="http://schemas.microsoft.com/office/drawing/2014/main" id="{EA94946B-61F2-4728-B45E-96A7DE68B93A}"/>
               </a:ext>
             </a:extLst>
           </p:cNvPr>
@@ -34464,7 +34464,7 @@
           <p:cNvPr id="5" name="TextBox 5">
             <a:extLst xmlns:a="http://schemas.openxmlformats.org/drawingml/2006/main">
               <a:ext uri="{FF2B5EF4-FFF2-40B4-BE49-F238E27FC236}">
-                <a16:creationId xmlns:a16="http://schemas.microsoft.com/office/drawing/2014/main" id="{8E82D7BA-238F-49F5-B284-3CEDD54B4F1B}"/>
+                <a16:creationId xmlns:a16="http://schemas.microsoft.com/office/drawing/2014/main" id="{832350E7-7A06-4CB3-9D4E-1BE829B7218F}"/>
               </a:ext>
             </a:extLst>
           </p:cNvPr>
@@ -34500,7 +34500,7 @@
           <p:cNvPr id="6" name="Freeform 6">
             <a:extLst xmlns:a="http://schemas.openxmlformats.org/drawingml/2006/main">
               <a:ext uri="{FF2B5EF4-FFF2-40B4-BE49-F238E27FC236}">
-                <a16:creationId xmlns:a16="http://schemas.microsoft.com/office/drawing/2014/main" id="{A7F7DA1B-5A33-4EB0-B713-AC9340D7CA2D}"/>
+                <a16:creationId xmlns:a16="http://schemas.microsoft.com/office/drawing/2014/main" id="{6F5D708B-2A58-43EA-B64F-A65582B28E39}"/>
               </a:ext>
             </a:extLst>
           </p:cNvPr>
@@ -34538,7 +34538,7 @@
             </a:pathLst>
           </a:custGeom>
           <a:blipFill xmlns:a="http://schemas.openxmlformats.org/drawingml/2006/main">
-            <a:blip xmlns:r="http://schemas.openxmlformats.org/officeDocument/2006/relationships" r:embed="R78b8576c3748433d"/>
+            <a:blip xmlns:r="http://schemas.openxmlformats.org/officeDocument/2006/relationships" r:embed="R6760dcf447d449cd"/>
             <a:stretch>
               <a:fillRect l="0" t="0" r="0" b="0"/>
             </a:stretch>
@@ -34550,7 +34550,7 @@
           <p:cNvPr id="7" name="Freeform 7">
             <a:extLst xmlns:a="http://schemas.openxmlformats.org/drawingml/2006/main">
               <a:ext uri="{FF2B5EF4-FFF2-40B4-BE49-F238E27FC236}">
-                <a16:creationId xmlns:a16="http://schemas.microsoft.com/office/drawing/2014/main" id="{F055E3B0-9BAD-4305-AB90-4FE82B06D8B3}"/>
+                <a16:creationId xmlns:a16="http://schemas.microsoft.com/office/drawing/2014/main" id="{EA6BDD97-CBA3-4EA2-98B3-F0839CD75EB1}"/>
               </a:ext>
             </a:extLst>
           </p:cNvPr>
@@ -34588,10 +34588,10 @@
             </a:pathLst>
           </a:custGeom>
           <a:blipFill xmlns:a="http://schemas.openxmlformats.org/drawingml/2006/main">
-            <a:blip xmlns:r="http://schemas.openxmlformats.org/officeDocument/2006/relationships" r:embed="R7853de9decc540e2">
+            <a:blip xmlns:r="http://schemas.openxmlformats.org/officeDocument/2006/relationships" r:embed="Rd80f9fc243c14116">
               <a:extLst>
                 <a:ext uri="{96DAC541-7B7A-43D3-8B79-37D633B846F1}">
-                  <asvg:svgBlip xmlns:asvg="http://schemas.microsoft.com/office/drawing/2016/SVG/main" r:embed="R5b481e93b54e46b5"/>
+                  <asvg:svgBlip xmlns:asvg="http://schemas.microsoft.com/office/drawing/2016/SVG/main" r:embed="Rfdc05d7a88944ace"/>
                 </a:ext>
               </a:extLst>
             </a:blip>
@@ -34606,7 +34606,7 @@
           <p:cNvPr id="8" name="Freeform 8">
             <a:extLst xmlns:a="http://schemas.openxmlformats.org/drawingml/2006/main">
               <a:ext uri="{FF2B5EF4-FFF2-40B4-BE49-F238E27FC236}">
-                <a16:creationId xmlns:a16="http://schemas.microsoft.com/office/drawing/2014/main" id="{7E6A03BF-9247-454F-AD6A-8AD4CDB7F90C}"/>
+                <a16:creationId xmlns:a16="http://schemas.microsoft.com/office/drawing/2014/main" id="{2EEA60DD-F96F-4516-8D5A-7DC1DA392E73}"/>
               </a:ext>
             </a:extLst>
           </p:cNvPr>
@@ -34644,10 +34644,10 @@
             </a:pathLst>
           </a:custGeom>
           <a:blipFill xmlns:a="http://schemas.openxmlformats.org/drawingml/2006/main">
-            <a:blip xmlns:r="http://schemas.openxmlformats.org/officeDocument/2006/relationships" r:embed="R7853de9decc540e2">
+            <a:blip xmlns:r="http://schemas.openxmlformats.org/officeDocument/2006/relationships" r:embed="Rd80f9fc243c14116">
               <a:extLst>
                 <a:ext uri="{96DAC541-7B7A-43D3-8B79-37D633B846F1}">
-                  <asvg:svgBlip xmlns:asvg="http://schemas.microsoft.com/office/drawing/2016/SVG/main" r:embed="R5b481e93b54e46b5"/>
+                  <asvg:svgBlip xmlns:asvg="http://schemas.microsoft.com/office/drawing/2016/SVG/main" r:embed="Rfdc05d7a88944ace"/>
                 </a:ext>
               </a:extLst>
             </a:blip>
@@ -34662,7 +34662,7 @@
           <p:cNvPr id="9" name="Freeform 9">
             <a:extLst xmlns:a="http://schemas.openxmlformats.org/drawingml/2006/main">
               <a:ext uri="{FF2B5EF4-FFF2-40B4-BE49-F238E27FC236}">
-                <a16:creationId xmlns:a16="http://schemas.microsoft.com/office/drawing/2014/main" id="{612DD9BD-253C-453E-B3A4-859E5151F3AC}"/>
+                <a16:creationId xmlns:a16="http://schemas.microsoft.com/office/drawing/2014/main" id="{1BDA29C4-16FC-40C9-B611-B325946B80B9}"/>
               </a:ext>
             </a:extLst>
           </p:cNvPr>
@@ -34710,7 +34710,7 @@
           <p:cNvPr id="10" name="TextBox 10">
             <a:extLst xmlns:a="http://schemas.openxmlformats.org/drawingml/2006/main">
               <a:ext uri="{FF2B5EF4-FFF2-40B4-BE49-F238E27FC236}">
-                <a16:creationId xmlns:a16="http://schemas.microsoft.com/office/drawing/2014/main" id="{DFD60F7A-6337-4B4D-B147-CE1A31E9D44D}"/>
+                <a16:creationId xmlns:a16="http://schemas.microsoft.com/office/drawing/2014/main" id="{54926248-D066-476B-AA53-A9F19071F8DF}"/>
               </a:ext>
             </a:extLst>
           </p:cNvPr>
@@ -34871,7 +34871,7 @@
           <p:cNvPr id="11" name="TextBox 11">
             <a:extLst xmlns:a="http://schemas.openxmlformats.org/drawingml/2006/main">
               <a:ext uri="{FF2B5EF4-FFF2-40B4-BE49-F238E27FC236}">
-                <a16:creationId xmlns:a16="http://schemas.microsoft.com/office/drawing/2014/main" id="{B0079C3B-546E-422E-B91C-1A239326AE8A}"/>
+                <a16:creationId xmlns:a16="http://schemas.microsoft.com/office/drawing/2014/main" id="{1EB88EB9-6C59-4633-A686-F1A7065356AF}"/>
               </a:ext>
             </a:extLst>
           </p:cNvPr>
@@ -34925,7 +34925,7 @@
           <p:cNvPr id="12" name="TextBox 12">
             <a:extLst xmlns:a="http://schemas.openxmlformats.org/drawingml/2006/main">
               <a:ext uri="{FF2B5EF4-FFF2-40B4-BE49-F238E27FC236}">
-                <a16:creationId xmlns:a16="http://schemas.microsoft.com/office/drawing/2014/main" id="{DC49AD96-567F-47AB-8815-B0A7B6350217}"/>
+                <a16:creationId xmlns:a16="http://schemas.microsoft.com/office/drawing/2014/main" id="{594687A3-B8D3-40F3-9348-8309BAFEDE44}"/>
               </a:ext>
             </a:extLst>
           </p:cNvPr>
@@ -34977,7 +34977,7 @@
           <p:cNvPr id="13" name="TextBox 13">
             <a:extLst xmlns:a="http://schemas.openxmlformats.org/drawingml/2006/main">
               <a:ext uri="{FF2B5EF4-FFF2-40B4-BE49-F238E27FC236}">
-                <a16:creationId xmlns:a16="http://schemas.microsoft.com/office/drawing/2014/main" id="{1BC8F89E-17CD-4B16-842C-E03FF9D47133}"/>
+                <a16:creationId xmlns:a16="http://schemas.microsoft.com/office/drawing/2014/main" id="{5A16601C-68EF-4D1E-B712-16AB32F00ACD}"/>
               </a:ext>
             </a:extLst>
           </p:cNvPr>
@@ -35029,7 +35029,7 @@
           <p:cNvPr id="14" name="TextBox 14">
             <a:extLst xmlns:a="http://schemas.openxmlformats.org/drawingml/2006/main">
               <a:ext uri="{FF2B5EF4-FFF2-40B4-BE49-F238E27FC236}">
-                <a16:creationId xmlns:a16="http://schemas.microsoft.com/office/drawing/2014/main" id="{DBA78A24-0C43-411A-8DB4-5465C1C4850B}"/>
+                <a16:creationId xmlns:a16="http://schemas.microsoft.com/office/drawing/2014/main" id="{751CE905-A203-4D36-BBAF-754752CA9CF3}"/>
               </a:ext>
             </a:extLst>
           </p:cNvPr>
@@ -35081,7 +35081,7 @@
           <p:cNvPr id="15" name="Freeform 15">
             <a:extLst xmlns:a="http://schemas.openxmlformats.org/drawingml/2006/main">
               <a:ext uri="{FF2B5EF4-FFF2-40B4-BE49-F238E27FC236}">
-                <a16:creationId xmlns:a16="http://schemas.microsoft.com/office/drawing/2014/main" id="{08490333-4F31-476B-B4FC-94F7646F9115}"/>
+                <a16:creationId xmlns:a16="http://schemas.microsoft.com/office/drawing/2014/main" id="{F42C2A44-2BBA-4C8D-A847-875A73929B79}"/>
               </a:ext>
             </a:extLst>
           </p:cNvPr>
@@ -35129,7 +35129,7 @@
           <p:cNvPr id="16" name="內容_8_檢查V1–V6：守恆與統計">
             <a:extLst xmlns:a="http://schemas.openxmlformats.org/drawingml/2006/main">
               <a:ext uri="{FF2B5EF4-FFF2-40B4-BE49-F238E27FC236}">
-                <a16:creationId xmlns:a16="http://schemas.microsoft.com/office/drawing/2014/main" id="{2B845F95-1FAD-475A-8A12-EA7E850F8790}"/>
+                <a16:creationId xmlns:a16="http://schemas.microsoft.com/office/drawing/2014/main" id="{652EA46A-1045-4617-96F1-CE9A9883BD55}"/>
               </a:ext>
             </a:extLst>
           </p:cNvPr>
@@ -35287,7 +35287,7 @@
           <p:cNvPr id="17" name="內容_8_驗證必須能攔下錯誤">
             <a:extLst xmlns:a="http://schemas.openxmlformats.org/drawingml/2006/main">
               <a:ext uri="{FF2B5EF4-FFF2-40B4-BE49-F238E27FC236}">
-                <a16:creationId xmlns:a16="http://schemas.microsoft.com/office/drawing/2014/main" id="{1D052379-B821-4860-9C86-45D66DB7FD76}"/>
+                <a16:creationId xmlns:a16="http://schemas.microsoft.com/office/drawing/2014/main" id="{3E135BF8-CE50-4F4F-A592-4BEE059077D8}"/>
               </a:ext>
             </a:extLst>
           </p:cNvPr>
@@ -35445,7 +35445,7 @@
           <p:cNvPr id="18" name="">
             <a:extLst xmlns:a="http://schemas.openxmlformats.org/drawingml/2006/main">
               <a:ext uri="{FF2B5EF4-FFF2-40B4-BE49-F238E27FC236}">
-                <a16:creationId xmlns:a16="http://schemas.microsoft.com/office/drawing/2014/main" id="{0340BCE9-7CD0-4177-A8D3-11050AC8523E}"/>
+                <a16:creationId xmlns:a16="http://schemas.microsoft.com/office/drawing/2014/main" id="{E179A2DF-EC05-4C6B-9E1B-5647358B66A1}"/>
               </a:ext>
             </a:extLst>
           </p:cNvPr>
@@ -35614,7 +35614,7 @@
                           <a:ea typeface="Microsoft JhengHei"/>
                           <a:cs typeface="Microsoft JhengHei"/>
                         </a:rPr>
-                        <a:t>V1 守恆</a:t>
+                        <a:t>守恆檢查（V1）</a:t>
                       </a:r>
                     </a:p>
                   </a:txBody>
@@ -35730,7 +35730,7 @@
                           <a:ea typeface="Microsoft JhengHei"/>
                           <a:cs typeface="Microsoft JhengHei"/>
                         </a:rPr>
-                        <a:t>V2／V3 穩定</a:t>
+                        <a:t>穩定檢查（V2／V3）</a:t>
                       </a:r>
                     </a:p>
                   </a:txBody>
@@ -35772,7 +35772,7 @@
                           <a:ea typeface="Microsoft JhengHei"/>
                           <a:cs typeface="Microsoft JhengHei"/>
                         </a:rPr>
-                        <a:t>平日：流量CV≤5%；在製漂移-0.21%</a:t>
+                        <a:t>平日變異係數≤5%；在製漂移-0.21%</a:t>
                       </a:r>
                     </a:p>
                   </a:txBody>
@@ -35846,7 +35846,7 @@
                           <a:ea typeface="Microsoft JhengHei"/>
                           <a:cs typeface="Microsoft JhengHei"/>
                         </a:rPr>
-                        <a:t>V4 同種子</a:t>
+                        <a:t>同種子檢查（V4）</a:t>
                       </a:r>
                     </a:p>
                   </a:txBody>
@@ -35962,7 +35962,7 @@
                           <a:ea typeface="Microsoft JhengHei"/>
                           <a:cs typeface="Microsoft JhengHei"/>
                         </a:rPr>
-                        <a:t>V5 估計精度</a:t>
+                        <a:t>估計精度檢查（V5）</a:t>
                       </a:r>
                     </a:p>
                   </a:txBody>
@@ -36078,7 +36078,7 @@
                           <a:ea typeface="Microsoft JhengHei"/>
                           <a:cs typeface="Microsoft JhengHei"/>
                         </a:rPr>
-                        <a:t>V6 分級比例</a:t>
+                        <a:t>分級比例檢查（V6）</a:t>
                       </a:r>
                     </a:p>
                   </a:txBody>
@@ -36188,7 +36188,7 @@
           <p:cNvPr id="19" name="內容_8_V是檢查編號，不是模型版本。">
             <a:extLst xmlns:a="http://schemas.openxmlformats.org/drawingml/2006/main">
               <a:ext uri="{FF2B5EF4-FFF2-40B4-BE49-F238E27FC236}">
-                <a16:creationId xmlns:a16="http://schemas.microsoft.com/office/drawing/2014/main" id="{3AD8234C-15BA-465D-AD97-0CF264E1976B}"/>
+                <a16:creationId xmlns:a16="http://schemas.microsoft.com/office/drawing/2014/main" id="{A2571063-2FBB-4EBD-935C-29A1DB835FC5}"/>
               </a:ext>
             </a:extLst>
           </p:cNvPr>
@@ -36336,7 +36336,7 @@
                 <a:ea typeface="Microsoft JhengHei"/>
                 <a:cs typeface="Microsoft JhengHei"/>
               </a:rPr>
-              <a:t>V是檢查編號，不是模型版本。CV＝相對波動；p值用來檢查分級比例是否相容。</a:t>
+              <a:t>V是檢查編號，不是模型版本。變異係數（CV）表示相對波動；p值用來檢查分級比例是否相容。</a:t>
             </a:r>
           </a:p>
         </p:txBody>
@@ -36346,7 +36346,7 @@
           <p:cNvPr id="20" name="內容_8_600個基準樣本＝主實驗30">
             <a:extLst xmlns:a="http://schemas.openxmlformats.org/drawingml/2006/main">
               <a:ext uri="{FF2B5EF4-FFF2-40B4-BE49-F238E27FC236}">
-                <a16:creationId xmlns:a16="http://schemas.microsoft.com/office/drawing/2014/main" id="{893D8F59-9048-4B04-A1F6-AF0E53BABC1B}"/>
+                <a16:creationId xmlns:a16="http://schemas.microsoft.com/office/drawing/2014/main" id="{EF37D15C-D6FD-44F8-8076-B7A29A0262C1}"/>
               </a:ext>
             </a:extLst>
           </p:cNvPr>
@@ -36502,7 +36502,7 @@
     </p:spTree>
     <p:extLst>
       <p:ext uri="{BB962C8B-B14F-4D97-AF65-F5344CB8AC3E}">
-        <p14:creationId xmlns:p14="http://schemas.microsoft.com/office/powerpoint/2010/main" val="1165577380"/>
+        <p14:creationId xmlns:p14="http://schemas.microsoft.com/office/powerpoint/2010/main" val="1154784595"/>
       </p:ext>
     </p:extLst>
   </p:cSld>
@@ -36526,7 +36526,7 @@
           <p:cNvPr id="2" name="Freeform 2">
             <a:extLst xmlns:a="http://schemas.openxmlformats.org/drawingml/2006/main">
               <a:ext uri="{FF2B5EF4-FFF2-40B4-BE49-F238E27FC236}">
-                <a16:creationId xmlns:a16="http://schemas.microsoft.com/office/drawing/2014/main" id="{F99FE5BC-BE58-4952-B28F-62CAF9B746A8}"/>
+                <a16:creationId xmlns:a16="http://schemas.microsoft.com/office/drawing/2014/main" id="{E2731B3A-0047-4CE8-9698-CC4E4EEE6066}"/>
               </a:ext>
             </a:extLst>
           </p:cNvPr>
@@ -36564,7 +36564,7 @@
             </a:pathLst>
           </a:custGeom>
           <a:blipFill xmlns:a="http://schemas.openxmlformats.org/drawingml/2006/main">
-            <a:blip xmlns:r="http://schemas.openxmlformats.org/officeDocument/2006/relationships" r:embed="R5334ff5f9aae4649"/>
+            <a:blip xmlns:r="http://schemas.openxmlformats.org/officeDocument/2006/relationships" r:embed="Red7a344e41314736"/>
             <a:stretch>
               <a:fillRect l="-35258" t="-5555" r="-24931" b="-72434"/>
             </a:stretch>
@@ -36576,7 +36576,7 @@
           <p:cNvPr id="4" name="Freeform 4">
             <a:extLst xmlns:a="http://schemas.openxmlformats.org/drawingml/2006/main">
               <a:ext uri="{FF2B5EF4-FFF2-40B4-BE49-F238E27FC236}">
-                <a16:creationId xmlns:a16="http://schemas.microsoft.com/office/drawing/2014/main" id="{F3E65B8D-3A66-40F9-B06C-42C786A928E5}"/>
+                <a16:creationId xmlns:a16="http://schemas.microsoft.com/office/drawing/2014/main" id="{BF204474-599A-48C3-BA3A-46C3EEA3E4BE}"/>
               </a:ext>
             </a:extLst>
           </p:cNvPr>
@@ -36650,7 +36650,7 @@
           <p:cNvPr id="5" name="TextBox 5">
             <a:extLst xmlns:a="http://schemas.openxmlformats.org/drawingml/2006/main">
               <a:ext uri="{FF2B5EF4-FFF2-40B4-BE49-F238E27FC236}">
-                <a16:creationId xmlns:a16="http://schemas.microsoft.com/office/drawing/2014/main" id="{22FCC330-EC48-45DF-9A7A-4B7EEEB99CCE}"/>
+                <a16:creationId xmlns:a16="http://schemas.microsoft.com/office/drawing/2014/main" id="{E50D0010-0774-4577-8C70-B332E131D847}"/>
               </a:ext>
             </a:extLst>
           </p:cNvPr>
@@ -36686,7 +36686,7 @@
           <p:cNvPr id="6" name="Freeform 6">
             <a:extLst xmlns:a="http://schemas.openxmlformats.org/drawingml/2006/main">
               <a:ext uri="{FF2B5EF4-FFF2-40B4-BE49-F238E27FC236}">
-                <a16:creationId xmlns:a16="http://schemas.microsoft.com/office/drawing/2014/main" id="{85D4C207-C3E2-4119-87FD-64B285E314D9}"/>
+                <a16:creationId xmlns:a16="http://schemas.microsoft.com/office/drawing/2014/main" id="{D76CA9EC-1DBF-4907-B068-95AB71649EAC}"/>
               </a:ext>
             </a:extLst>
           </p:cNvPr>
@@ -36724,7 +36724,7 @@
             </a:pathLst>
           </a:custGeom>
           <a:blipFill xmlns:a="http://schemas.openxmlformats.org/drawingml/2006/main">
-            <a:blip xmlns:r="http://schemas.openxmlformats.org/officeDocument/2006/relationships" r:embed="R3d864407df184c72"/>
+            <a:blip xmlns:r="http://schemas.openxmlformats.org/officeDocument/2006/relationships" r:embed="Rb56a6fafb1ac45b8"/>
             <a:stretch>
               <a:fillRect l="0" t="0" r="0" b="0"/>
             </a:stretch>
@@ -36736,7 +36736,7 @@
           <p:cNvPr id="7" name="Freeform 7">
             <a:extLst xmlns:a="http://schemas.openxmlformats.org/drawingml/2006/main">
               <a:ext uri="{FF2B5EF4-FFF2-40B4-BE49-F238E27FC236}">
-                <a16:creationId xmlns:a16="http://schemas.microsoft.com/office/drawing/2014/main" id="{866AF0D6-E60E-4547-BF20-5E9538E8EB37}"/>
+                <a16:creationId xmlns:a16="http://schemas.microsoft.com/office/drawing/2014/main" id="{D331004C-845B-4F36-9336-D201C46A39DF}"/>
               </a:ext>
             </a:extLst>
           </p:cNvPr>
@@ -36774,10 +36774,10 @@
             </a:pathLst>
           </a:custGeom>
           <a:blipFill xmlns:a="http://schemas.openxmlformats.org/drawingml/2006/main">
-            <a:blip xmlns:r="http://schemas.openxmlformats.org/officeDocument/2006/relationships" r:embed="R9a634155974c49ef">
+            <a:blip xmlns:r="http://schemas.openxmlformats.org/officeDocument/2006/relationships" r:embed="Rc71ce6855213436f">
               <a:extLst>
                 <a:ext uri="{96DAC541-7B7A-43D3-8B79-37D633B846F1}">
-                  <asvg:svgBlip xmlns:asvg="http://schemas.microsoft.com/office/drawing/2016/SVG/main" r:embed="R857cf036bf894848"/>
+                  <asvg:svgBlip xmlns:asvg="http://schemas.microsoft.com/office/drawing/2016/SVG/main" r:embed="R207c0be9f82e4d56"/>
                 </a:ext>
               </a:extLst>
             </a:blip>
@@ -36792,7 +36792,7 @@
           <p:cNvPr id="8" name="Freeform 8">
             <a:extLst xmlns:a="http://schemas.openxmlformats.org/drawingml/2006/main">
               <a:ext uri="{FF2B5EF4-FFF2-40B4-BE49-F238E27FC236}">
-                <a16:creationId xmlns:a16="http://schemas.microsoft.com/office/drawing/2014/main" id="{3215C087-C1F2-44E8-A3A8-F6E8E7159D6E}"/>
+                <a16:creationId xmlns:a16="http://schemas.microsoft.com/office/drawing/2014/main" id="{19455DD3-676A-4510-924C-1F029652E72E}"/>
               </a:ext>
             </a:extLst>
           </p:cNvPr>
@@ -36830,10 +36830,10 @@
             </a:pathLst>
           </a:custGeom>
           <a:blipFill xmlns:a="http://schemas.openxmlformats.org/drawingml/2006/main">
-            <a:blip xmlns:r="http://schemas.openxmlformats.org/officeDocument/2006/relationships" r:embed="R9a634155974c49ef">
+            <a:blip xmlns:r="http://schemas.openxmlformats.org/officeDocument/2006/relationships" r:embed="Rc71ce6855213436f">
               <a:extLst>
                 <a:ext uri="{96DAC541-7B7A-43D3-8B79-37D633B846F1}">
-                  <asvg:svgBlip xmlns:asvg="http://schemas.microsoft.com/office/drawing/2016/SVG/main" r:embed="R857cf036bf894848"/>
+                  <asvg:svgBlip xmlns:asvg="http://schemas.microsoft.com/office/drawing/2016/SVG/main" r:embed="R207c0be9f82e4d56"/>
                 </a:ext>
               </a:extLst>
             </a:blip>
@@ -36848,7 +36848,7 @@
           <p:cNvPr id="10" name="Freeform 10">
             <a:extLst xmlns:a="http://schemas.openxmlformats.org/drawingml/2006/main">
               <a:ext uri="{FF2B5EF4-FFF2-40B4-BE49-F238E27FC236}">
-                <a16:creationId xmlns:a16="http://schemas.microsoft.com/office/drawing/2014/main" id="{47ADDFD4-798A-42D8-A4F9-24CB8A988B4E}"/>
+                <a16:creationId xmlns:a16="http://schemas.microsoft.com/office/drawing/2014/main" id="{ECDE063D-F80C-47BB-A75C-6007080941F1}"/>
               </a:ext>
             </a:extLst>
           </p:cNvPr>
@@ -36907,7 +36907,7 @@
           <p:cNvPr id="11" name="TextBox 11">
             <a:extLst xmlns:a="http://schemas.openxmlformats.org/drawingml/2006/main">
               <a:ext uri="{FF2B5EF4-FFF2-40B4-BE49-F238E27FC236}">
-                <a16:creationId xmlns:a16="http://schemas.microsoft.com/office/drawing/2014/main" id="{2BC03FF9-0027-4AA2-AF1F-F9E4E94E58EE}"/>
+                <a16:creationId xmlns:a16="http://schemas.microsoft.com/office/drawing/2014/main" id="{87334B8A-5718-4AD9-8C27-664161493CBE}"/>
               </a:ext>
             </a:extLst>
           </p:cNvPr>
@@ -36947,7 +36947,7 @@
           <p:cNvPr id="12" name="Freeform 12">
             <a:extLst xmlns:a="http://schemas.openxmlformats.org/drawingml/2006/main">
               <a:ext uri="{FF2B5EF4-FFF2-40B4-BE49-F238E27FC236}">
-                <a16:creationId xmlns:a16="http://schemas.microsoft.com/office/drawing/2014/main" id="{C6801EF2-4827-4C51-BF07-780EEBC59BB8}"/>
+                <a16:creationId xmlns:a16="http://schemas.microsoft.com/office/drawing/2014/main" id="{1A513757-3B2B-40CA-A1CB-F0DD83349622}"/>
               </a:ext>
             </a:extLst>
           </p:cNvPr>
@@ -36995,7 +36995,7 @@
           <p:cNvPr id="13" name="TextBox 13">
             <a:extLst xmlns:a="http://schemas.openxmlformats.org/drawingml/2006/main">
               <a:ext uri="{FF2B5EF4-FFF2-40B4-BE49-F238E27FC236}">
-                <a16:creationId xmlns:a16="http://schemas.microsoft.com/office/drawing/2014/main" id="{9E7C1D47-9D76-4713-8406-E310BECA5C34}"/>
+                <a16:creationId xmlns:a16="http://schemas.microsoft.com/office/drawing/2014/main" id="{F74DA85D-3C7C-4149-B273-DF4FEF2B9976}"/>
               </a:ext>
             </a:extLst>
           </p:cNvPr>
@@ -37047,7 +37047,7 @@
           <p:cNvPr id="14" name="TextBox 14">
             <a:extLst xmlns:a="http://schemas.openxmlformats.org/drawingml/2006/main">
               <a:ext uri="{FF2B5EF4-FFF2-40B4-BE49-F238E27FC236}">
-                <a16:creationId xmlns:a16="http://schemas.microsoft.com/office/drawing/2014/main" id="{F6916723-18DA-4188-88AD-0CC7ACBD962A}"/>
+                <a16:creationId xmlns:a16="http://schemas.microsoft.com/office/drawing/2014/main" id="{7749389F-73AE-495D-B2DD-5637ACEBF694}"/>
               </a:ext>
             </a:extLst>
           </p:cNvPr>
@@ -37099,7 +37099,7 @@
           <p:cNvPr id="15" name="TextBox 15">
             <a:extLst xmlns:a="http://schemas.openxmlformats.org/drawingml/2006/main">
               <a:ext uri="{FF2B5EF4-FFF2-40B4-BE49-F238E27FC236}">
-                <a16:creationId xmlns:a16="http://schemas.microsoft.com/office/drawing/2014/main" id="{28577912-9902-462E-BC60-D4C1C409F993}"/>
+                <a16:creationId xmlns:a16="http://schemas.microsoft.com/office/drawing/2014/main" id="{1D65F3CE-3A72-4AEA-96E4-642FB2AE7F9B}"/>
               </a:ext>
             </a:extLst>
           </p:cNvPr>
@@ -37260,7 +37260,7 @@
           <p:cNvPr id="16" name="TextBox 16">
             <a:extLst xmlns:a="http://schemas.openxmlformats.org/drawingml/2006/main">
               <a:ext uri="{FF2B5EF4-FFF2-40B4-BE49-F238E27FC236}">
-                <a16:creationId xmlns:a16="http://schemas.microsoft.com/office/drawing/2014/main" id="{D0114DFC-003F-48B8-8DF5-0FBA13A77A7B}"/>
+                <a16:creationId xmlns:a16="http://schemas.microsoft.com/office/drawing/2014/main" id="{6494AE3F-DB18-4915-8E60-86D941F74AC5}"/>
               </a:ext>
             </a:extLst>
           </p:cNvPr>
@@ -37314,7 +37314,7 @@
           <p:cNvPr id="17" name="TextBox 17">
             <a:extLst xmlns:a="http://schemas.openxmlformats.org/drawingml/2006/main">
               <a:ext uri="{FF2B5EF4-FFF2-40B4-BE49-F238E27FC236}">
-                <a16:creationId xmlns:a16="http://schemas.microsoft.com/office/drawing/2014/main" id="{29084B8D-54DB-4DB4-92CF-87BA95DC86C1}"/>
+                <a16:creationId xmlns:a16="http://schemas.microsoft.com/office/drawing/2014/main" id="{8C4DAE6C-DD8A-44BF-B649-987B2153B974}"/>
               </a:ext>
             </a:extLst>
           </p:cNvPr>
@@ -37366,7 +37366,7 @@
           <p:cNvPr id="18" name="TextBox 18">
             <a:extLst xmlns:a="http://schemas.openxmlformats.org/drawingml/2006/main">
               <a:ext uri="{FF2B5EF4-FFF2-40B4-BE49-F238E27FC236}">
-                <a16:creationId xmlns:a16="http://schemas.microsoft.com/office/drawing/2014/main" id="{C988A1CF-2910-4E79-8034-1F6B67159F02}"/>
+                <a16:creationId xmlns:a16="http://schemas.microsoft.com/office/drawing/2014/main" id="{BA53E170-8D4C-4180-B72E-4816E5553D93}"/>
               </a:ext>
             </a:extLst>
           </p:cNvPr>
@@ -37418,7 +37418,7 @@
           <p:cNvPr id="20" name="Freeform 20">
             <a:extLst xmlns:a="http://schemas.openxmlformats.org/drawingml/2006/main">
               <a:ext uri="{FF2B5EF4-FFF2-40B4-BE49-F238E27FC236}">
-                <a16:creationId xmlns:a16="http://schemas.microsoft.com/office/drawing/2014/main" id="{9E100D11-5138-4D4E-8481-D00CCD46B5E3}"/>
+                <a16:creationId xmlns:a16="http://schemas.microsoft.com/office/drawing/2014/main" id="{3C175612-76B4-4DA1-A70C-7EA93F2749E6}"/>
               </a:ext>
             </a:extLst>
           </p:cNvPr>
@@ -37477,7 +37477,7 @@
           <p:cNvPr id="21" name="TextBox 21">
             <a:extLst xmlns:a="http://schemas.openxmlformats.org/drawingml/2006/main">
               <a:ext uri="{FF2B5EF4-FFF2-40B4-BE49-F238E27FC236}">
-                <a16:creationId xmlns:a16="http://schemas.microsoft.com/office/drawing/2014/main" id="{F82C7D64-C48E-4BA9-82D0-A08E6E63BD62}"/>
+                <a16:creationId xmlns:a16="http://schemas.microsoft.com/office/drawing/2014/main" id="{7398A68A-6B44-4A9A-ACD0-CD6EE771A4D8}"/>
               </a:ext>
             </a:extLst>
           </p:cNvPr>
@@ -37517,7 +37517,7 @@
           <p:cNvPr id="22" name="Freeform 22">
             <a:extLst xmlns:a="http://schemas.openxmlformats.org/drawingml/2006/main">
               <a:ext uri="{FF2B5EF4-FFF2-40B4-BE49-F238E27FC236}">
-                <a16:creationId xmlns:a16="http://schemas.microsoft.com/office/drawing/2014/main" id="{4D66FC4C-65E8-4048-A199-B690B187D4C4}"/>
+                <a16:creationId xmlns:a16="http://schemas.microsoft.com/office/drawing/2014/main" id="{8D2BF20E-56A6-4144-8711-7B2410C9C336}"/>
               </a:ext>
             </a:extLst>
           </p:cNvPr>
@@ -37565,7 +37565,7 @@
           <p:cNvPr id="23" name="TextBox 23">
             <a:extLst xmlns:a="http://schemas.openxmlformats.org/drawingml/2006/main">
               <a:ext uri="{FF2B5EF4-FFF2-40B4-BE49-F238E27FC236}">
-                <a16:creationId xmlns:a16="http://schemas.microsoft.com/office/drawing/2014/main" id="{723084BD-37B0-4755-AFC7-F1FC68C4DA45}"/>
+                <a16:creationId xmlns:a16="http://schemas.microsoft.com/office/drawing/2014/main" id="{EED12B3B-FB4C-4063-8AFC-9CAB0D4418BD}"/>
               </a:ext>
             </a:extLst>
           </p:cNvPr>
@@ -37617,7 +37617,7 @@
           <p:cNvPr id="24" name="TextBox 24">
             <a:extLst xmlns:a="http://schemas.openxmlformats.org/drawingml/2006/main">
               <a:ext uri="{FF2B5EF4-FFF2-40B4-BE49-F238E27FC236}">
-                <a16:creationId xmlns:a16="http://schemas.microsoft.com/office/drawing/2014/main" id="{7E34437A-3390-4FA4-97F1-26BEE2FC738F}"/>
+                <a16:creationId xmlns:a16="http://schemas.microsoft.com/office/drawing/2014/main" id="{76F8E23B-003C-4B28-9068-5D78B8D7F960}"/>
               </a:ext>
             </a:extLst>
           </p:cNvPr>
@@ -37669,7 +37669,7 @@
           <p:cNvPr id="25" name="Freeform 25">
             <a:extLst xmlns:a="http://schemas.openxmlformats.org/drawingml/2006/main">
               <a:ext uri="{FF2B5EF4-FFF2-40B4-BE49-F238E27FC236}">
-                <a16:creationId xmlns:a16="http://schemas.microsoft.com/office/drawing/2014/main" id="{C8CCB0F5-D8EE-4B7E-A1E4-CF63CB24D1F8}"/>
+                <a16:creationId xmlns:a16="http://schemas.microsoft.com/office/drawing/2014/main" id="{E226617A-E614-41E2-BE13-43B1C7B051CE}"/>
               </a:ext>
             </a:extLst>
           </p:cNvPr>
@@ -37717,7 +37717,7 @@
           <p:cNvPr id="26" name="Freeform 26">
             <a:extLst xmlns:a="http://schemas.openxmlformats.org/drawingml/2006/main">
               <a:ext uri="{FF2B5EF4-FFF2-40B4-BE49-F238E27FC236}">
-                <a16:creationId xmlns:a16="http://schemas.microsoft.com/office/drawing/2014/main" id="{6C304718-B852-4FB8-B077-1DDD81569A1B}"/>
+                <a16:creationId xmlns:a16="http://schemas.microsoft.com/office/drawing/2014/main" id="{1273C16E-D9B4-4989-B0C4-E868E9D8E2D3}"/>
               </a:ext>
             </a:extLst>
           </p:cNvPr>
@@ -37765,7 +37765,7 @@
           <p:cNvPr id="27" name="內容_9_檢查V7–V11：物理與排隊">
             <a:extLst xmlns:a="http://schemas.openxmlformats.org/drawingml/2006/main">
               <a:ext uri="{FF2B5EF4-FFF2-40B4-BE49-F238E27FC236}">
-                <a16:creationId xmlns:a16="http://schemas.microsoft.com/office/drawing/2014/main" id="{DD4AFBEA-4F5E-4FDC-A78B-FC5507C28516}"/>
+                <a16:creationId xmlns:a16="http://schemas.microsoft.com/office/drawing/2014/main" id="{51DE7E38-52BD-43A6-A37D-CC82041E6644}"/>
               </a:ext>
             </a:extLst>
           </p:cNvPr>
@@ -37923,7 +37923,7 @@
           <p:cNvPr id="28" name="內容_9_將模型對回物理與排隊">
             <a:extLst xmlns:a="http://schemas.openxmlformats.org/drawingml/2006/main">
               <a:ext uri="{FF2B5EF4-FFF2-40B4-BE49-F238E27FC236}">
-                <a16:creationId xmlns:a16="http://schemas.microsoft.com/office/drawing/2014/main" id="{22A2781B-4B68-42D8-9611-20F5865A1532}"/>
+                <a16:creationId xmlns:a16="http://schemas.microsoft.com/office/drawing/2014/main" id="{18422F5E-4934-4025-97DE-E5894ABE3FD4}"/>
               </a:ext>
             </a:extLst>
           </p:cNvPr>
@@ -38081,7 +38081,7 @@
           <p:cNvPr id="29" name="">
             <a:extLst xmlns:a="http://schemas.openxmlformats.org/drawingml/2006/main">
               <a:ext uri="{FF2B5EF4-FFF2-40B4-BE49-F238E27FC236}">
-                <a16:creationId xmlns:a16="http://schemas.microsoft.com/office/drawing/2014/main" id="{AD31A027-BB66-4FB3-8150-341D1474A357}"/>
+                <a16:creationId xmlns:a16="http://schemas.microsoft.com/office/drawing/2014/main" id="{4D03F7AA-BFB2-4903-85CD-78C92720A3B3}"/>
               </a:ext>
             </a:extLst>
           </p:cNvPr>
@@ -38250,7 +38250,7 @@
                           <a:ea typeface="Microsoft JhengHei"/>
                           <a:cs typeface="Microsoft JhengHei"/>
                         </a:rPr>
-                        <a:t>V7 清洗產能</a:t>
+                        <a:t>清洗產能檢查（V7）</a:t>
                       </a:r>
                     </a:p>
                   </a:txBody>
@@ -38366,7 +38366,7 @@
                           <a:ea typeface="Microsoft JhengHei"/>
                           <a:cs typeface="Microsoft JhengHei"/>
                         </a:rPr>
-                        <a:t>V8 停機占比</a:t>
+                        <a:t>停機占比檢查（V8）</a:t>
                       </a:r>
                     </a:p>
                   </a:txBody>
@@ -38408,7 +38408,7 @@
                           <a:ea typeface="Microsoft JhengHei"/>
                           <a:cs typeface="Microsoft JhengHei"/>
                         </a:rPr>
-                        <a:t>S0均值3.80%；理論4%</a:t>
+                        <a:t>平日基準情境（S0）均值3.80%；理論4%</a:t>
                       </a:r>
                     </a:p>
                   </a:txBody>
@@ -38482,7 +38482,7 @@
                           <a:ea typeface="Microsoft JhengHei"/>
                           <a:cs typeface="Microsoft JhengHei"/>
                         </a:rPr>
-                        <a:t>V9 利特爾定律</a:t>
+                        <a:t>利特爾定律檢查（V9）</a:t>
                       </a:r>
                     </a:p>
                   </a:txBody>
@@ -38598,7 +38598,7 @@
                           <a:ea typeface="Microsoft JhengHei"/>
                           <a:cs typeface="Microsoft JhengHei"/>
                         </a:rPr>
-                        <a:t>V10 五倍壓力</a:t>
+                        <a:t>五倍壓力檢查（V10）</a:t>
                       </a:r>
                     </a:p>
                   </a:txBody>
@@ -38714,7 +38714,7 @@
                           <a:ea typeface="Microsoft JhengHei"/>
                           <a:cs typeface="Microsoft JhengHei"/>
                         </a:rPr>
-                        <a:t>V11 無長時停滯</a:t>
+                        <a:t>無長時停滯檢查（V11）</a:t>
                       </a:r>
                     </a:p>
                   </a:txBody>
@@ -38824,7 +38824,7 @@
           <p:cNvPr id="30" name="內容_9_負載比例＝到達率÷處理能力；">
             <a:extLst xmlns:a="http://schemas.openxmlformats.org/drawingml/2006/main">
               <a:ext uri="{FF2B5EF4-FFF2-40B4-BE49-F238E27FC236}">
-                <a16:creationId xmlns:a16="http://schemas.microsoft.com/office/drawing/2014/main" id="{FC8C63BC-333A-4C50-9BE1-DA3201A6FB87}"/>
+                <a16:creationId xmlns:a16="http://schemas.microsoft.com/office/drawing/2014/main" id="{E2F09C10-1542-4DF4-A85B-FA783791A3C9}"/>
               </a:ext>
             </a:extLst>
           </p:cNvPr>
@@ -38982,7 +38982,7 @@
           <p:cNvPr id="31" name="內容_9_1920次不重複原生運行；1">
             <a:extLst xmlns:a="http://schemas.openxmlformats.org/drawingml/2006/main">
               <a:ext uri="{FF2B5EF4-FFF2-40B4-BE49-F238E27FC236}">
-                <a16:creationId xmlns:a16="http://schemas.microsoft.com/office/drawing/2014/main" id="{5454E7FF-B754-4DA6-979E-61D07E1BAB58}"/>
+                <a16:creationId xmlns:a16="http://schemas.microsoft.com/office/drawing/2014/main" id="{485505A5-367B-413B-8F70-BCFBE90A4C60}"/>
               </a:ext>
             </a:extLst>
           </p:cNvPr>
@@ -39138,7 +39138,7 @@
     </p:spTree>
     <p:extLst>
       <p:ext uri="{BB962C8B-B14F-4D97-AF65-F5344CB8AC3E}">
-        <p14:creationId xmlns:p14="http://schemas.microsoft.com/office/powerpoint/2010/main" val="1375023001"/>
+        <p14:creationId xmlns:p14="http://schemas.microsoft.com/office/powerpoint/2010/main" val="1418929552"/>
       </p:ext>
     </p:extLst>
   </p:cSld>

</xml_diff>